<commit_message>
Talk: add official HPRC logo to title and closing slides
</commit_message>
<xml_diff>
--- a/talk/HPRC2026_talk.pptx
+++ b/talk/HPRC2026_talk.pptx
@@ -3898,6 +3898,30 @@
           </a:p>
         </p:txBody>
       </p:sp>
+      <p:pic>
+        <p:nvPicPr>
+          <p:cNvPr id="9" name="Image 1" descr="/Users/seeskand/Documents/HPRC/2026/hprc_2026_poster/talk/figures/hprc_logo.png">    </p:cNvPr>
+          <p:cNvPicPr>
+            <a:picLocks noChangeAspect="1"/>
+          </p:cNvPicPr>
+          <p:nvPr/>
+        </p:nvPicPr>
+        <p:blipFill>
+          <a:blip r:embed="rId2"/>
+          <a:stretch>
+            <a:fillRect/>
+          </a:stretch>
+        </p:blipFill>
+        <p:spPr>
+          <a:xfrm>
+            <a:off x="10271455" y="5216393"/>
+            <a:ext cx="1371600" cy="1138687"/>
+          </a:xfrm>
+          <a:prstGeom prst="rect">
+            <a:avLst/>
+          </a:prstGeom>
+        </p:spPr>
+      </p:pic>
     </p:spTree>
   </p:cSld>
   <p:clrMapOvr>
@@ -7622,6 +7646,30 @@
           </a:p>
         </p:txBody>
       </p:sp>
+      <p:pic>
+        <p:nvPicPr>
+          <p:cNvPr id="7" name="Image 1" descr="/Users/seeskand/Documents/HPRC/2026/hprc_2026_poster/talk/figures/hprc_logo.png">    </p:cNvPr>
+          <p:cNvPicPr>
+            <a:picLocks noChangeAspect="1"/>
+          </p:cNvPicPr>
+          <p:nvPr/>
+        </p:nvPicPr>
+        <p:blipFill>
+          <a:blip r:embed="rId2"/>
+          <a:stretch>
+            <a:fillRect/>
+          </a:stretch>
+        </p:blipFill>
+        <p:spPr>
+          <a:xfrm>
+            <a:off x="10271455" y="5216393"/>
+            <a:ext cx="1371600" cy="1138687"/>
+          </a:xfrm>
+          <a:prstGeom prst="rect">
+            <a:avLst/>
+          </a:prstGeom>
+        </p:spPr>
+      </p:pic>
     </p:spTree>
   </p:cSld>
   <p:clrMapOvr>

</xml_diff>

<commit_message>
Lab deck: screenshot-first slides; drop bulk chain generator from talk, script, and lab deck
</commit_message>
<xml_diff>
--- a/talk/HPRC2026_talk.pptx
+++ b/talk/HPRC2026_talk.pptx
@@ -1984,9 +1984,10 @@
               <a:t>[12:00-13:30]
 Now, honestly, what's not finished, and what's planned.
 Today, chains are built per view. Pan far enough and we build another one. Wide, segmental-duplication-heavy regions lose positions; on the 1q21.1 region we recover about half.
-The plan. First, precomputed whole-genome chains: because we know both endpoints, we can intersect the two haplotype paths directly instead of probing the index, and that's roughly three hundred times faster: hours for every assembly pair, not weeks. That also removes the segdup problem, and it means lifted tracks pan and zoom anywhere for free.
-Second, this is on the development browser today; the goal is the public UCSC Genome Browser.
-Third: more graphs. Nothing here is specific to release 2. New HPRC releases plug in by building one index.</a:t>
+The plan. First and foremost: this is on the development browser today; the goal is the public UCSC Genome Browser.
+Second, chains that cover more and persist: today a widened chain dies with the session; sharing it across users makes popular regions free after the first visit.
+Third, better recovery in wide, segdup-dense regions.
+And more graphs. Nothing here is specific to release 2. New HPRC releases plug in by building one index.</a:t>
             </a:r>
             <a:endParaRPr lang="en-US" dirty="0"/>
           </a:p>
@@ -2430,7 +2431,7 @@
           <a:p>
             <a:r>
               <a:rPr lang="en-US" dirty="0"/>
-              <a:t>Backup: how on-demand chains still let users pan and zoom, and why precomputed whole-genome chains are the long-term answer.</a:t>
+              <a:t>Backup: how on-demand chains still let users pan and zoom.</a:t>
             </a:r>
             <a:endParaRPr lang="en-US" dirty="0"/>
           </a:p>
@@ -6772,7 +6773,7 @@
                 <a:ea typeface="Calibri" pitchFamily="34" charset="-122"/>
                 <a:cs typeface="Calibri" pitchFamily="34" charset="-120"/>
               </a:rPr>
-              <a:t>Precomputed whole-genome chains by direct path intersection: about 300× faster, hours for all 466 assemblies. Lifted tracks then pan and zoom anywhere for free.</a:t>
+              <a:t>Public release in the UCSC Genome Browser.</a:t>
             </a:r>
             <a:endParaRPr lang="en-US" sz="1600" dirty="0"/>
           </a:p>
@@ -6793,7 +6794,7 @@
                 <a:ea typeface="Calibri" pitchFamily="34" charset="-122"/>
                 <a:cs typeface="Calibri" pitchFamily="34" charset="-120"/>
               </a:rPr>
-              <a:t>The same exact intersection fixes wide segdup regions.</a:t>
+              <a:t>Chains that cover more, and persist: widened chains shared across users instead of dying with the session.</a:t>
             </a:r>
             <a:endParaRPr lang="en-US" sz="1600" dirty="0"/>
           </a:p>
@@ -6814,7 +6815,7 @@
                 <a:ea typeface="Calibri" pitchFamily="34" charset="-122"/>
                 <a:cs typeface="Calibri" pitchFamily="34" charset="-120"/>
               </a:rPr>
-              <a:t>Public release in the UCSC Genome Browser.</a:t>
+              <a:t>Better recovery in wide, segdup-dense regions.</a:t>
             </a:r>
             <a:endParaRPr lang="en-US" sz="1600" dirty="0"/>
           </a:p>

</xml_diff>

<commit_message>
Talk: frame demos as two user stories (a sequence in hand; a gene on a reference)
</commit_message>
<xml_diff>
--- a/talk/HPRC2026_talk.pptx
+++ b/talk/HPRC2026_talk.pptx
@@ -1337,8 +1337,8 @@
             <a:r>
               <a:rPr lang="en-US" dirty="0"/>
               <a:t>[7:25-8:15]
-Question two starts from coordinates instead of a sequence. Convert Coordinates Between Assemblies. Source: CHM13, a ten-kilobase region on chromosome 6. Target: any of the other 463 haplotypes; the picker can show only the ones that actually contain the region.
-Result: HG02015 paternal, contig CM085893, a hundred percent of bases, a hundred percent of span, in about a hundred milliseconds. And GRCh38 is a path in this graph too, so hg38 works as the source.</a:t>
+The second user starts from coordinates, not a sequence. He knows his gene on a reference. Here the source is CHM13 and the gene is HLA-DMA, a ten-kilobase region on chromosome 6; GRCh38 is a path in this graph too, so hg38 works exactly the same way. Target: any of the other 463 haplotypes, and the picker can show only the ones that actually contain the region.
+He picks HG02015 paternal, a haplotype he has never looked at. Result: contig CM085893, a hundred percent of bases, a hundred percent of span, in about a hundred milliseconds.</a:t>
             </a:r>
             <a:endParaRPr lang="en-US" dirty="0"/>
           </a:p>
@@ -1517,11 +1517,11 @@
             <a:r>
               <a:rPr lang="en-US" dirty="0"/>
               <a:t>[8:40-10:20]  SLOW DOWN. This is the slide the talk exists for.
-But a coordinate on its own is a lonely thing. Question three, and this is the one I care about most.
-This is HG02015 paternal. Release 2 gave it CAT and Liftoff genes, and per-assembly annotation is the right answer where it exists. What HG02015 does not have, and never will, is everything else: ClinVar, the GWAS catalog, ENCODE, your lab's BED file. Those live once, on one reference.
+But a coordinate on its own is a lonely thing. He clicks the result, and this is the part I care about most.
+This is HG02015 paternal, at his gene. Release 2 gave it CAT and Liftoff genes, and per-assembly annotation is the right answer where it exists. What HG02015 does not have, and never will, is everything else: ClinVar, the GWAS catalog, ENCODE, your lab's BED file. Those live once, on one reference.
 And here they are: CHM13's tracks, drawn at their translated positions, under an Alignment Differences track marking every insertion, deletion and mismatch between the two assemblies.
 (pause) The chain that made this possible did not exist a second before the page loaded. The translation blocks became a bigChain, the browser's own QuickLift drew the tracks, and the chain is reused for every pan.
-That's what I mean by making release 2 useful. The thousands of tracks that exist once, on one reference, will never be rebuilt 464 times. Any of these assemblies can borrow them, on demand, for the region you're actually looking at.</a:t>
+That's the second user done: a gene he knew on a reference, on a haplotype nobody annotated for him, with the reference's annotation around it. And that's what I mean by making release 2 useful. The thousands of tracks that exist once, on one reference, will never be rebuilt 464 times. Any haplotype can borrow them, on demand, for the region you're actually looking at.</a:t>
             </a:r>
             <a:endParaRPr lang="en-US" dirty="0"/>
           </a:p>
@@ -1884,8 +1884,8 @@
             <a:r>
               <a:rPr lang="en-US" dirty="0"/>
               <a:t>[13:05-13:45]
-So, back to the three questions I promised.
-Which haplotypes carry my sequence? Yes. Where is my region on HG02015? Yes. Can I see the genes when I get there? Yes: the reference's tracks, over a chain built on the spot.
+So, back to the two users I promised.
+The one with a sequence: every haplotype that carries it, ranked, and mapped as a track on the one she chose. The one with a gene on a reference: the same gene on HG02015 in a tenth of a second, with the reference's annotation drawn around it, over a chain built on the spot.
 It's live on the development browser today. So bring me your hardest region, and tell me where it breaks.
 (Advance to the thanks slide, let it breathe, then take questions.)</a:t>
             </a:r>
@@ -2601,11 +2601,10 @@
             <a:r>
               <a:rPr lang="en-US" dirty="0"/>
               <a:t>[1:50-2:30]
-Strip this down to what a browser user actually types.
-One: I have a sequence. Which haplotypes carry it, and where?
-Two: I have a region on CHM13. Where is it on HG02015?
-Three: when I get there, can I see the genes?
-Everyone in this room can answer all three with enough shell. Nobody can answer any of them from the browser, in seconds, for an arbitrary pair. By the end of this talk: all three, live.</a:t>
+So let me follow two users through the browser.
+The first has a sequence in hand: a probe, a contig, a variant's flanks. Which haplotypes in the graph carry it, and where on each? And then: map it, and look at it.
+The second has a gene, and knows it on a reference: GRCh38, or CHM13. Where is that gene on HG02015? And when they get there, can they see its annotation?
+Everyone in this room can serve both users with enough shell. Nobody can do it from the browser, in seconds, for an arbitrary haplotype. By the end of this talk: both, live.</a:t>
             </a:r>
             <a:endParaRPr lang="en-US" dirty="0"/>
           </a:p>
@@ -2970,8 +2969,8 @@
             <a:r>
               <a:rPr lang="en-US" dirty="0"/>
               <a:t>[5:55-6:55]
-That's the whole method. Now the three questions, starting with the first.
-This is the Pangenome Mapping page: BLAT, but for the pangenome. You paste a sequence. It is mapped once, to the whole graph, with vg giraffe. You get back every assembly consistent with it, ranked by identity, and a position on whichever haplotype you pick. Picking a different haplotype re-surjects the same alignment; nothing is remapped.
+That's the whole method. Now the two users, starting with the one holding a sequence.
+This is the Pangenome Mapping page: BLAT, but for the pangenome. She pastes her sequence, a kilobase here. It is mapped once, to the whole graph, with vg giraffe. She gets back every haplotype that carries it, ranked by identity: here two, HG01167 hap1 and HG04157 paternal. And a position on whichever one she picks. Picking a different haplotype re-surjects the same alignment; nothing is remapped.
 You'll notice MAPQ zero. That's not a bad alignment; that's what MAPQ means in a graph where every locus exists hundreds of times. We report identity and coverage per haplotype instead.</a:t>
             </a:r>
             <a:endParaRPr lang="en-US" dirty="0"/>
@@ -3061,7 +3060,7 @@
             <a:r>
               <a:rPr lang="en-US" dirty="0"/>
               <a:t>[6:55-7:25]
-Click through to a haplotype, here HG01167 hap1, and you don't land on a special page. You land in the browser, with the sequence as a native track and base-level differences colored the way BLAT users already know. Nothing here is a special case.</a:t>
+She clicks through to a haplotype, here HG01167 hap1, and doesn't land on a special page. She lands in the browser, on that haplotype, with her sequence as a native track and base-level differences colored the way BLAT users already know. That's the first user done: which haplotypes, where, and mapped.</a:t>
             </a:r>
             <a:endParaRPr lang="en-US" dirty="0"/>
           </a:p>
@@ -3862,7 +3861,7 @@
                 <a:ea typeface="Calibri" pitchFamily="34" charset="-122"/>
                 <a:cs typeface="Calibri" pitchFamily="34" charset="-120"/>
               </a:rPr>
-              <a:t>Any region, any of 464 haplotypes, in about 100 ms</a:t>
+              <a:t>Story 2: a reference gene on any haplotype, ~100 ms</a:t>
             </a:r>
             <a:endParaRPr lang="en-US" sz="3200" dirty="0"/>
           </a:p>
@@ -3940,7 +3939,7 @@
                 <a:ea typeface="Calibri" pitchFamily="34" charset="-122"/>
                 <a:cs typeface="Calibri" pitchFamily="34" charset="-120"/>
               </a:rPr>
-              <a:t>Question 2</a:t>
+              <a:t>Story 2</a:t>
             </a:r>
             <a:endParaRPr lang="en-US" sz="1600" dirty="0"/>
           </a:p>
@@ -4462,7 +4461,7 @@
                 <a:ea typeface="Calibri" pitchFamily="34" charset="-122"/>
                 <a:cs typeface="Calibri" pitchFamily="34" charset="-120"/>
               </a:rPr>
-              <a:t>No new habits: it lives inside hgConvert too</a:t>
+              <a:t>...or from the hgConvert page he already uses</a:t>
             </a:r>
             <a:endParaRPr lang="en-US" sz="3200" dirty="0"/>
           </a:p>
@@ -4509,7 +4508,46 @@
       </p:sp>
       <p:sp>
         <p:nvSpPr>
-          <p:cNvPr id="4" name="Shape 2"/>
+          <p:cNvPr id="4" name="Text 2"/>
+          <p:cNvSpPr txBox="1"/>
+          <p:nvPr/>
+        </p:nvSpPr>
+        <p:spPr>
+          <a:xfrm>
+            <a:off x="9631375" y="384048"/>
+            <a:ext cx="2011680" cy="713232"/>
+          </a:xfrm>
+          <a:prstGeom prst="rect">
+            <a:avLst/>
+          </a:prstGeom>
+          <a:noFill/>
+          <a:ln/>
+        </p:spPr>
+        <p:txBody>
+          <a:bodyPr wrap="square" lIns="0" tIns="0" rIns="0" bIns="0" rtlCol="0" anchor="ctr"/>
+          <a:lstStyle/>
+          <a:p>
+            <a:pPr algn="r" indent="0" marL="0">
+              <a:buNone/>
+            </a:pPr>
+            <a:r>
+              <a:rPr lang="en-US" sz="1600" b="1" dirty="0">
+                <a:solidFill>
+                  <a:srgbClr val="003C6C"/>
+                </a:solidFill>
+                <a:latin typeface="Calibri" pitchFamily="34" charset="0"/>
+                <a:ea typeface="Calibri" pitchFamily="34" charset="-122"/>
+                <a:cs typeface="Calibri" pitchFamily="34" charset="-120"/>
+              </a:rPr>
+              <a:t>Story 2</a:t>
+            </a:r>
+            <a:endParaRPr lang="en-US" sz="1600" dirty="0"/>
+          </a:p>
+        </p:txBody>
+      </p:sp>
+      <p:sp>
+        <p:nvSpPr>
+          <p:cNvPr id="5" name="Shape 3"/>
           <p:cNvSpPr/>
           <p:nvPr/>
         </p:nvSpPr>
@@ -4536,7 +4574,7 @@
       </p:sp>
       <p:sp>
         <p:nvSpPr>
-          <p:cNvPr id="5" name="Shape 3"/>
+          <p:cNvPr id="6" name="Shape 4"/>
           <p:cNvSpPr/>
           <p:nvPr/>
         </p:nvSpPr>
@@ -4561,7 +4599,7 @@
       </p:sp>
       <p:sp>
         <p:nvSpPr>
-          <p:cNvPr id="6" name="Shape 4"/>
+          <p:cNvPr id="7" name="Shape 5"/>
           <p:cNvSpPr/>
           <p:nvPr/>
         </p:nvSpPr>
@@ -4586,7 +4624,7 @@
       </p:sp>
       <p:sp>
         <p:nvSpPr>
-          <p:cNvPr id="7" name="Shape 5"/>
+          <p:cNvPr id="8" name="Shape 6"/>
           <p:cNvSpPr/>
           <p:nvPr/>
         </p:nvSpPr>
@@ -4611,7 +4649,7 @@
       </p:sp>
       <p:sp>
         <p:nvSpPr>
-          <p:cNvPr id="8" name="Text 6"/>
+          <p:cNvPr id="9" name="Text 7"/>
           <p:cNvSpPr txBox="1"/>
           <p:nvPr/>
         </p:nvSpPr>
@@ -4650,7 +4688,7 @@
       </p:sp>
       <p:pic>
         <p:nvPicPr>
-          <p:cNvPr id="9" name="Image 0" descr="/Users/seeskand/Documents/HPRC/2026/hprc_2026_poster/talk/figures/crop_dropdown.png">    </p:cNvPr>
+          <p:cNvPr id="10" name="Image 0" descr="/Users/seeskand/Documents/HPRC/2026/hprc_2026_poster/talk/figures/crop_dropdown.png">    </p:cNvPr>
           <p:cNvPicPr>
             <a:picLocks noChangeAspect="1"/>
           </p:cNvPicPr>
@@ -4674,7 +4712,7 @@
       </p:pic>
       <p:sp>
         <p:nvSpPr>
-          <p:cNvPr id="10" name="Text 7"/>
+          <p:cNvPr id="11" name="Text 8"/>
           <p:cNvSpPr txBox="1"/>
           <p:nvPr/>
         </p:nvSpPr>
@@ -4713,7 +4751,7 @@
       </p:sp>
       <p:sp>
         <p:nvSpPr>
-          <p:cNvPr id="11" name="Text 8"/>
+          <p:cNvPr id="12" name="Text 9"/>
           <p:cNvSpPr txBox="1"/>
           <p:nvPr/>
         </p:nvSpPr>
@@ -4752,7 +4790,7 @@
       </p:sp>
       <p:sp>
         <p:nvSpPr>
-          <p:cNvPr id="12" name="Shape 9"/>
+          <p:cNvPr id="13" name="Shape 10"/>
           <p:cNvSpPr/>
           <p:nvPr/>
         </p:nvSpPr>
@@ -4779,7 +4817,7 @@
       </p:sp>
       <p:sp>
         <p:nvSpPr>
-          <p:cNvPr id="13" name="Text 10"/>
+          <p:cNvPr id="14" name="Text 11"/>
           <p:cNvSpPr txBox="1"/>
           <p:nvPr/>
         </p:nvSpPr>
@@ -4881,7 +4919,7 @@
                 <a:ea typeface="Calibri" pitchFamily="34" charset="-122"/>
                 <a:cs typeface="Calibri" pitchFamily="34" charset="-120"/>
               </a:rPr>
-              <a:t>Arrive with the annotations you left behind</a:t>
+              <a:t>...and arrive with the reference's annotations</a:t>
             </a:r>
             <a:endParaRPr lang="en-US" sz="3200" dirty="0"/>
           </a:p>
@@ -4959,7 +4997,7 @@
                 <a:ea typeface="Calibri" pitchFamily="34" charset="-122"/>
                 <a:cs typeface="Calibri" pitchFamily="34" charset="-120"/>
               </a:rPr>
-              <a:t>Question 3</a:t>
+              <a:t>Story 2</a:t>
             </a:r>
             <a:endParaRPr lang="en-US" sz="1600" dirty="0"/>
           </a:p>
@@ -7390,7 +7428,7 @@
                 <a:ea typeface="Calibri" pitchFamily="34" charset="-122"/>
                 <a:cs typeface="Calibri" pitchFamily="34" charset="-120"/>
               </a:rPr>
-              <a:t>All three: yes</a:t>
+              <a:t>Both users, served</a:t>
             </a:r>
             <a:endParaRPr lang="en-US" sz="3200" dirty="0"/>
           </a:p>
@@ -7405,11 +7443,11 @@
         <p:spPr>
           <a:xfrm>
             <a:off x="548640" y="1325880"/>
-            <a:ext cx="3454298" cy="4114800"/>
+            <a:ext cx="5364328" cy="4114800"/>
           </a:xfrm>
           <a:prstGeom prst="roundRect">
             <a:avLst>
-              <a:gd name="adj" fmla="val 3177"/>
+              <a:gd name="adj" fmla="val 2667"/>
             </a:avLst>
           </a:prstGeom>
           <a:solidFill>
@@ -7480,8 +7518,8 @@
         </p:nvSpPr>
         <p:spPr>
           <a:xfrm>
-            <a:off x="868680" y="2697480"/>
-            <a:ext cx="2814218" cy="457200"/>
+            <a:off x="1828800" y="1709928"/>
+            <a:ext cx="3718408" cy="320040"/>
           </a:xfrm>
           <a:prstGeom prst="rect">
             <a:avLst/>
@@ -7497,7 +7535,46 @@
               <a:buNone/>
             </a:pPr>
             <a:r>
-              <a:rPr lang="en-US" sz="2000" b="1" dirty="0">
+              <a:rPr lang="en-US" sz="1400" b="1" spc="200" kern="0" dirty="0">
+                <a:solidFill>
+                  <a:srgbClr val="C6D3DF"/>
+                </a:solidFill>
+                <a:latin typeface="Calibri" pitchFamily="34" charset="0"/>
+                <a:ea typeface="Calibri" pitchFamily="34" charset="-122"/>
+                <a:cs typeface="Calibri" pitchFamily="34" charset="-120"/>
+              </a:rPr>
+              <a:t>Story 1</a:t>
+            </a:r>
+            <a:endParaRPr lang="en-US" sz="1400" dirty="0"/>
+          </a:p>
+        </p:txBody>
+      </p:sp>
+      <p:sp>
+        <p:nvSpPr>
+          <p:cNvPr id="8" name="Text 5"/>
+          <p:cNvSpPr txBox="1"/>
+          <p:nvPr/>
+        </p:nvSpPr>
+        <p:spPr>
+          <a:xfrm>
+            <a:off x="1828800" y="2011680"/>
+            <a:ext cx="3718408" cy="457200"/>
+          </a:xfrm>
+          <a:prstGeom prst="rect">
+            <a:avLst/>
+          </a:prstGeom>
+          <a:noFill/>
+          <a:ln/>
+        </p:spPr>
+        <p:txBody>
+          <a:bodyPr wrap="square" lIns="0" tIns="0" rIns="0" bIns="0" rtlCol="0" anchor="t"/>
+          <a:lstStyle/>
+          <a:p>
+            <a:pPr indent="0" marL="0">
+              <a:buNone/>
+            </a:pPr>
+            <a:r>
+              <a:rPr lang="en-US" sz="2200" b="1" dirty="0">
                 <a:solidFill>
                   <a:srgbClr val="FFFFFF"/>
                 </a:solidFill>
@@ -7505,22 +7582,22 @@
                 <a:ea typeface="Calibri" pitchFamily="34" charset="-122"/>
                 <a:cs typeface="Calibri" pitchFamily="34" charset="-120"/>
               </a:rPr>
-              <a:t>I have a sequence.</a:t>
+              <a:t>A sequence in hand</a:t>
             </a:r>
-            <a:endParaRPr lang="en-US" sz="2000" dirty="0"/>
+            <a:endParaRPr lang="en-US" sz="2200" dirty="0"/>
           </a:p>
         </p:txBody>
       </p:sp>
       <p:sp>
         <p:nvSpPr>
-          <p:cNvPr id="8" name="Text 5"/>
+          <p:cNvPr id="9" name="Text 6"/>
           <p:cNvSpPr txBox="1"/>
           <p:nvPr/>
         </p:nvSpPr>
         <p:spPr>
           <a:xfrm>
-            <a:off x="868680" y="3200400"/>
-            <a:ext cx="2814218" cy="914400"/>
+            <a:off x="868680" y="2788920"/>
+            <a:ext cx="4724248" cy="1280160"/>
           </a:xfrm>
           <a:prstGeom prst="rect">
             <a:avLst/>
@@ -7536,7 +7613,7 @@
               <a:buNone/>
             </a:pPr>
             <a:r>
-              <a:rPr lang="en-US" sz="2000" dirty="0">
+              <a:rPr lang="en-US" sz="1900" dirty="0">
                 <a:solidFill>
                   <a:srgbClr val="C6D3DF"/>
                 </a:solidFill>
@@ -7544,22 +7621,22 @@
                 <a:ea typeface="Calibri" pitchFamily="34" charset="-122"/>
                 <a:cs typeface="Calibri" pitchFamily="34" charset="-120"/>
               </a:rPr>
-              <a:t>Which haplotypes carry it, and where?</a:t>
+              <a:t>Which haplotypes carry this sequence, and where on each? Then map it, and look at it.</a:t>
             </a:r>
-            <a:endParaRPr lang="en-US" sz="2000" dirty="0"/>
+            <a:endParaRPr lang="en-US" sz="1900" dirty="0"/>
           </a:p>
         </p:txBody>
       </p:sp>
       <p:sp>
         <p:nvSpPr>
-          <p:cNvPr id="9" name="Text 6"/>
+          <p:cNvPr id="10" name="Text 7"/>
           <p:cNvSpPr txBox="1"/>
           <p:nvPr/>
         </p:nvSpPr>
         <p:spPr>
           <a:xfrm>
-            <a:off x="868680" y="4251960"/>
-            <a:ext cx="2814218" cy="320040"/>
+            <a:off x="868680" y="4160520"/>
+            <a:ext cx="4724248" cy="457200"/>
           </a:xfrm>
           <a:prstGeom prst="rect">
             <a:avLst/>
@@ -7575,7 +7652,7 @@
               <a:buNone/>
             </a:pPr>
             <a:r>
-              <a:rPr lang="en-US" sz="1400" dirty="0">
+              <a:rPr lang="en-US" sz="1500" dirty="0">
                 <a:solidFill>
                   <a:srgbClr val="C6D3DF"/>
                 </a:solidFill>
@@ -7583,22 +7660,22 @@
                 <a:ea typeface="Calibri" pitchFamily="34" charset="-122"/>
                 <a:cs typeface="Calibri" pitchFamily="34" charset="-120"/>
               </a:rPr>
-              <a:t>in the browser, in seconds</a:t>
+              <a:t>every carrying haplotype, ranked; mapped as a track on the one she chose</a:t>
             </a:r>
-            <a:endParaRPr lang="en-US" sz="1400" dirty="0"/>
+            <a:endParaRPr lang="en-US" sz="1500" dirty="0"/>
           </a:p>
         </p:txBody>
       </p:sp>
       <p:sp>
         <p:nvSpPr>
-          <p:cNvPr id="10" name="Text 7"/>
+          <p:cNvPr id="11" name="Text 8"/>
           <p:cNvSpPr txBox="1"/>
           <p:nvPr/>
         </p:nvSpPr>
         <p:spPr>
           <a:xfrm>
             <a:off x="868680" y="4572000"/>
-            <a:ext cx="2814218" cy="640080"/>
+            <a:ext cx="4724248" cy="640080"/>
           </a:xfrm>
           <a:prstGeom prst="rect">
             <a:avLst/>
@@ -7622,7 +7699,7 @@
                 <a:ea typeface="Calibri" pitchFamily="34" charset="-122"/>
                 <a:cs typeface="Calibri" pitchFamily="34" charset="-120"/>
               </a:rPr>
-              <a:t>yes</a:t>
+              <a:t>done</a:t>
             </a:r>
             <a:endParaRPr lang="en-US" sz="4000" dirty="0"/>
           </a:p>
@@ -7630,18 +7707,18 @@
       </p:sp>
       <p:sp>
         <p:nvSpPr>
-          <p:cNvPr id="11" name="Shape 8"/>
-          <p:cNvSpPr/>
-          <p:nvPr/>
-        </p:nvSpPr>
-        <p:spPr>
-          <a:xfrm>
-            <a:off x="4368698" y="1325880"/>
-            <a:ext cx="3454298" cy="4114800"/>
+          <p:cNvPr id="12" name="Shape 9"/>
+          <p:cNvSpPr/>
+          <p:nvPr/>
+        </p:nvSpPr>
+        <p:spPr>
+          <a:xfrm>
+            <a:off x="6278728" y="1325880"/>
+            <a:ext cx="5364328" cy="4114800"/>
           </a:xfrm>
           <a:prstGeom prst="roundRect">
             <a:avLst>
-              <a:gd name="adj" fmla="val 3177"/>
+              <a:gd name="adj" fmla="val 2667"/>
             </a:avLst>
           </a:prstGeom>
           <a:solidFill>
@@ -7657,13 +7734,13 @@
       </p:sp>
       <p:sp>
         <p:nvSpPr>
-          <p:cNvPr id="12" name="Shape 9"/>
-          <p:cNvSpPr/>
-          <p:nvPr/>
-        </p:nvSpPr>
-        <p:spPr>
-          <a:xfrm>
-            <a:off x="4688738" y="1691640"/>
+          <p:cNvPr id="13" name="Shape 10"/>
+          <p:cNvSpPr/>
+          <p:nvPr/>
+        </p:nvSpPr>
+        <p:spPr>
+          <a:xfrm>
+            <a:off x="6598768" y="1691640"/>
             <a:ext cx="777240" cy="777240"/>
           </a:xfrm>
           <a:prstGeom prst="ellipse">
@@ -7682,7 +7759,7 @@
       </p:sp>
       <p:pic>
         <p:nvPicPr>
-          <p:cNvPr id="13" name="Image 1" descr="preencoded.png">    </p:cNvPr>
+          <p:cNvPr id="14" name="Image 1" descr="preencoded.png">    </p:cNvPr>
           <p:cNvPicPr>
             <a:picLocks noChangeAspect="1"/>
           </p:cNvPicPr>
@@ -7696,7 +7773,7 @@
         </p:blipFill>
         <p:spPr>
           <a:xfrm>
-            <a:off x="4890821" y="1893722"/>
+            <a:off x="6800850" y="1893722"/>
             <a:ext cx="373075" cy="373075"/>
           </a:xfrm>
           <a:prstGeom prst="rect">
@@ -7706,14 +7783,14 @@
       </p:pic>
       <p:sp>
         <p:nvSpPr>
-          <p:cNvPr id="14" name="Text 10"/>
+          <p:cNvPr id="15" name="Text 11"/>
           <p:cNvSpPr txBox="1"/>
           <p:nvPr/>
         </p:nvSpPr>
         <p:spPr>
           <a:xfrm>
-            <a:off x="4688738" y="2697480"/>
-            <a:ext cx="2814218" cy="457200"/>
+            <a:off x="7558888" y="1709928"/>
+            <a:ext cx="3718408" cy="320040"/>
           </a:xfrm>
           <a:prstGeom prst="rect">
             <a:avLst/>
@@ -7729,7 +7806,46 @@
               <a:buNone/>
             </a:pPr>
             <a:r>
-              <a:rPr lang="en-US" sz="2000" b="1" dirty="0">
+              <a:rPr lang="en-US" sz="1400" b="1" spc="200" kern="0" dirty="0">
+                <a:solidFill>
+                  <a:srgbClr val="C6D3DF"/>
+                </a:solidFill>
+                <a:latin typeface="Calibri" pitchFamily="34" charset="0"/>
+                <a:ea typeface="Calibri" pitchFamily="34" charset="-122"/>
+                <a:cs typeface="Calibri" pitchFamily="34" charset="-120"/>
+              </a:rPr>
+              <a:t>Story 2</a:t>
+            </a:r>
+            <a:endParaRPr lang="en-US" sz="1400" dirty="0"/>
+          </a:p>
+        </p:txBody>
+      </p:sp>
+      <p:sp>
+        <p:nvSpPr>
+          <p:cNvPr id="16" name="Text 12"/>
+          <p:cNvSpPr txBox="1"/>
+          <p:nvPr/>
+        </p:nvSpPr>
+        <p:spPr>
+          <a:xfrm>
+            <a:off x="7558888" y="2011680"/>
+            <a:ext cx="3718408" cy="457200"/>
+          </a:xfrm>
+          <a:prstGeom prst="rect">
+            <a:avLst/>
+          </a:prstGeom>
+          <a:noFill/>
+          <a:ln/>
+        </p:spPr>
+        <p:txBody>
+          <a:bodyPr wrap="square" lIns="0" tIns="0" rIns="0" bIns="0" rtlCol="0" anchor="t"/>
+          <a:lstStyle/>
+          <a:p>
+            <a:pPr indent="0" marL="0">
+              <a:buNone/>
+            </a:pPr>
+            <a:r>
+              <a:rPr lang="en-US" sz="2200" b="1" dirty="0">
                 <a:solidFill>
                   <a:srgbClr val="FFFFFF"/>
                 </a:solidFill>
@@ -7737,22 +7853,22 @@
                 <a:ea typeface="Calibri" pitchFamily="34" charset="-122"/>
                 <a:cs typeface="Calibri" pitchFamily="34" charset="-120"/>
               </a:rPr>
-              <a:t>I have a CHM13 region.</a:t>
+              <a:t>A gene on a reference</a:t>
             </a:r>
-            <a:endParaRPr lang="en-US" sz="2000" dirty="0"/>
+            <a:endParaRPr lang="en-US" sz="2200" dirty="0"/>
           </a:p>
         </p:txBody>
       </p:sp>
       <p:sp>
         <p:nvSpPr>
-          <p:cNvPr id="15" name="Text 11"/>
+          <p:cNvPr id="17" name="Text 13"/>
           <p:cNvSpPr txBox="1"/>
           <p:nvPr/>
         </p:nvSpPr>
         <p:spPr>
           <a:xfrm>
-            <a:off x="4688738" y="3200400"/>
-            <a:ext cx="2814218" cy="914400"/>
+            <a:off x="6598768" y="2788920"/>
+            <a:ext cx="4724248" cy="1280160"/>
           </a:xfrm>
           <a:prstGeom prst="rect">
             <a:avLst/>
@@ -7768,7 +7884,7 @@
               <a:buNone/>
             </a:pPr>
             <a:r>
-              <a:rPr lang="en-US" sz="2000" dirty="0">
+              <a:rPr lang="en-US" sz="1900" dirty="0">
                 <a:solidFill>
                   <a:srgbClr val="C6D3DF"/>
                 </a:solidFill>
@@ -7776,22 +7892,22 @@
                 <a:ea typeface="Calibri" pitchFamily="34" charset="-122"/>
                 <a:cs typeface="Calibri" pitchFamily="34" charset="-120"/>
               </a:rPr>
-              <a:t>Where is it on HG02015?</a:t>
+              <a:t>This gene is on GRCh38 (or CHM13). Where is it on HG02015? And can I see its annotation there?</a:t>
             </a:r>
-            <a:endParaRPr lang="en-US" sz="2000" dirty="0"/>
+            <a:endParaRPr lang="en-US" sz="1900" dirty="0"/>
           </a:p>
         </p:txBody>
       </p:sp>
       <p:sp>
         <p:nvSpPr>
-          <p:cNvPr id="16" name="Text 12"/>
+          <p:cNvPr id="18" name="Text 14"/>
           <p:cNvSpPr txBox="1"/>
           <p:nvPr/>
         </p:nvSpPr>
         <p:spPr>
           <a:xfrm>
-            <a:off x="4688738" y="4251960"/>
-            <a:ext cx="2814218" cy="320040"/>
+            <a:off x="6598768" y="4160520"/>
+            <a:ext cx="4724248" cy="457200"/>
           </a:xfrm>
           <a:prstGeom prst="rect">
             <a:avLst/>
@@ -7807,7 +7923,7 @@
               <a:buNone/>
             </a:pPr>
             <a:r>
-              <a:rPr lang="en-US" sz="1400" dirty="0">
+              <a:rPr lang="en-US" sz="1500" dirty="0">
                 <a:solidFill>
                   <a:srgbClr val="C6D3DF"/>
                 </a:solidFill>
@@ -7815,22 +7931,22 @@
                 <a:ea typeface="Calibri" pitchFamily="34" charset="-122"/>
                 <a:cs typeface="Calibri" pitchFamily="34" charset="-120"/>
               </a:rPr>
-              <a:t>in the browser, in seconds</a:t>
+              <a:t>the gene on HG02015 in ~100 ms, with the reference's annotation drawn around it</a:t>
             </a:r>
-            <a:endParaRPr lang="en-US" sz="1400" dirty="0"/>
+            <a:endParaRPr lang="en-US" sz="1500" dirty="0"/>
           </a:p>
         </p:txBody>
       </p:sp>
       <p:sp>
         <p:nvSpPr>
-          <p:cNvPr id="17" name="Text 13"/>
+          <p:cNvPr id="19" name="Text 15"/>
           <p:cNvSpPr txBox="1"/>
           <p:nvPr/>
         </p:nvSpPr>
         <p:spPr>
           <a:xfrm>
-            <a:off x="4688738" y="4572000"/>
-            <a:ext cx="2814218" cy="640080"/>
+            <a:off x="6598768" y="4572000"/>
+            <a:ext cx="4724248" cy="640080"/>
           </a:xfrm>
           <a:prstGeom prst="rect">
             <a:avLst/>
@@ -7854,7 +7970,7 @@
                 <a:ea typeface="Calibri" pitchFamily="34" charset="-122"/>
                 <a:cs typeface="Calibri" pitchFamily="34" charset="-120"/>
               </a:rPr>
-              <a:t>yes</a:t>
+              <a:t>done</a:t>
             </a:r>
             <a:endParaRPr lang="en-US" sz="4000" dirty="0"/>
           </a:p>
@@ -7862,239 +7978,7 @@
       </p:sp>
       <p:sp>
         <p:nvSpPr>
-          <p:cNvPr id="18" name="Shape 14"/>
-          <p:cNvSpPr/>
-          <p:nvPr/>
-        </p:nvSpPr>
-        <p:spPr>
-          <a:xfrm>
-            <a:off x="8188757" y="1325880"/>
-            <a:ext cx="3454298" cy="4114800"/>
-          </a:xfrm>
-          <a:prstGeom prst="roundRect">
-            <a:avLst>
-              <a:gd name="adj" fmla="val 3177"/>
-            </a:avLst>
-          </a:prstGeom>
-          <a:solidFill>
-            <a:srgbClr val="0F3557"/>
-          </a:solidFill>
-          <a:ln w="12700">
-            <a:solidFill>
-              <a:srgbClr val="1D4F7C"/>
-            </a:solidFill>
-            <a:prstDash val="solid"/>
-          </a:ln>
-        </p:spPr>
-      </p:sp>
-      <p:sp>
-        <p:nvSpPr>
-          <p:cNvPr id="19" name="Shape 15"/>
-          <p:cNvSpPr/>
-          <p:nvPr/>
-        </p:nvSpPr>
-        <p:spPr>
-          <a:xfrm>
-            <a:off x="8508797" y="1691640"/>
-            <a:ext cx="777240" cy="777240"/>
-          </a:xfrm>
-          <a:prstGeom prst="ellipse">
-            <a:avLst/>
-          </a:prstGeom>
-          <a:solidFill>
-            <a:srgbClr val="0E7C9C"/>
-          </a:solidFill>
-          <a:ln w="12700">
-            <a:solidFill>
-              <a:srgbClr val="0E7C9C"/>
-            </a:solidFill>
-            <a:prstDash val="solid"/>
-          </a:ln>
-        </p:spPr>
-      </p:sp>
-      <p:pic>
-        <p:nvPicPr>
-          <p:cNvPr id="20" name="Image 2" descr="preencoded.png">    </p:cNvPr>
-          <p:cNvPicPr>
-            <a:picLocks noChangeAspect="1"/>
-          </p:cNvPicPr>
-          <p:nvPr/>
-        </p:nvPicPr>
-        <p:blipFill>
-          <a:blip r:embed="rId3"/>
-          <a:stretch>
-            <a:fillRect/>
-          </a:stretch>
-        </p:blipFill>
-        <p:spPr>
-          <a:xfrm>
-            <a:off x="8710879" y="1893722"/>
-            <a:ext cx="373075" cy="373075"/>
-          </a:xfrm>
-          <a:prstGeom prst="rect">
-            <a:avLst/>
-          </a:prstGeom>
-        </p:spPr>
-      </p:pic>
-      <p:sp>
-        <p:nvSpPr>
-          <p:cNvPr id="21" name="Text 16"/>
-          <p:cNvSpPr txBox="1"/>
-          <p:nvPr/>
-        </p:nvSpPr>
-        <p:spPr>
-          <a:xfrm>
-            <a:off x="8508797" y="2697480"/>
-            <a:ext cx="2814218" cy="457200"/>
-          </a:xfrm>
-          <a:prstGeom prst="rect">
-            <a:avLst/>
-          </a:prstGeom>
-          <a:noFill/>
-          <a:ln/>
-        </p:spPr>
-        <p:txBody>
-          <a:bodyPr wrap="square" lIns="0" tIns="0" rIns="0" bIns="0" rtlCol="0" anchor="t"/>
-          <a:lstStyle/>
-          <a:p>
-            <a:pPr indent="0" marL="0">
-              <a:buNone/>
-            </a:pPr>
-            <a:r>
-              <a:rPr lang="en-US" sz="2000" b="1" dirty="0">
-                <a:solidFill>
-                  <a:srgbClr val="FFFFFF"/>
-                </a:solidFill>
-                <a:latin typeface="Calibri" pitchFamily="34" charset="0"/>
-                <a:ea typeface="Calibri" pitchFamily="34" charset="-122"/>
-                <a:cs typeface="Calibri" pitchFamily="34" charset="-120"/>
-              </a:rPr>
-              <a:t>When I get there,</a:t>
-            </a:r>
-            <a:endParaRPr lang="en-US" sz="2000" dirty="0"/>
-          </a:p>
-        </p:txBody>
-      </p:sp>
-      <p:sp>
-        <p:nvSpPr>
-          <p:cNvPr id="22" name="Text 17"/>
-          <p:cNvSpPr txBox="1"/>
-          <p:nvPr/>
-        </p:nvSpPr>
-        <p:spPr>
-          <a:xfrm>
-            <a:off x="8508797" y="3200400"/>
-            <a:ext cx="2814218" cy="914400"/>
-          </a:xfrm>
-          <a:prstGeom prst="rect">
-            <a:avLst/>
-          </a:prstGeom>
-          <a:noFill/>
-          <a:ln/>
-        </p:spPr>
-        <p:txBody>
-          <a:bodyPr wrap="square" lIns="0" tIns="0" rIns="0" bIns="0" rtlCol="0" anchor="t"/>
-          <a:lstStyle/>
-          <a:p>
-            <a:pPr indent="0" marL="0">
-              <a:buNone/>
-            </a:pPr>
-            <a:r>
-              <a:rPr lang="en-US" sz="2000" dirty="0">
-                <a:solidFill>
-                  <a:srgbClr val="C6D3DF"/>
-                </a:solidFill>
-                <a:latin typeface="Calibri" pitchFamily="34" charset="0"/>
-                <a:ea typeface="Calibri" pitchFamily="34" charset="-122"/>
-                <a:cs typeface="Calibri" pitchFamily="34" charset="-120"/>
-              </a:rPr>
-              <a:t>can I see the genes?</a:t>
-            </a:r>
-            <a:endParaRPr lang="en-US" sz="2000" dirty="0"/>
-          </a:p>
-        </p:txBody>
-      </p:sp>
-      <p:sp>
-        <p:nvSpPr>
-          <p:cNvPr id="23" name="Text 18"/>
-          <p:cNvSpPr txBox="1"/>
-          <p:nvPr/>
-        </p:nvSpPr>
-        <p:spPr>
-          <a:xfrm>
-            <a:off x="8508797" y="4251960"/>
-            <a:ext cx="2814218" cy="320040"/>
-          </a:xfrm>
-          <a:prstGeom prst="rect">
-            <a:avLst/>
-          </a:prstGeom>
-          <a:noFill/>
-          <a:ln/>
-        </p:spPr>
-        <p:txBody>
-          <a:bodyPr wrap="square" lIns="0" tIns="0" rIns="0" bIns="0" rtlCol="0" anchor="t"/>
-          <a:lstStyle/>
-          <a:p>
-            <a:pPr indent="0" marL="0">
-              <a:buNone/>
-            </a:pPr>
-            <a:r>
-              <a:rPr lang="en-US" sz="1400" dirty="0">
-                <a:solidFill>
-                  <a:srgbClr val="C6D3DF"/>
-                </a:solidFill>
-                <a:latin typeface="Calibri" pitchFamily="34" charset="0"/>
-                <a:ea typeface="Calibri" pitchFamily="34" charset="-122"/>
-                <a:cs typeface="Calibri" pitchFamily="34" charset="-120"/>
-              </a:rPr>
-              <a:t>the reference's tracks, over a chain built on the spot</a:t>
-            </a:r>
-            <a:endParaRPr lang="en-US" sz="1400" dirty="0"/>
-          </a:p>
-        </p:txBody>
-      </p:sp>
-      <p:sp>
-        <p:nvSpPr>
-          <p:cNvPr id="24" name="Text 19"/>
-          <p:cNvSpPr txBox="1"/>
-          <p:nvPr/>
-        </p:nvSpPr>
-        <p:spPr>
-          <a:xfrm>
-            <a:off x="8508797" y="4572000"/>
-            <a:ext cx="2814218" cy="640080"/>
-          </a:xfrm>
-          <a:prstGeom prst="rect">
-            <a:avLst/>
-          </a:prstGeom>
-          <a:noFill/>
-          <a:ln/>
-        </p:spPr>
-        <p:txBody>
-          <a:bodyPr wrap="square" lIns="0" tIns="0" rIns="0" bIns="0" rtlCol="0" anchor="ctr"/>
-          <a:lstStyle/>
-          <a:p>
-            <a:pPr indent="0" marL="0">
-              <a:buNone/>
-            </a:pPr>
-            <a:r>
-              <a:rPr lang="en-US" sz="4000" b="1" dirty="0">
-                <a:solidFill>
-                  <a:srgbClr val="FDC700"/>
-                </a:solidFill>
-                <a:latin typeface="Calibri" pitchFamily="34" charset="0"/>
-                <a:ea typeface="Calibri" pitchFamily="34" charset="-122"/>
-                <a:cs typeface="Calibri" pitchFamily="34" charset="-120"/>
-              </a:rPr>
-              <a:t>yes</a:t>
-            </a:r>
-            <a:endParaRPr lang="en-US" sz="4000" dirty="0"/>
-          </a:p>
-        </p:txBody>
-      </p:sp>
-      <p:sp>
-        <p:nvSpPr>
-          <p:cNvPr id="25" name="Text 20"/>
+          <p:cNvPr id="20" name="Text 16"/>
           <p:cNvSpPr txBox="1"/>
           <p:nvPr/>
         </p:nvSpPr>
@@ -22799,7 +22683,7 @@
                 <a:ea typeface="Calibri" pitchFamily="34" charset="-122"/>
                 <a:cs typeface="Calibri" pitchFamily="34" charset="-120"/>
               </a:rPr>
-              <a:t>Three questions the browser can't answer today</a:t>
+              <a:t>Two users the browser can't serve today</a:t>
             </a:r>
             <a:endParaRPr lang="en-US" sz="3200" dirty="0"/>
           </a:p>
@@ -22853,11 +22737,11 @@
         <p:spPr>
           <a:xfrm>
             <a:off x="548640" y="1325880"/>
-            <a:ext cx="3454298" cy="4114800"/>
+            <a:ext cx="5364328" cy="4114800"/>
           </a:xfrm>
           <a:prstGeom prst="roundRect">
             <a:avLst>
-              <a:gd name="adj" fmla="val 3177"/>
+              <a:gd name="adj" fmla="val 2667"/>
             </a:avLst>
           </a:prstGeom>
           <a:solidFill>
@@ -22928,8 +22812,8 @@
         </p:nvSpPr>
         <p:spPr>
           <a:xfrm>
-            <a:off x="868680" y="2697480"/>
-            <a:ext cx="2814218" cy="457200"/>
+            <a:off x="1828800" y="1709928"/>
+            <a:ext cx="3718408" cy="320040"/>
           </a:xfrm>
           <a:prstGeom prst="rect">
             <a:avLst/>
@@ -22945,7 +22829,46 @@
               <a:buNone/>
             </a:pPr>
             <a:r>
-              <a:rPr lang="en-US" sz="2000" b="1" dirty="0">
+              <a:rPr lang="en-US" sz="1400" b="1" spc="200" kern="0" dirty="0">
+                <a:solidFill>
+                  <a:srgbClr val="5B6B7C"/>
+                </a:solidFill>
+                <a:latin typeface="Calibri" pitchFamily="34" charset="0"/>
+                <a:ea typeface="Calibri" pitchFamily="34" charset="-122"/>
+                <a:cs typeface="Calibri" pitchFamily="34" charset="-120"/>
+              </a:rPr>
+              <a:t>Story 1</a:t>
+            </a:r>
+            <a:endParaRPr lang="en-US" sz="1400" dirty="0"/>
+          </a:p>
+        </p:txBody>
+      </p:sp>
+      <p:sp>
+        <p:nvSpPr>
+          <p:cNvPr id="8" name="Text 5"/>
+          <p:cNvSpPr txBox="1"/>
+          <p:nvPr/>
+        </p:nvSpPr>
+        <p:spPr>
+          <a:xfrm>
+            <a:off x="1828800" y="2011680"/>
+            <a:ext cx="3718408" cy="457200"/>
+          </a:xfrm>
+          <a:prstGeom prst="rect">
+            <a:avLst/>
+          </a:prstGeom>
+          <a:noFill/>
+          <a:ln/>
+        </p:spPr>
+        <p:txBody>
+          <a:bodyPr wrap="square" lIns="0" tIns="0" rIns="0" bIns="0" rtlCol="0" anchor="t"/>
+          <a:lstStyle/>
+          <a:p>
+            <a:pPr indent="0" marL="0">
+              <a:buNone/>
+            </a:pPr>
+            <a:r>
+              <a:rPr lang="en-US" sz="2200" b="1" dirty="0">
                 <a:solidFill>
                   <a:srgbClr val="003C6C"/>
                 </a:solidFill>
@@ -22953,22 +22876,22 @@
                 <a:ea typeface="Calibri" pitchFamily="34" charset="-122"/>
                 <a:cs typeface="Calibri" pitchFamily="34" charset="-120"/>
               </a:rPr>
-              <a:t>I have a sequence.</a:t>
+              <a:t>A sequence in hand</a:t>
             </a:r>
-            <a:endParaRPr lang="en-US" sz="2000" dirty="0"/>
+            <a:endParaRPr lang="en-US" sz="2200" dirty="0"/>
           </a:p>
         </p:txBody>
       </p:sp>
       <p:sp>
         <p:nvSpPr>
-          <p:cNvPr id="8" name="Text 5"/>
+          <p:cNvPr id="9" name="Text 6"/>
           <p:cNvSpPr txBox="1"/>
           <p:nvPr/>
         </p:nvSpPr>
         <p:spPr>
           <a:xfrm>
-            <a:off x="868680" y="3200400"/>
-            <a:ext cx="2814218" cy="914400"/>
+            <a:off x="868680" y="2788920"/>
+            <a:ext cx="4724248" cy="1280160"/>
           </a:xfrm>
           <a:prstGeom prst="rect">
             <a:avLst/>
@@ -22984,7 +22907,7 @@
               <a:buNone/>
             </a:pPr>
             <a:r>
-              <a:rPr lang="en-US" sz="2000" dirty="0">
+              <a:rPr lang="en-US" sz="1900" dirty="0">
                 <a:solidFill>
                   <a:srgbClr val="18293B"/>
                 </a:solidFill>
@@ -22992,22 +22915,22 @@
                 <a:ea typeface="Calibri" pitchFamily="34" charset="-122"/>
                 <a:cs typeface="Calibri" pitchFamily="34" charset="-120"/>
               </a:rPr>
-              <a:t>Which haplotypes carry it, and where?</a:t>
+              <a:t>Which haplotypes carry this sequence, and where on each? Then map it, and look at it.</a:t>
             </a:r>
-            <a:endParaRPr lang="en-US" sz="2000" dirty="0"/>
+            <a:endParaRPr lang="en-US" sz="1900" dirty="0"/>
           </a:p>
         </p:txBody>
       </p:sp>
       <p:sp>
         <p:nvSpPr>
-          <p:cNvPr id="9" name="Text 6"/>
+          <p:cNvPr id="10" name="Text 7"/>
           <p:cNvSpPr txBox="1"/>
           <p:nvPr/>
         </p:nvSpPr>
         <p:spPr>
           <a:xfrm>
             <a:off x="868680" y="4251960"/>
-            <a:ext cx="2814218" cy="320040"/>
+            <a:ext cx="4724248" cy="320040"/>
           </a:xfrm>
           <a:prstGeom prst="rect">
             <a:avLst/>
@@ -23039,14 +22962,14 @@
       </p:sp>
       <p:sp>
         <p:nvSpPr>
-          <p:cNvPr id="10" name="Text 7"/>
+          <p:cNvPr id="11" name="Text 8"/>
           <p:cNvSpPr txBox="1"/>
           <p:nvPr/>
         </p:nvSpPr>
         <p:spPr>
           <a:xfrm>
             <a:off x="868680" y="4572000"/>
-            <a:ext cx="2814218" cy="640080"/>
+            <a:ext cx="4724248" cy="640080"/>
           </a:xfrm>
           <a:prstGeom prst="rect">
             <a:avLst/>
@@ -23062,7 +22985,7 @@
               <a:buNone/>
             </a:pPr>
             <a:r>
-              <a:rPr lang="en-US" sz="2600" b="1" dirty="0">
+              <a:rPr lang="en-US" sz="2400" b="1" dirty="0">
                 <a:solidFill>
                   <a:srgbClr val="E4572E"/>
                 </a:solidFill>
@@ -23070,26 +22993,26 @@
                 <a:ea typeface="Calibri" pitchFamily="34" charset="-122"/>
                 <a:cs typeface="Calibri" pitchFamily="34" charset="-120"/>
               </a:rPr>
-              <a:t>from a shell only</a:t>
+              <a:t>BLAT, one assembly at a time</a:t>
             </a:r>
-            <a:endParaRPr lang="en-US" sz="2600" dirty="0"/>
+            <a:endParaRPr lang="en-US" sz="2400" dirty="0"/>
           </a:p>
         </p:txBody>
       </p:sp>
       <p:sp>
         <p:nvSpPr>
-          <p:cNvPr id="11" name="Shape 8"/>
-          <p:cNvSpPr/>
-          <p:nvPr/>
-        </p:nvSpPr>
-        <p:spPr>
-          <a:xfrm>
-            <a:off x="4368698" y="1325880"/>
-            <a:ext cx="3454298" cy="4114800"/>
+          <p:cNvPr id="12" name="Shape 9"/>
+          <p:cNvSpPr/>
+          <p:nvPr/>
+        </p:nvSpPr>
+        <p:spPr>
+          <a:xfrm>
+            <a:off x="6278728" y="1325880"/>
+            <a:ext cx="5364328" cy="4114800"/>
           </a:xfrm>
           <a:prstGeom prst="roundRect">
             <a:avLst>
-              <a:gd name="adj" fmla="val 3177"/>
+              <a:gd name="adj" fmla="val 2667"/>
             </a:avLst>
           </a:prstGeom>
           <a:solidFill>
@@ -23105,13 +23028,13 @@
       </p:sp>
       <p:sp>
         <p:nvSpPr>
-          <p:cNvPr id="12" name="Shape 9"/>
-          <p:cNvSpPr/>
-          <p:nvPr/>
-        </p:nvSpPr>
-        <p:spPr>
-          <a:xfrm>
-            <a:off x="4688738" y="1691640"/>
+          <p:cNvPr id="13" name="Shape 10"/>
+          <p:cNvSpPr/>
+          <p:nvPr/>
+        </p:nvSpPr>
+        <p:spPr>
+          <a:xfrm>
+            <a:off x="6598768" y="1691640"/>
             <a:ext cx="777240" cy="777240"/>
           </a:xfrm>
           <a:prstGeom prst="ellipse">
@@ -23130,7 +23053,7 @@
       </p:sp>
       <p:pic>
         <p:nvPicPr>
-          <p:cNvPr id="13" name="Image 1" descr="preencoded.png">    </p:cNvPr>
+          <p:cNvPr id="14" name="Image 1" descr="preencoded.png">    </p:cNvPr>
           <p:cNvPicPr>
             <a:picLocks noChangeAspect="1"/>
           </p:cNvPicPr>
@@ -23144,7 +23067,7 @@
         </p:blipFill>
         <p:spPr>
           <a:xfrm>
-            <a:off x="4890821" y="1893722"/>
+            <a:off x="6800850" y="1893722"/>
             <a:ext cx="373075" cy="373075"/>
           </a:xfrm>
           <a:prstGeom prst="rect">
@@ -23154,14 +23077,14 @@
       </p:pic>
       <p:sp>
         <p:nvSpPr>
-          <p:cNvPr id="14" name="Text 10"/>
+          <p:cNvPr id="15" name="Text 11"/>
           <p:cNvSpPr txBox="1"/>
           <p:nvPr/>
         </p:nvSpPr>
         <p:spPr>
           <a:xfrm>
-            <a:off x="4688738" y="2697480"/>
-            <a:ext cx="2814218" cy="457200"/>
+            <a:off x="7558888" y="1709928"/>
+            <a:ext cx="3718408" cy="320040"/>
           </a:xfrm>
           <a:prstGeom prst="rect">
             <a:avLst/>
@@ -23177,7 +23100,46 @@
               <a:buNone/>
             </a:pPr>
             <a:r>
-              <a:rPr lang="en-US" sz="2000" b="1" dirty="0">
+              <a:rPr lang="en-US" sz="1400" b="1" spc="200" kern="0" dirty="0">
+                <a:solidFill>
+                  <a:srgbClr val="5B6B7C"/>
+                </a:solidFill>
+                <a:latin typeface="Calibri" pitchFamily="34" charset="0"/>
+                <a:ea typeface="Calibri" pitchFamily="34" charset="-122"/>
+                <a:cs typeface="Calibri" pitchFamily="34" charset="-120"/>
+              </a:rPr>
+              <a:t>Story 2</a:t>
+            </a:r>
+            <a:endParaRPr lang="en-US" sz="1400" dirty="0"/>
+          </a:p>
+        </p:txBody>
+      </p:sp>
+      <p:sp>
+        <p:nvSpPr>
+          <p:cNvPr id="16" name="Text 12"/>
+          <p:cNvSpPr txBox="1"/>
+          <p:nvPr/>
+        </p:nvSpPr>
+        <p:spPr>
+          <a:xfrm>
+            <a:off x="7558888" y="2011680"/>
+            <a:ext cx="3718408" cy="457200"/>
+          </a:xfrm>
+          <a:prstGeom prst="rect">
+            <a:avLst/>
+          </a:prstGeom>
+          <a:noFill/>
+          <a:ln/>
+        </p:spPr>
+        <p:txBody>
+          <a:bodyPr wrap="square" lIns="0" tIns="0" rIns="0" bIns="0" rtlCol="0" anchor="t"/>
+          <a:lstStyle/>
+          <a:p>
+            <a:pPr indent="0" marL="0">
+              <a:buNone/>
+            </a:pPr>
+            <a:r>
+              <a:rPr lang="en-US" sz="2200" b="1" dirty="0">
                 <a:solidFill>
                   <a:srgbClr val="003C6C"/>
                 </a:solidFill>
@@ -23185,22 +23147,22 @@
                 <a:ea typeface="Calibri" pitchFamily="34" charset="-122"/>
                 <a:cs typeface="Calibri" pitchFamily="34" charset="-120"/>
               </a:rPr>
-              <a:t>I have a CHM13 region.</a:t>
+              <a:t>A gene on a reference</a:t>
             </a:r>
-            <a:endParaRPr lang="en-US" sz="2000" dirty="0"/>
+            <a:endParaRPr lang="en-US" sz="2200" dirty="0"/>
           </a:p>
         </p:txBody>
       </p:sp>
       <p:sp>
         <p:nvSpPr>
-          <p:cNvPr id="15" name="Text 11"/>
+          <p:cNvPr id="17" name="Text 13"/>
           <p:cNvSpPr txBox="1"/>
           <p:nvPr/>
         </p:nvSpPr>
         <p:spPr>
           <a:xfrm>
-            <a:off x="4688738" y="3200400"/>
-            <a:ext cx="2814218" cy="914400"/>
+            <a:off x="6598768" y="2788920"/>
+            <a:ext cx="4724248" cy="1280160"/>
           </a:xfrm>
           <a:prstGeom prst="rect">
             <a:avLst/>
@@ -23216,7 +23178,7 @@
               <a:buNone/>
             </a:pPr>
             <a:r>
-              <a:rPr lang="en-US" sz="2000" dirty="0">
+              <a:rPr lang="en-US" sz="1900" dirty="0">
                 <a:solidFill>
                   <a:srgbClr val="18293B"/>
                 </a:solidFill>
@@ -23224,22 +23186,22 @@
                 <a:ea typeface="Calibri" pitchFamily="34" charset="-122"/>
                 <a:cs typeface="Calibri" pitchFamily="34" charset="-120"/>
               </a:rPr>
-              <a:t>Where is it on HG02015?</a:t>
+              <a:t>This gene is on GRCh38 (or CHM13). Where is it on HG02015? And can I see its annotation there?</a:t>
             </a:r>
-            <a:endParaRPr lang="en-US" sz="2000" dirty="0"/>
+            <a:endParaRPr lang="en-US" sz="1900" dirty="0"/>
           </a:p>
         </p:txBody>
       </p:sp>
       <p:sp>
         <p:nvSpPr>
-          <p:cNvPr id="16" name="Text 12"/>
+          <p:cNvPr id="18" name="Text 14"/>
           <p:cNvSpPr txBox="1"/>
           <p:nvPr/>
         </p:nvSpPr>
         <p:spPr>
           <a:xfrm>
-            <a:off x="4688738" y="4251960"/>
-            <a:ext cx="2814218" cy="320040"/>
+            <a:off x="6598768" y="4251960"/>
+            <a:ext cx="4724248" cy="320040"/>
           </a:xfrm>
           <a:prstGeom prst="rect">
             <a:avLst/>
@@ -23271,14 +23233,14 @@
       </p:sp>
       <p:sp>
         <p:nvSpPr>
-          <p:cNvPr id="17" name="Text 13"/>
+          <p:cNvPr id="19" name="Text 15"/>
           <p:cNvSpPr txBox="1"/>
           <p:nvPr/>
         </p:nvSpPr>
         <p:spPr>
           <a:xfrm>
-            <a:off x="4688738" y="4572000"/>
-            <a:ext cx="2814218" cy="640080"/>
+            <a:off x="6598768" y="4572000"/>
+            <a:ext cx="4724248" cy="640080"/>
           </a:xfrm>
           <a:prstGeom prst="rect">
             <a:avLst/>
@@ -23294,7 +23256,7 @@
               <a:buNone/>
             </a:pPr>
             <a:r>
-              <a:rPr lang="en-US" sz="2600" b="1" dirty="0">
+              <a:rPr lang="en-US" sz="2400" b="1" dirty="0">
                 <a:solidFill>
                   <a:srgbClr val="E4572E"/>
                 </a:solidFill>
@@ -23302,247 +23264,15 @@
                 <a:ea typeface="Calibri" pitchFamily="34" charset="-122"/>
                 <a:cs typeface="Calibri" pitchFamily="34" charset="-120"/>
               </a:rPr>
-              <a:t>56 pairs have chains</a:t>
+              <a:t>56 chain pairs; only the haplotype's own tracks</a:t>
             </a:r>
-            <a:endParaRPr lang="en-US" sz="2600" dirty="0"/>
+            <a:endParaRPr lang="en-US" sz="2400" dirty="0"/>
           </a:p>
         </p:txBody>
       </p:sp>
       <p:sp>
         <p:nvSpPr>
-          <p:cNvPr id="18" name="Shape 14"/>
-          <p:cNvSpPr/>
-          <p:nvPr/>
-        </p:nvSpPr>
-        <p:spPr>
-          <a:xfrm>
-            <a:off x="8188757" y="1325880"/>
-            <a:ext cx="3454298" cy="4114800"/>
-          </a:xfrm>
-          <a:prstGeom prst="roundRect">
-            <a:avLst>
-              <a:gd name="adj" fmla="val 3177"/>
-            </a:avLst>
-          </a:prstGeom>
-          <a:solidFill>
-            <a:srgbClr val="EDF1F6"/>
-          </a:solidFill>
-          <a:ln w="12700">
-            <a:solidFill>
-              <a:srgbClr val="DCE3EB"/>
-            </a:solidFill>
-            <a:prstDash val="solid"/>
-          </a:ln>
-        </p:spPr>
-      </p:sp>
-      <p:sp>
-        <p:nvSpPr>
-          <p:cNvPr id="19" name="Shape 15"/>
-          <p:cNvSpPr/>
-          <p:nvPr/>
-        </p:nvSpPr>
-        <p:spPr>
-          <a:xfrm>
-            <a:off x="8508797" y="1691640"/>
-            <a:ext cx="777240" cy="777240"/>
-          </a:xfrm>
-          <a:prstGeom prst="ellipse">
-            <a:avLst/>
-          </a:prstGeom>
-          <a:solidFill>
-            <a:srgbClr val="003C6C"/>
-          </a:solidFill>
-          <a:ln w="12700">
-            <a:solidFill>
-              <a:srgbClr val="003C6C"/>
-            </a:solidFill>
-            <a:prstDash val="solid"/>
-          </a:ln>
-        </p:spPr>
-      </p:sp>
-      <p:pic>
-        <p:nvPicPr>
-          <p:cNvPr id="20" name="Image 2" descr="preencoded.png">    </p:cNvPr>
-          <p:cNvPicPr>
-            <a:picLocks noChangeAspect="1"/>
-          </p:cNvPicPr>
-          <p:nvPr/>
-        </p:nvPicPr>
-        <p:blipFill>
-          <a:blip r:embed="rId3"/>
-          <a:stretch>
-            <a:fillRect/>
-          </a:stretch>
-        </p:blipFill>
-        <p:spPr>
-          <a:xfrm>
-            <a:off x="8710879" y="1893722"/>
-            <a:ext cx="373075" cy="373075"/>
-          </a:xfrm>
-          <a:prstGeom prst="rect">
-            <a:avLst/>
-          </a:prstGeom>
-        </p:spPr>
-      </p:pic>
-      <p:sp>
-        <p:nvSpPr>
-          <p:cNvPr id="21" name="Text 16"/>
-          <p:cNvSpPr txBox="1"/>
-          <p:nvPr/>
-        </p:nvSpPr>
-        <p:spPr>
-          <a:xfrm>
-            <a:off x="8508797" y="2697480"/>
-            <a:ext cx="2814218" cy="457200"/>
-          </a:xfrm>
-          <a:prstGeom prst="rect">
-            <a:avLst/>
-          </a:prstGeom>
-          <a:noFill/>
-          <a:ln/>
-        </p:spPr>
-        <p:txBody>
-          <a:bodyPr wrap="square" lIns="0" tIns="0" rIns="0" bIns="0" rtlCol="0" anchor="t"/>
-          <a:lstStyle/>
-          <a:p>
-            <a:pPr indent="0" marL="0">
-              <a:buNone/>
-            </a:pPr>
-            <a:r>
-              <a:rPr lang="en-US" sz="2000" b="1" dirty="0">
-                <a:solidFill>
-                  <a:srgbClr val="003C6C"/>
-                </a:solidFill>
-                <a:latin typeface="Calibri" pitchFamily="34" charset="0"/>
-                <a:ea typeface="Calibri" pitchFamily="34" charset="-122"/>
-                <a:cs typeface="Calibri" pitchFamily="34" charset="-120"/>
-              </a:rPr>
-              <a:t>When I get there,</a:t>
-            </a:r>
-            <a:endParaRPr lang="en-US" sz="2000" dirty="0"/>
-          </a:p>
-        </p:txBody>
-      </p:sp>
-      <p:sp>
-        <p:nvSpPr>
-          <p:cNvPr id="22" name="Text 17"/>
-          <p:cNvSpPr txBox="1"/>
-          <p:nvPr/>
-        </p:nvSpPr>
-        <p:spPr>
-          <a:xfrm>
-            <a:off x="8508797" y="3200400"/>
-            <a:ext cx="2814218" cy="914400"/>
-          </a:xfrm>
-          <a:prstGeom prst="rect">
-            <a:avLst/>
-          </a:prstGeom>
-          <a:noFill/>
-          <a:ln/>
-        </p:spPr>
-        <p:txBody>
-          <a:bodyPr wrap="square" lIns="0" tIns="0" rIns="0" bIns="0" rtlCol="0" anchor="t"/>
-          <a:lstStyle/>
-          <a:p>
-            <a:pPr indent="0" marL="0">
-              <a:buNone/>
-            </a:pPr>
-            <a:r>
-              <a:rPr lang="en-US" sz="2000" dirty="0">
-                <a:solidFill>
-                  <a:srgbClr val="18293B"/>
-                </a:solidFill>
-                <a:latin typeface="Calibri" pitchFamily="34" charset="0"/>
-                <a:ea typeface="Calibri" pitchFamily="34" charset="-122"/>
-                <a:cs typeface="Calibri" pitchFamily="34" charset="-120"/>
-              </a:rPr>
-              <a:t>can I see the genes?</a:t>
-            </a:r>
-            <a:endParaRPr lang="en-US" sz="2000" dirty="0"/>
-          </a:p>
-        </p:txBody>
-      </p:sp>
-      <p:sp>
-        <p:nvSpPr>
-          <p:cNvPr id="23" name="Text 18"/>
-          <p:cNvSpPr txBox="1"/>
-          <p:nvPr/>
-        </p:nvSpPr>
-        <p:spPr>
-          <a:xfrm>
-            <a:off x="8508797" y="4251960"/>
-            <a:ext cx="2814218" cy="320040"/>
-          </a:xfrm>
-          <a:prstGeom prst="rect">
-            <a:avLst/>
-          </a:prstGeom>
-          <a:noFill/>
-          <a:ln/>
-        </p:spPr>
-        <p:txBody>
-          <a:bodyPr wrap="square" lIns="0" tIns="0" rIns="0" bIns="0" rtlCol="0" anchor="t"/>
-          <a:lstStyle/>
-          <a:p>
-            <a:pPr indent="0" marL="0">
-              <a:buNone/>
-            </a:pPr>
-            <a:r>
-              <a:rPr lang="en-US" sz="1600" dirty="0">
-                <a:solidFill>
-                  <a:srgbClr val="5B6B7C"/>
-                </a:solidFill>
-                <a:latin typeface="Calibri" pitchFamily="34" charset="0"/>
-                <a:ea typeface="Calibri" pitchFamily="34" charset="-122"/>
-                <a:cs typeface="Calibri" pitchFamily="34" charset="-120"/>
-              </a:rPr>
-              <a:t>today</a:t>
-            </a:r>
-            <a:endParaRPr lang="en-US" sz="1600" dirty="0"/>
-          </a:p>
-        </p:txBody>
-      </p:sp>
-      <p:sp>
-        <p:nvSpPr>
-          <p:cNvPr id="24" name="Text 19"/>
-          <p:cNvSpPr txBox="1"/>
-          <p:nvPr/>
-        </p:nvSpPr>
-        <p:spPr>
-          <a:xfrm>
-            <a:off x="8508797" y="4572000"/>
-            <a:ext cx="2814218" cy="640080"/>
-          </a:xfrm>
-          <a:prstGeom prst="rect">
-            <a:avLst/>
-          </a:prstGeom>
-          <a:noFill/>
-          <a:ln/>
-        </p:spPr>
-        <p:txBody>
-          <a:bodyPr wrap="square" lIns="0" tIns="0" rIns="0" bIns="0" rtlCol="0" anchor="ctr"/>
-          <a:lstStyle/>
-          <a:p>
-            <a:pPr indent="0" marL="0">
-              <a:buNone/>
-            </a:pPr>
-            <a:r>
-              <a:rPr lang="en-US" sz="2600" b="1" dirty="0">
-                <a:solidFill>
-                  <a:srgbClr val="E4572E"/>
-                </a:solidFill>
-                <a:latin typeface="Calibri" pitchFamily="34" charset="0"/>
-                <a:ea typeface="Calibri" pitchFamily="34" charset="-122"/>
-                <a:cs typeface="Calibri" pitchFamily="34" charset="-120"/>
-              </a:rPr>
-              <a:t>only its own tracks</a:t>
-            </a:r>
-            <a:endParaRPr lang="en-US" sz="2600" dirty="0"/>
-          </a:p>
-        </p:txBody>
-      </p:sp>
-      <p:sp>
-        <p:nvSpPr>
-          <p:cNvPr id="25" name="Text 20"/>
+          <p:cNvPr id="20" name="Text 16"/>
           <p:cNvSpPr txBox="1"/>
           <p:nvPr/>
         </p:nvSpPr>
@@ -23573,7 +23303,7 @@
                 <a:ea typeface="Calibri" pitchFamily="34" charset="-122"/>
                 <a:cs typeface="Calibri" pitchFamily="34" charset="-120"/>
               </a:rPr>
-              <a:t>By the end of this talk: all three, in the browser, in seconds.</a:t>
+              <a:t>By the end of this talk: both, in the browser, in seconds.</a:t>
             </a:r>
             <a:endParaRPr lang="en-US" sz="2000" dirty="0"/>
           </a:p>
@@ -25801,7 +25531,7 @@
                 <a:ea typeface="Calibri" pitchFamily="34" charset="-122"/>
                 <a:cs typeface="Calibri" pitchFamily="34" charset="-120"/>
               </a:rPr>
-              <a:t>One mapping returns every assembly that carries it</a:t>
+              <a:t>Story 1: one sequence, every haplotype carrying it</a:t>
             </a:r>
             <a:endParaRPr lang="en-US" sz="3200" dirty="0"/>
           </a:p>
@@ -25879,7 +25609,7 @@
                 <a:ea typeface="Calibri" pitchFamily="34" charset="-122"/>
                 <a:cs typeface="Calibri" pitchFamily="34" charset="-120"/>
               </a:rPr>
-              <a:t>Question 1</a:t>
+              <a:t>Story 1</a:t>
             </a:r>
             <a:endParaRPr lang="en-US" sz="1600" dirty="0"/>
           </a:p>
@@ -26469,7 +26199,7 @@
                 <a:ea typeface="Calibri" pitchFamily="34" charset="-122"/>
                 <a:cs typeface="Calibri" pitchFamily="34" charset="-120"/>
               </a:rPr>
-              <a:t>...and it lands as a native track</a:t>
+              <a:t>...and map it onto the haplotype you choose</a:t>
             </a:r>
             <a:endParaRPr lang="en-US" sz="3200" dirty="0"/>
           </a:p>
@@ -26516,7 +26246,46 @@
       </p:sp>
       <p:sp>
         <p:nvSpPr>
-          <p:cNvPr id="4" name="Shape 2"/>
+          <p:cNvPr id="4" name="Text 2"/>
+          <p:cNvSpPr txBox="1"/>
+          <p:nvPr/>
+        </p:nvSpPr>
+        <p:spPr>
+          <a:xfrm>
+            <a:off x="9631375" y="384048"/>
+            <a:ext cx="2011680" cy="713232"/>
+          </a:xfrm>
+          <a:prstGeom prst="rect">
+            <a:avLst/>
+          </a:prstGeom>
+          <a:noFill/>
+          <a:ln/>
+        </p:spPr>
+        <p:txBody>
+          <a:bodyPr wrap="square" lIns="0" tIns="0" rIns="0" bIns="0" rtlCol="0" anchor="ctr"/>
+          <a:lstStyle/>
+          <a:p>
+            <a:pPr algn="r" indent="0" marL="0">
+              <a:buNone/>
+            </a:pPr>
+            <a:r>
+              <a:rPr lang="en-US" sz="1600" b="1" dirty="0">
+                <a:solidFill>
+                  <a:srgbClr val="003C6C"/>
+                </a:solidFill>
+                <a:latin typeface="Calibri" pitchFamily="34" charset="0"/>
+                <a:ea typeface="Calibri" pitchFamily="34" charset="-122"/>
+                <a:cs typeface="Calibri" pitchFamily="34" charset="-120"/>
+              </a:rPr>
+              <a:t>Story 1</a:t>
+            </a:r>
+            <a:endParaRPr lang="en-US" sz="1600" dirty="0"/>
+          </a:p>
+        </p:txBody>
+      </p:sp>
+      <p:sp>
+        <p:nvSpPr>
+          <p:cNvPr id="5" name="Shape 3"/>
           <p:cNvSpPr/>
           <p:nvPr/>
         </p:nvSpPr>
@@ -26543,7 +26312,7 @@
       </p:sp>
       <p:sp>
         <p:nvSpPr>
-          <p:cNvPr id="5" name="Shape 3"/>
+          <p:cNvPr id="6" name="Shape 4"/>
           <p:cNvSpPr/>
           <p:nvPr/>
         </p:nvSpPr>
@@ -26568,7 +26337,7 @@
       </p:sp>
       <p:sp>
         <p:nvSpPr>
-          <p:cNvPr id="6" name="Shape 4"/>
+          <p:cNvPr id="7" name="Shape 5"/>
           <p:cNvSpPr/>
           <p:nvPr/>
         </p:nvSpPr>
@@ -26593,7 +26362,7 @@
       </p:sp>
       <p:sp>
         <p:nvSpPr>
-          <p:cNvPr id="7" name="Shape 5"/>
+          <p:cNvPr id="8" name="Shape 6"/>
           <p:cNvSpPr/>
           <p:nvPr/>
         </p:nvSpPr>
@@ -26618,7 +26387,7 @@
       </p:sp>
       <p:sp>
         <p:nvSpPr>
-          <p:cNvPr id="8" name="Text 6"/>
+          <p:cNvPr id="9" name="Text 7"/>
           <p:cNvSpPr txBox="1"/>
           <p:nvPr/>
         </p:nvSpPr>
@@ -26657,7 +26426,7 @@
       </p:sp>
       <p:pic>
         <p:nvPicPr>
-          <p:cNvPr id="9" name="Image 0" descr="/Users/seeskand/Documents/HPRC/2026/hprc_2026_poster/talk/figures/crop_seqtrack.png">    </p:cNvPr>
+          <p:cNvPr id="10" name="Image 0" descr="/Users/seeskand/Documents/HPRC/2026/hprc_2026_poster/talk/figures/crop_seqtrack.png">    </p:cNvPr>
           <p:cNvPicPr>
             <a:picLocks noChangeAspect="1"/>
           </p:cNvPicPr>
@@ -26681,7 +26450,7 @@
       </p:pic>
       <p:sp>
         <p:nvSpPr>
-          <p:cNvPr id="10" name="Shape 7"/>
+          <p:cNvPr id="11" name="Shape 8"/>
           <p:cNvSpPr/>
           <p:nvPr/>
         </p:nvSpPr>
@@ -26710,7 +26479,7 @@
       </p:sp>
       <p:sp>
         <p:nvSpPr>
-          <p:cNvPr id="11" name="Text 8"/>
+          <p:cNvPr id="12" name="Text 9"/>
           <p:cNvSpPr txBox="1"/>
           <p:nvPr/>
         </p:nvSpPr>

</xml_diff>

<commit_message>
Talk: elaborate the two user stories (insertion absent from GRCh38; gene known on a reference), add QuickLift-today slide, fold hgConvert into the convert slide
</commit_message>
<xml_diff>
--- a/talk/HPRC2026_talk.pptx
+++ b/talk/HPRC2026_talk.pptx
@@ -1336,9 +1336,11 @@
           <a:p>
             <a:r>
               <a:rPr lang="en-US" dirty="0"/>
-              <a:t>[7:25-8:15]
-The second user starts from coordinates, not a sequence. He knows his gene on a reference. Here the source is CHM13 and the gene is HLA-DMA, a ten-kilobase region on chromosome 6; GRCh38 is a path in this graph too, so hg38 works exactly the same way. Target: any of the other 463 haplotypes, and the picker can show only the ones that actually contain the region.
-He picks HG02015 paternal, a haplotype he has never looked at. Result: contig CM085893, a hundred percent of bases, a hundred percent of span, in about a hundred milliseconds.</a:t>
+              <a:t>[7:25-8:00]
+Second afternoon. She has HLA-DMA open on a reference, ClinVar and GWAS beside it, and she wants that locus on one HPRC individual.
+The browser already has the right tool for this: QuickLift, shipped last year. View, In Other Genomes, tick QuickLift tracks, and your tracks are drawn on the other assembly with the differences marked. It is superb for hg38 to hs1.
+But QuickLift needs a prebuilt chain between the two assemblies, made by UCSC on request. Between HPRC haplotypes the browser has fifty-six, out of more than two hundred thousand pairs. She picks HG02015. There is no chain. Dead end.
+The renderer is ready. What's missing is a chain for any pair, on demand. That is exactly what the walk from slide seven produces.</a:t>
             </a:r>
             <a:endParaRPr lang="en-US" dirty="0"/>
           </a:p>
@@ -1426,9 +1428,9 @@
           <a:p>
             <a:r>
               <a:rPr lang="en-US" dirty="0"/>
-              <a:t>[8:15-8:40]
-And it asks nothing new of anyone. Open the ordinary hgConvert page and the pangenome assemblies are simply in the menu. Pick one, and the conversion goes through the graph instead of a chain file. Same button, new capability.
-(Skip this slide if running long.)</a:t>
+              <a:t>[8:00-8:50]
+Now the same afternoon with our tool. Source: the reference she was looking at; here CHM13 and the gene is HLA-DMA, a ten-kilobase region on chromosome 6. GRCh38 is a path in this graph too, so hg38 works exactly the same way. Target: any of the other 463 haplotypes, and the picker can show only the ones that actually contain the region.
+She picks HG02015 paternal, the haplotype that was a dead end a minute ago. Result: contig CM085893, a hundred percent of bases, a hundred percent of span, in about a hundred milliseconds. And because we plugged into the same menus, the pangenome haplotypes also show up in the ordinary hgConvert page.</a:t>
             </a:r>
             <a:endParaRPr lang="en-US" dirty="0"/>
           </a:p>
@@ -1517,11 +1519,11 @@
             <a:r>
               <a:rPr lang="en-US" dirty="0"/>
               <a:t>[8:40-10:20]  SLOW DOWN. This is the slide the talk exists for.
-But a coordinate on its own is a lonely thing. He clicks the result, and this is the part I care about most.
-This is HG02015 paternal, at his gene. Release 2 gave it CAT and Liftoff genes, and per-assembly annotation is the right answer where it exists. What HG02015 does not have, and never will, is everything else: ClinVar, the GWAS catalog, ENCODE, your lab's BED file. Those live once, on one reference.
-And here they are: CHM13's tracks, drawn at their translated positions, under an Alignment Differences track marking every insertion, deletion and mismatch between the two assemblies.
-(pause) The chain that made this possible did not exist a second before the page loaded. The translation blocks became a bigChain, the browser's own QuickLift drew the tracks, and the chain is reused for every pan.
-That's the second user done: a gene he knew on a reference, on a haplotype nobody annotated for him, with the reference's annotation around it. And that's what I mean by making release 2 useful. The thousands of tracks that exist once, on one reference, will never be rebuilt 464 times. Any haplotype can borrow them, on demand, for the region you're actually looking at.</a:t>
+But a coordinate on its own is a lonely thing. She clicks the result, and this is the part I care about most.
+This is HG02015 paternal, at her gene. Release 2 gave it CAT and Liftoff genes, and per-assembly annotation is the right answer where it exists. What HG02015 does not have, and never will, is everything else: ClinVar, the GWAS catalog, ENCODE, her own BED file. Those live once, on one reference.
+And here they are: the reference's tracks, drawn at their translated positions, with the differences marked the way QuickLift users already read them: insertions, deletions, mismatches.
+(pause) The chain that made this possible did not exist a second before the page loaded. The translation blocks became a bigChain, the browser's own QuickLift renderer drew the tracks, and the chain is reused for every pan. Same QuickLift. The chain just isn't prebuilt anymore.
+Second afternoon done: a gene she knew on a reference, on a haplotype nobody built a chain for, with the reference's annotation around it. That's what I mean by making release 2 useful: the thousands of tracks that exist once, on one reference, will never be rebuilt 464 times. Any haplotype can borrow them, on demand.</a:t>
             </a:r>
             <a:endParaRPr lang="en-US" dirty="0"/>
           </a:p>
@@ -1884,8 +1886,8 @@
             <a:r>
               <a:rPr lang="en-US" dirty="0"/>
               <a:t>[13:05-13:45]
-So, back to the two users I promised.
-The one with a sequence: every haplotype that carries it, ranked, and mapped as a track on the one she chose. The one with a gene on a reference: the same gene on HG02015 in a tenth of a second, with the reference's annotation drawn around it, over a chain built on the spot.
+So, back to her two afternoons.
+The insertion that isn't in GRCh38: two carriers found in seconds, and mapped as a track on a genome that has it. The gene she knew on a reference: on HG02015 in a tenth of a second, with the reference's tracks drawn around it, over a chain that didn't exist until she asked.
 It's live on the development browser today. So bring me your hardest region, and tell me where it breaks.
 (Advance to the thanks slide, let it breathe, then take questions.)</a:t>
             </a:r>
@@ -2600,11 +2602,11 @@
           <a:p>
             <a:r>
               <a:rPr lang="en-US" dirty="0"/>
-              <a:t>[1:50-2:30]
-So let me follow two users through the browser.
-The first has a sequence in hand: a probe, a contig, a variant's flanks. Which haplotypes in the graph carry it, and where on each? And then: map it, and look at it.
-The second has a gene, and knows it on a reference: GRCh38, or CHM13. Where is that gene on HG02015? And when they get there, can they see its annotation?
-Everyone in this room can serve both users with enough shell. Nobody can do it from the browser, in seconds, for an arbitrary haplotype. By the end of this talk: both, live.</a:t>
+              <a:t>[1:50-2:35]
+Let me make this concrete with one researcher and two afternoons.
+First afternoon: she has assembled an insertion from a patient's long reads, and it is not in GRCh38. Which HPRC haplotypes carry it? How common is it? What does the neighbourhood look like on a genome that actually has it? Today her tool is BLAT: one assembly at a time, and BLAT knows nothing about the graph, so it can't tell her who else carries the sequence.
+Second afternoon: she's curating a gene on GRCh38, ClinVar and the GWAS catalog open, and she wants to see that locus on one HPRC individual. Today her tool is QuickLift, and QuickLift works only where a chain already exists. For most HPRC haplotypes, it doesn't.
+Everyone in this room can serve her with enough shell. Nobody can do it from the browser, in seconds, for an arbitrary haplotype. By the end of this talk: both afternoons, live.</a:t>
             </a:r>
             <a:endParaRPr lang="en-US" dirty="0"/>
           </a:p>
@@ -2969,8 +2971,8 @@
             <a:r>
               <a:rPr lang="en-US" dirty="0"/>
               <a:t>[5:55-6:55]
-That's the whole method. Now the two users, starting with the one holding a sequence.
-This is the Pangenome Mapping page: BLAT, but for the pangenome. She pastes her sequence, a kilobase here. It is mapped once, to the whole graph, with vg giraffe. She gets back every haplotype that carries it, ranked by identity: here two, HG01167 hap1 and HG04157 paternal. And a position on whichever one she picks. Picking a different haplotype re-surjects the same alignment; nothing is remapped.
+That's the whole method. Now the first afternoon: the insertion that isn't in the reference.
+This is the Pangenome Mapping page: BLAT, but for the pangenome. She pastes her sequence, a kilobase here. It is mapped once, to the whole graph, with vg giraffe, in a few seconds. Notice what BLAT could never have told her: exactly two of the 464 haplotypes carry this sequence, HG01167 hap1 and HG04157 paternal, and GRCh38 is not one of them. Ranked by identity, with a position on whichever one she picks. Picking a different haplotype re-surjects the same alignment; nothing is remapped.
 You'll notice MAPQ zero. That's not a bad alignment; that's what MAPQ means in a graph where every locus exists hundreds of times. We report identity and coverage per haplotype instead.</a:t>
             </a:r>
             <a:endParaRPr lang="en-US" dirty="0"/>
@@ -3060,7 +3062,7 @@
             <a:r>
               <a:rPr lang="en-US" dirty="0"/>
               <a:t>[6:55-7:25]
-She clicks through to a haplotype, here HG01167 hap1, and doesn't land on a special page. She lands in the browser, on that haplotype, with her sequence as a native track and base-level differences colored the way BLAT users already know. That's the first user done: which haplotypes, where, and mapped.</a:t>
+She clicks through to a haplotype, here HG01167 hap1, and doesn't land on a special page. She lands in the browser, on a genome that actually has her insertion, with the sequence as a native track, base-level differences colored the way BLAT users already know, and that haplotype's own annotation around it. First afternoon done: who carries it, where, and what it looks like there.</a:t>
             </a:r>
             <a:endParaRPr lang="en-US" dirty="0"/>
           </a:p>
@@ -3861,7 +3863,7 @@
                 <a:ea typeface="Calibri" pitchFamily="34" charset="-122"/>
                 <a:cs typeface="Calibri" pitchFamily="34" charset="-120"/>
               </a:rPr>
-              <a:t>Story 2: a reference gene on any haplotype, ~100 ms</a:t>
+              <a:t>Story 2, today: QuickLift needs a chain for every pair</a:t>
             </a:r>
             <a:endParaRPr lang="en-US" sz="3200" dirty="0"/>
           </a:p>
@@ -3953,12 +3955,12 @@
         </p:nvSpPr>
         <p:spPr>
           <a:xfrm>
-            <a:off x="595774" y="1325880"/>
-            <a:ext cx="6580852" cy="4983480"/>
+            <a:off x="548640" y="1325880"/>
+            <a:ext cx="5364328" cy="4206240"/>
           </a:xfrm>
           <a:prstGeom prst="roundRect">
             <a:avLst>
-              <a:gd name="adj" fmla="val 2202"/>
+              <a:gd name="adj" fmla="val 2609"/>
             </a:avLst>
           </a:prstGeom>
           <a:solidFill>
@@ -3980,115 +3982,26 @@
         </p:nvSpPr>
         <p:spPr>
           <a:xfrm>
-            <a:off x="742078" y="1417320"/>
-            <a:ext cx="100584" cy="100584"/>
+            <a:off x="868680" y="1645920"/>
+            <a:ext cx="640080" cy="640080"/>
           </a:xfrm>
           <a:prstGeom prst="ellipse">
             <a:avLst/>
           </a:prstGeom>
           <a:solidFill>
-            <a:srgbClr val="CBD5E0"/>
-          </a:solidFill>
-          <a:ln w="12700">
-            <a:solidFill>
-              <a:srgbClr val="CBD5E0"/>
-            </a:solidFill>
-            <a:prstDash val="solid"/>
-          </a:ln>
-        </p:spPr>
-      </p:sp>
-      <p:sp>
-        <p:nvSpPr>
-          <p:cNvPr id="7" name="Shape 5"/>
-          <p:cNvSpPr/>
-          <p:nvPr/>
-        </p:nvSpPr>
-        <p:spPr>
-          <a:xfrm>
-            <a:off x="906670" y="1417320"/>
-            <a:ext cx="100584" cy="100584"/>
-          </a:xfrm>
-          <a:prstGeom prst="ellipse">
-            <a:avLst/>
-          </a:prstGeom>
-          <a:solidFill>
-            <a:srgbClr val="CBD5E0"/>
-          </a:solidFill>
-          <a:ln w="12700">
-            <a:solidFill>
-              <a:srgbClr val="CBD5E0"/>
-            </a:solidFill>
-            <a:prstDash val="solid"/>
-          </a:ln>
-        </p:spPr>
-      </p:sp>
-      <p:sp>
-        <p:nvSpPr>
-          <p:cNvPr id="8" name="Shape 6"/>
-          <p:cNvSpPr/>
-          <p:nvPr/>
-        </p:nvSpPr>
-        <p:spPr>
-          <a:xfrm>
-            <a:off x="1071262" y="1417320"/>
-            <a:ext cx="100584" cy="100584"/>
-          </a:xfrm>
-          <a:prstGeom prst="ellipse">
-            <a:avLst/>
-          </a:prstGeom>
-          <a:solidFill>
-            <a:srgbClr val="CBD5E0"/>
-          </a:solidFill>
-          <a:ln w="12700">
-            <a:solidFill>
-              <a:srgbClr val="CBD5E0"/>
-            </a:solidFill>
-            <a:prstDash val="solid"/>
-          </a:ln>
-        </p:spPr>
-      </p:sp>
-      <p:sp>
-        <p:nvSpPr>
-          <p:cNvPr id="9" name="Text 7"/>
-          <p:cNvSpPr txBox="1"/>
-          <p:nvPr/>
-        </p:nvSpPr>
-        <p:spPr>
-          <a:xfrm>
-            <a:off x="1373014" y="1353312"/>
-            <a:ext cx="3657600" cy="237744"/>
-          </a:xfrm>
-          <a:prstGeom prst="rect">
-            <a:avLst/>
-          </a:prstGeom>
-          <a:noFill/>
-          <a:ln/>
-        </p:spPr>
-        <p:txBody>
-          <a:bodyPr wrap="square" lIns="0" tIns="0" rIns="0" bIns="0" rtlCol="0" anchor="ctr"/>
-          <a:lstStyle/>
-          <a:p>
-            <a:pPr indent="0" marL="0">
-              <a:buNone/>
-            </a:pPr>
-            <a:r>
-              <a:rPr lang="en-US" sz="900" dirty="0">
-                <a:solidFill>
-                  <a:srgbClr val="5B6B7C"/>
-                </a:solidFill>
-                <a:latin typeface="Courier New" pitchFamily="34" charset="0"/>
-                <a:ea typeface="Courier New" pitchFamily="34" charset="-122"/>
-                <a:cs typeface="Courier New" pitchFamily="34" charset="-120"/>
-              </a:rPr>
-              <a:t>genome.ucsc.edu</a:t>
-            </a:r>
-            <a:endParaRPr lang="en-US" sz="900" dirty="0"/>
-          </a:p>
-        </p:txBody>
+            <a:srgbClr val="003C6C"/>
+          </a:solidFill>
+          <a:ln w="12700">
+            <a:solidFill>
+              <a:srgbClr val="003C6C"/>
+            </a:solidFill>
+            <a:prstDash val="solid"/>
+          </a:ln>
+        </p:spPr>
       </p:sp>
       <p:pic>
         <p:nvPicPr>
-          <p:cNvPr id="10" name="Image 0" descr="/Users/seeskand/Documents/HPRC/2026/hprc_2026_poster/talk/figures/crop_convert.png">    </p:cNvPr>
+          <p:cNvPr id="7" name="Image 0" descr="preencoded.png">    </p:cNvPr>
           <p:cNvPicPr>
             <a:picLocks noChangeAspect="1"/>
           </p:cNvPicPr>
@@ -4102,8 +4015,8 @@
         </p:blipFill>
         <p:spPr>
           <a:xfrm>
-            <a:off x="705502" y="1636776"/>
-            <a:ext cx="6361396" cy="4562856"/>
+            <a:off x="1035101" y="1812341"/>
+            <a:ext cx="307238" cy="307238"/>
           </a:xfrm>
           <a:prstGeom prst="rect">
             <a:avLst/>
@@ -4112,14 +4025,14 @@
       </p:pic>
       <p:sp>
         <p:nvSpPr>
-          <p:cNvPr id="11" name="Text 8"/>
+          <p:cNvPr id="8" name="Text 5"/>
           <p:cNvSpPr txBox="1"/>
           <p:nvPr/>
         </p:nvSpPr>
         <p:spPr>
           <a:xfrm>
-            <a:off x="7543800" y="1417320"/>
-            <a:ext cx="4099255" cy="320040"/>
+            <a:off x="1691640" y="1709928"/>
+            <a:ext cx="3901288" cy="502920"/>
           </a:xfrm>
           <a:prstGeom prst="rect">
             <a:avLst/>
@@ -4132,214 +4045,6 @@
           <a:lstStyle/>
           <a:p>
             <a:pPr indent="0" marL="0">
-              <a:buNone/>
-            </a:pPr>
-            <a:r>
-              <a:rPr lang="en-US" sz="1600" b="1" dirty="0">
-                <a:solidFill>
-                  <a:srgbClr val="5B6B7C"/>
-                </a:solidFill>
-                <a:latin typeface="Calibri" pitchFamily="34" charset="0"/>
-                <a:ea typeface="Calibri" pitchFamily="34" charset="-122"/>
-                <a:cs typeface="Calibri" pitchFamily="34" charset="-120"/>
-              </a:rPr>
-              <a:t>CHM13</a:t>
-            </a:r>
-            <a:endParaRPr lang="en-US" sz="1600" dirty="0"/>
-          </a:p>
-        </p:txBody>
-      </p:sp>
-      <p:sp>
-        <p:nvSpPr>
-          <p:cNvPr id="12" name="Text 9"/>
-          <p:cNvSpPr txBox="1"/>
-          <p:nvPr/>
-        </p:nvSpPr>
-        <p:spPr>
-          <a:xfrm>
-            <a:off x="7543800" y="1737360"/>
-            <a:ext cx="4099255" cy="411480"/>
-          </a:xfrm>
-          <a:prstGeom prst="rect">
-            <a:avLst/>
-          </a:prstGeom>
-          <a:noFill/>
-          <a:ln/>
-        </p:spPr>
-        <p:txBody>
-          <a:bodyPr wrap="square" lIns="0" tIns="0" rIns="0" bIns="0" rtlCol="0" anchor="t"/>
-          <a:lstStyle/>
-          <a:p>
-            <a:pPr indent="0" marL="0">
-              <a:buNone/>
-            </a:pPr>
-            <a:r>
-              <a:rPr lang="en-US" sz="1800" dirty="0">
-                <a:solidFill>
-                  <a:srgbClr val="18293B"/>
-                </a:solidFill>
-                <a:latin typeface="Courier New" pitchFamily="34" charset="0"/>
-                <a:ea typeface="Courier New" pitchFamily="34" charset="-122"/>
-                <a:cs typeface="Courier New" pitchFamily="34" charset="-120"/>
-              </a:rPr>
-              <a:t>chr6:32,768,058-32,778,749</a:t>
-            </a:r>
-            <a:endParaRPr lang="en-US" sz="1800" dirty="0"/>
-          </a:p>
-        </p:txBody>
-      </p:sp>
-      <p:sp>
-        <p:nvSpPr>
-          <p:cNvPr id="13" name="Shape 10"/>
-          <p:cNvSpPr/>
-          <p:nvPr/>
-        </p:nvSpPr>
-        <p:spPr>
-          <a:xfrm>
-            <a:off x="7635240" y="2240280"/>
-            <a:ext cx="320040" cy="411480"/>
-          </a:xfrm>
-          <a:prstGeom prst="downArrow">
-            <a:avLst/>
-          </a:prstGeom>
-          <a:solidFill>
-            <a:srgbClr val="FDC700"/>
-          </a:solidFill>
-          <a:ln w="12700">
-            <a:solidFill>
-              <a:srgbClr val="FDC700"/>
-            </a:solidFill>
-            <a:prstDash val="solid"/>
-          </a:ln>
-        </p:spPr>
-      </p:sp>
-      <p:sp>
-        <p:nvSpPr>
-          <p:cNvPr id="14" name="Text 11"/>
-          <p:cNvSpPr txBox="1"/>
-          <p:nvPr/>
-        </p:nvSpPr>
-        <p:spPr>
-          <a:xfrm>
-            <a:off x="7543800" y="2743200"/>
-            <a:ext cx="4099255" cy="320040"/>
-          </a:xfrm>
-          <a:prstGeom prst="rect">
-            <a:avLst/>
-          </a:prstGeom>
-          <a:noFill/>
-          <a:ln/>
-        </p:spPr>
-        <p:txBody>
-          <a:bodyPr wrap="square" lIns="0" tIns="0" rIns="0" bIns="0" rtlCol="0" anchor="t"/>
-          <a:lstStyle/>
-          <a:p>
-            <a:pPr indent="0" marL="0">
-              <a:buNone/>
-            </a:pPr>
-            <a:r>
-              <a:rPr lang="en-US" sz="1600" b="1" dirty="0">
-                <a:solidFill>
-                  <a:srgbClr val="5B6B7C"/>
-                </a:solidFill>
-                <a:latin typeface="Calibri" pitchFamily="34" charset="0"/>
-                <a:ea typeface="Calibri" pitchFamily="34" charset="-122"/>
-                <a:cs typeface="Calibri" pitchFamily="34" charset="-120"/>
-              </a:rPr>
-              <a:t>HG02015 paternal</a:t>
-            </a:r>
-            <a:endParaRPr lang="en-US" sz="1600" dirty="0"/>
-          </a:p>
-        </p:txBody>
-      </p:sp>
-      <p:sp>
-        <p:nvSpPr>
-          <p:cNvPr id="15" name="Text 12"/>
-          <p:cNvSpPr txBox="1"/>
-          <p:nvPr/>
-        </p:nvSpPr>
-        <p:spPr>
-          <a:xfrm>
-            <a:off x="7543800" y="3063240"/>
-            <a:ext cx="4099255" cy="731520"/>
-          </a:xfrm>
-          <a:prstGeom prst="rect">
-            <a:avLst/>
-          </a:prstGeom>
-          <a:noFill/>
-          <a:ln/>
-        </p:spPr>
-        <p:txBody>
-          <a:bodyPr wrap="square" lIns="0" tIns="0" rIns="0" bIns="0" rtlCol="0" anchor="t"/>
-          <a:lstStyle/>
-          <a:p>
-            <a:pPr indent="0" marL="0">
-              <a:buNone/>
-            </a:pPr>
-            <a:r>
-              <a:rPr lang="en-US" sz="1800" dirty="0">
-                <a:solidFill>
-                  <a:srgbClr val="18293B"/>
-                </a:solidFill>
-                <a:latin typeface="Courier New" pitchFamily="34" charset="0"/>
-                <a:ea typeface="Courier New" pitchFamily="34" charset="-122"/>
-                <a:cs typeface="Courier New" pitchFamily="34" charset="-120"/>
-              </a:rPr>
-              <a:t>CM085893.1:32,953,289-32,963,978</a:t>
-            </a:r>
-            <a:endParaRPr lang="en-US" sz="1800" dirty="0"/>
-          </a:p>
-        </p:txBody>
-      </p:sp>
-      <p:sp>
-        <p:nvSpPr>
-          <p:cNvPr id="16" name="Shape 13"/>
-          <p:cNvSpPr/>
-          <p:nvPr/>
-        </p:nvSpPr>
-        <p:spPr>
-          <a:xfrm>
-            <a:off x="7543800" y="3931920"/>
-            <a:ext cx="4099255" cy="868680"/>
-          </a:xfrm>
-          <a:prstGeom prst="roundRect">
-            <a:avLst>
-              <a:gd name="adj" fmla="val 12632"/>
-            </a:avLst>
-          </a:prstGeom>
-          <a:solidFill>
-            <a:srgbClr val="EDF1F6"/>
-          </a:solidFill>
-          <a:ln w="12700">
-            <a:solidFill>
-              <a:srgbClr val="DCE3EB"/>
-            </a:solidFill>
-            <a:prstDash val="solid"/>
-          </a:ln>
-        </p:spPr>
-      </p:sp>
-      <p:sp>
-        <p:nvSpPr>
-          <p:cNvPr id="17" name="Text 14"/>
-          <p:cNvSpPr txBox="1"/>
-          <p:nvPr/>
-        </p:nvSpPr>
-        <p:spPr>
-          <a:xfrm>
-            <a:off x="7543800" y="3931920"/>
-            <a:ext cx="4099255" cy="868680"/>
-          </a:xfrm>
-          <a:prstGeom prst="rect">
-            <a:avLst/>
-          </a:prstGeom>
-          <a:noFill/>
-          <a:ln/>
-        </p:spPr>
-        <p:txBody>
-          <a:bodyPr wrap="square" lIns="0" tIns="0" rIns="0" bIns="0" rtlCol="0" anchor="ctr"/>
-          <a:lstStyle/>
-          <a:p>
-            <a:pPr algn="ctr" indent="0" marL="0">
               <a:buNone/>
             </a:pPr>
             <a:r>
@@ -4351,7 +4056,7 @@
                 <a:ea typeface="Calibri" pitchFamily="34" charset="-122"/>
                 <a:cs typeface="Calibri" pitchFamily="34" charset="-120"/>
               </a:rPr>
-              <a:t>100% of bases, 100% of span</a:t>
+              <a:t>QuickLift, in the browser since 2025</a:t>
             </a:r>
             <a:endParaRPr lang="en-US" sz="2200" dirty="0"/>
           </a:p>
@@ -4359,14 +4064,14 @@
       </p:sp>
       <p:sp>
         <p:nvSpPr>
-          <p:cNvPr id="18" name="Text 15"/>
+          <p:cNvPr id="9" name="Text 6"/>
           <p:cNvSpPr txBox="1"/>
           <p:nvPr/>
         </p:nvSpPr>
         <p:spPr>
           <a:xfrm>
-            <a:off x="7543800" y="4983480"/>
-            <a:ext cx="4099255" cy="1280160"/>
+            <a:off x="868680" y="2514600"/>
+            <a:ext cx="4724248" cy="2926080"/>
           </a:xfrm>
           <a:prstGeom prst="rect">
             <a:avLst/>
@@ -4378,8 +4083,12 @@
           <a:bodyPr wrap="square" lIns="0" tIns="0" rIns="0" bIns="0" rtlCol="0" anchor="t"/>
           <a:lstStyle/>
           <a:p>
-            <a:pPr indent="0" marL="0">
-              <a:buNone/>
+            <a:pPr marL="203200" indent="-203200">
+              <a:spcAft>
+                <a:spcPts val="900"/>
+              </a:spcAft>
+              <a:buSzPct val="100000"/>
+              <a:buChar char="•"/>
             </a:pPr>
             <a:r>
               <a:rPr lang="en-US" sz="1700" dirty="0">
@@ -4390,9 +4099,180 @@
                 <a:ea typeface="Calibri" pitchFamily="34" charset="-122"/>
                 <a:cs typeface="Calibri" pitchFamily="34" charset="-120"/>
               </a:rPr>
-              <a:t>About 115 ms for this 10.7 kb region. GRCh38 is a path in the graph too, so hg38 can be the source.</a:t>
+              <a:t>View &gt; In Other Genomes, tick "QuickLift tracks": your tracks are drawn on the other assembly, differences marked with vertical bars.</a:t>
             </a:r>
             <a:endParaRPr lang="en-US" sz="1700" dirty="0"/>
+          </a:p>
+          <a:p>
+            <a:pPr marL="203200" indent="-203200">
+              <a:spcAft>
+                <a:spcPts val="900"/>
+              </a:spcAft>
+              <a:buSzPct val="100000"/>
+              <a:buChar char="•"/>
+            </a:pPr>
+            <a:r>
+              <a:rPr lang="en-US" sz="1700" dirty="0">
+                <a:solidFill>
+                  <a:srgbClr val="18293B"/>
+                </a:solidFill>
+                <a:latin typeface="Calibri" pitchFamily="34" charset="0"/>
+                <a:ea typeface="Calibri" pitchFamily="34" charset="-122"/>
+                <a:cs typeface="Calibri" pitchFamily="34" charset="-120"/>
+              </a:rPr>
+              <a:t>Needs a prebuilt liftOver chain between the two assemblies, made by UCSC on request.</a:t>
+            </a:r>
+            <a:endParaRPr lang="en-US" sz="1700" dirty="0"/>
+          </a:p>
+          <a:p>
+            <a:pPr marL="203200" indent="-203200">
+              <a:spcAft>
+                <a:spcPts val="900"/>
+              </a:spcAft>
+              <a:buSzPct val="100000"/>
+              <a:buChar char="•"/>
+            </a:pPr>
+            <a:r>
+              <a:rPr lang="en-US" sz="1700" dirty="0">
+                <a:solidFill>
+                  <a:srgbClr val="18293B"/>
+                </a:solidFill>
+                <a:latin typeface="Calibri" pitchFamily="34" charset="0"/>
+                <a:ea typeface="Calibri" pitchFamily="34" charset="-122"/>
+                <a:cs typeface="Calibri" pitchFamily="34" charset="-120"/>
+              </a:rPr>
+              <a:t>Superb for hg38 to hs1. Between HPRC haplotypes: 56 chains, out of 200,000+ pairs.</a:t>
+            </a:r>
+            <a:endParaRPr lang="en-US" sz="1700" dirty="0"/>
+          </a:p>
+        </p:txBody>
+      </p:sp>
+      <p:sp>
+        <p:nvSpPr>
+          <p:cNvPr id="10" name="Shape 7"/>
+          <p:cNvSpPr/>
+          <p:nvPr/>
+        </p:nvSpPr>
+        <p:spPr>
+          <a:xfrm>
+            <a:off x="6278728" y="1325880"/>
+            <a:ext cx="5364328" cy="4206240"/>
+          </a:xfrm>
+          <a:prstGeom prst="roundRect">
+            <a:avLst>
+              <a:gd name="adj" fmla="val 2609"/>
+            </a:avLst>
+          </a:prstGeom>
+          <a:solidFill>
+            <a:srgbClr val="EDF1F6"/>
+          </a:solidFill>
+          <a:ln w="12700">
+            <a:solidFill>
+              <a:srgbClr val="DCE3EB"/>
+            </a:solidFill>
+            <a:prstDash val="solid"/>
+          </a:ln>
+        </p:spPr>
+      </p:sp>
+      <p:pic>
+        <p:nvPicPr>
+          <p:cNvPr id="11" name="Image 1" descr="/Users/seeskand/Documents/HPRC/2026/hprc_2026_poster/talk/figures/grids.png">    </p:cNvPr>
+          <p:cNvPicPr>
+            <a:picLocks noChangeAspect="1"/>
+          </p:cNvPicPr>
+          <p:nvPr/>
+        </p:nvPicPr>
+        <p:blipFill>
+          <a:blip r:embed="rId2"/>
+          <a:stretch>
+            <a:fillRect/>
+          </a:stretch>
+        </p:blipFill>
+        <p:spPr>
+          <a:xfrm>
+            <a:off x="6598768" y="1828800"/>
+            <a:ext cx="4724248" cy="1666982"/>
+          </a:xfrm>
+          <a:prstGeom prst="rect">
+            <a:avLst/>
+          </a:prstGeom>
+        </p:spPr>
+      </p:pic>
+      <p:sp>
+        <p:nvSpPr>
+          <p:cNvPr id="12" name="Text 8"/>
+          <p:cNvSpPr txBox="1"/>
+          <p:nvPr/>
+        </p:nvSpPr>
+        <p:spPr>
+          <a:xfrm>
+            <a:off x="6598768" y="3678662"/>
+            <a:ext cx="4724248" cy="1097280"/>
+          </a:xfrm>
+          <a:prstGeom prst="rect">
+            <a:avLst/>
+          </a:prstGeom>
+          <a:noFill/>
+          <a:ln/>
+        </p:spPr>
+        <p:txBody>
+          <a:bodyPr wrap="square" lIns="0" tIns="0" rIns="0" bIns="0" rtlCol="0" anchor="t"/>
+          <a:lstStyle/>
+          <a:p>
+            <a:pPr algn="ctr" indent="0" marL="0">
+              <a:buNone/>
+            </a:pPr>
+            <a:r>
+              <a:rPr lang="en-US" sz="1900" i="1" dirty="0">
+                <a:solidFill>
+                  <a:srgbClr val="003C6C"/>
+                </a:solidFill>
+                <a:latin typeface="Calibri" pitchFamily="34" charset="0"/>
+                <a:ea typeface="Calibri" pitchFamily="34" charset="-122"/>
+                <a:cs typeface="Calibri" pitchFamily="34" charset="-120"/>
+              </a:rPr>
+              <a:t>She picks HG02015 from the menu. There is no chain. Dead end.</a:t>
+            </a:r>
+            <a:endParaRPr lang="en-US" sz="1900" dirty="0"/>
+          </a:p>
+        </p:txBody>
+      </p:sp>
+      <p:sp>
+        <p:nvSpPr>
+          <p:cNvPr id="13" name="Text 9"/>
+          <p:cNvSpPr txBox="1"/>
+          <p:nvPr/>
+        </p:nvSpPr>
+        <p:spPr>
+          <a:xfrm>
+            <a:off x="548640" y="5852160"/>
+            <a:ext cx="11094415" cy="548640"/>
+          </a:xfrm>
+          <a:prstGeom prst="rect">
+            <a:avLst/>
+          </a:prstGeom>
+          <a:noFill/>
+          <a:ln/>
+        </p:spPr>
+        <p:txBody>
+          <a:bodyPr wrap="square" lIns="0" tIns="0" rIns="0" bIns="0" rtlCol="0" anchor="ctr"/>
+          <a:lstStyle/>
+          <a:p>
+            <a:pPr algn="ctr" indent="0" marL="0">
+              <a:buNone/>
+            </a:pPr>
+            <a:r>
+              <a:rPr lang="en-US" sz="2000" i="1" dirty="0">
+                <a:solidFill>
+                  <a:srgbClr val="003C6C"/>
+                </a:solidFill>
+                <a:latin typeface="Calibri" pitchFamily="34" charset="0"/>
+                <a:ea typeface="Calibri" pitchFamily="34" charset="-122"/>
+                <a:cs typeface="Calibri" pitchFamily="34" charset="-120"/>
+              </a:rPr>
+              <a:t>The renderer is ready. The missing piece is a chain for any pair, on demand.</a:t>
+            </a:r>
+            <a:endParaRPr lang="en-US" sz="2000" dirty="0"/>
           </a:p>
         </p:txBody>
       </p:sp>
@@ -4461,7 +4341,7 @@
                 <a:ea typeface="Calibri" pitchFamily="34" charset="-122"/>
                 <a:cs typeface="Calibri" pitchFamily="34" charset="-120"/>
               </a:rPr>
-              <a:t>...or from the hgConvert page he already uses</a:t>
+              <a:t>Story 2, now: any of 464 haplotypes, in ~100 ms</a:t>
             </a:r>
             <a:endParaRPr lang="en-US" sz="3200" dirty="0"/>
           </a:p>
@@ -4553,12 +4433,12 @@
         </p:nvSpPr>
         <p:spPr>
           <a:xfrm>
-            <a:off x="548640" y="1325880"/>
-            <a:ext cx="7132320" cy="3685032"/>
+            <a:off x="595774" y="1325880"/>
+            <a:ext cx="6580852" cy="4983480"/>
           </a:xfrm>
           <a:prstGeom prst="roundRect">
             <a:avLst>
-              <a:gd name="adj" fmla="val 2978"/>
+              <a:gd name="adj" fmla="val 2202"/>
             </a:avLst>
           </a:prstGeom>
           <a:solidFill>
@@ -4580,7 +4460,7 @@
         </p:nvSpPr>
         <p:spPr>
           <a:xfrm>
-            <a:off x="694944" y="1417320"/>
+            <a:off x="742078" y="1417320"/>
             <a:ext cx="100584" cy="100584"/>
           </a:xfrm>
           <a:prstGeom prst="ellipse">
@@ -4605,7 +4485,7 @@
         </p:nvSpPr>
         <p:spPr>
           <a:xfrm>
-            <a:off x="859536" y="1417320"/>
+            <a:off x="906670" y="1417320"/>
             <a:ext cx="100584" cy="100584"/>
           </a:xfrm>
           <a:prstGeom prst="ellipse">
@@ -4630,7 +4510,7 @@
         </p:nvSpPr>
         <p:spPr>
           <a:xfrm>
-            <a:off x="1024128" y="1417320"/>
+            <a:off x="1071262" y="1417320"/>
             <a:ext cx="100584" cy="100584"/>
           </a:xfrm>
           <a:prstGeom prst="ellipse">
@@ -4655,7 +4535,7 @@
         </p:nvSpPr>
         <p:spPr>
           <a:xfrm>
-            <a:off x="1325880" y="1353312"/>
+            <a:off x="1373014" y="1353312"/>
             <a:ext cx="3657600" cy="237744"/>
           </a:xfrm>
           <a:prstGeom prst="rect">
@@ -4688,7 +4568,7 @@
       </p:sp>
       <p:pic>
         <p:nvPicPr>
-          <p:cNvPr id="10" name="Image 0" descr="/Users/seeskand/Documents/HPRC/2026/hprc_2026_poster/talk/figures/crop_dropdown.png">    </p:cNvPr>
+          <p:cNvPr id="10" name="Image 0" descr="/Users/seeskand/Documents/HPRC/2026/hprc_2026_poster/talk/figures/crop_convert.png">    </p:cNvPr>
           <p:cNvPicPr>
             <a:picLocks noChangeAspect="1"/>
           </p:cNvPicPr>
@@ -4702,8 +4582,8 @@
         </p:blipFill>
         <p:spPr>
           <a:xfrm>
-            <a:off x="658368" y="1636776"/>
-            <a:ext cx="6912864" cy="3264408"/>
+            <a:off x="705502" y="1636776"/>
+            <a:ext cx="6361396" cy="4562856"/>
           </a:xfrm>
           <a:prstGeom prst="rect">
             <a:avLst/>
@@ -4718,8 +4598,47 @@
         </p:nvSpPr>
         <p:spPr>
           <a:xfrm>
-            <a:off x="8046720" y="1508760"/>
-            <a:ext cx="3596335" cy="1005840"/>
+            <a:off x="7543800" y="1417320"/>
+            <a:ext cx="4099255" cy="320040"/>
+          </a:xfrm>
+          <a:prstGeom prst="rect">
+            <a:avLst/>
+          </a:prstGeom>
+          <a:noFill/>
+          <a:ln/>
+        </p:spPr>
+        <p:txBody>
+          <a:bodyPr wrap="square" lIns="0" tIns="0" rIns="0" bIns="0" rtlCol="0" anchor="t"/>
+          <a:lstStyle/>
+          <a:p>
+            <a:pPr indent="0" marL="0">
+              <a:buNone/>
+            </a:pPr>
+            <a:r>
+              <a:rPr lang="en-US" sz="1600" b="1" dirty="0">
+                <a:solidFill>
+                  <a:srgbClr val="5B6B7C"/>
+                </a:solidFill>
+                <a:latin typeface="Calibri" pitchFamily="34" charset="0"/>
+                <a:ea typeface="Calibri" pitchFamily="34" charset="-122"/>
+                <a:cs typeface="Calibri" pitchFamily="34" charset="-120"/>
+              </a:rPr>
+              <a:t>CHM13</a:t>
+            </a:r>
+            <a:endParaRPr lang="en-US" sz="1600" dirty="0"/>
+          </a:p>
+        </p:txBody>
+      </p:sp>
+      <p:sp>
+        <p:nvSpPr>
+          <p:cNvPr id="12" name="Text 9"/>
+          <p:cNvSpPr txBox="1"/>
+          <p:nvPr/>
+        </p:nvSpPr>
+        <p:spPr>
+          <a:xfrm>
+            <a:off x="7543800" y="1737360"/>
+            <a:ext cx="4099255" cy="411480"/>
           </a:xfrm>
           <a:prstGeom prst="rect">
             <a:avLst/>
@@ -4739,26 +4658,90 @@
                 <a:solidFill>
                   <a:srgbClr val="18293B"/>
                 </a:solidFill>
+                <a:latin typeface="Courier New" pitchFamily="34" charset="0"/>
+                <a:ea typeface="Courier New" pitchFamily="34" charset="-122"/>
+                <a:cs typeface="Courier New" pitchFamily="34" charset="-120"/>
+              </a:rPr>
+              <a:t>chr6:32,768,058-32,778,749</a:t>
+            </a:r>
+            <a:endParaRPr lang="en-US" sz="1800" dirty="0"/>
+          </a:p>
+        </p:txBody>
+      </p:sp>
+      <p:sp>
+        <p:nvSpPr>
+          <p:cNvPr id="13" name="Shape 10"/>
+          <p:cNvSpPr/>
+          <p:nvPr/>
+        </p:nvSpPr>
+        <p:spPr>
+          <a:xfrm>
+            <a:off x="7635240" y="2240280"/>
+            <a:ext cx="320040" cy="411480"/>
+          </a:xfrm>
+          <a:prstGeom prst="downArrow">
+            <a:avLst/>
+          </a:prstGeom>
+          <a:solidFill>
+            <a:srgbClr val="FDC700"/>
+          </a:solidFill>
+          <a:ln w="12700">
+            <a:solidFill>
+              <a:srgbClr val="FDC700"/>
+            </a:solidFill>
+            <a:prstDash val="solid"/>
+          </a:ln>
+        </p:spPr>
+      </p:sp>
+      <p:sp>
+        <p:nvSpPr>
+          <p:cNvPr id="14" name="Text 11"/>
+          <p:cNvSpPr txBox="1"/>
+          <p:nvPr/>
+        </p:nvSpPr>
+        <p:spPr>
+          <a:xfrm>
+            <a:off x="7543800" y="2743200"/>
+            <a:ext cx="4099255" cy="320040"/>
+          </a:xfrm>
+          <a:prstGeom prst="rect">
+            <a:avLst/>
+          </a:prstGeom>
+          <a:noFill/>
+          <a:ln/>
+        </p:spPr>
+        <p:txBody>
+          <a:bodyPr wrap="square" lIns="0" tIns="0" rIns="0" bIns="0" rtlCol="0" anchor="t"/>
+          <a:lstStyle/>
+          <a:p>
+            <a:pPr indent="0" marL="0">
+              <a:buNone/>
+            </a:pPr>
+            <a:r>
+              <a:rPr lang="en-US" sz="1600" b="1" dirty="0">
+                <a:solidFill>
+                  <a:srgbClr val="5B6B7C"/>
+                </a:solidFill>
                 <a:latin typeface="Calibri" pitchFamily="34" charset="0"/>
                 <a:ea typeface="Calibri" pitchFamily="34" charset="-122"/>
                 <a:cs typeface="Calibri" pitchFamily="34" charset="-120"/>
               </a:rPr>
-              <a:t>Pangenome assemblies appear in the ordinary assembly menu.</a:t>
+              <a:t>HG02015 paternal</a:t>
             </a:r>
-            <a:endParaRPr lang="en-US" sz="1800" dirty="0"/>
+            <a:endParaRPr lang="en-US" sz="1600" dirty="0"/>
           </a:p>
         </p:txBody>
       </p:sp>
       <p:sp>
         <p:nvSpPr>
-          <p:cNvPr id="12" name="Text 9"/>
+          <p:cNvPr id="15" name="Text 12"/>
           <p:cNvSpPr txBox="1"/>
           <p:nvPr/>
         </p:nvSpPr>
         <p:spPr>
           <a:xfrm>
-            <a:off x="8046720" y="2697480"/>
-            <a:ext cx="3596335" cy="1188720"/>
+            <a:off x="7543800" y="3063240"/>
+            <a:ext cx="4099255" cy="731520"/>
           </a:xfrm>
           <a:prstGeom prst="rect">
             <a:avLst/>
@@ -4778,11 +4761,11 @@
                 <a:solidFill>
                   <a:srgbClr val="18293B"/>
                 </a:solidFill>
-                <a:latin typeface="Calibri" pitchFamily="34" charset="0"/>
-                <a:ea typeface="Calibri" pitchFamily="34" charset="-122"/>
-                <a:cs typeface="Calibri" pitchFamily="34" charset="-120"/>
+                <a:latin typeface="Courier New" pitchFamily="34" charset="0"/>
+                <a:ea typeface="Courier New" pitchFamily="34" charset="-122"/>
+                <a:cs typeface="Courier New" pitchFamily="34" charset="-120"/>
               </a:rPr>
-              <a:t>Pick one, and the conversion goes through the graph instead of a chain file.</a:t>
+              <a:t>CM085893.1:32,953,289-32,963,978</a:t>
             </a:r>
             <a:endParaRPr lang="en-US" sz="1800" dirty="0"/>
           </a:p>
@@ -4790,18 +4773,18 @@
       </p:sp>
       <p:sp>
         <p:nvSpPr>
-          <p:cNvPr id="13" name="Shape 10"/>
-          <p:cNvSpPr/>
-          <p:nvPr/>
-        </p:nvSpPr>
-        <p:spPr>
-          <a:xfrm>
-            <a:off x="8046720" y="4069080"/>
-            <a:ext cx="3596335" cy="822960"/>
+          <p:cNvPr id="16" name="Shape 13"/>
+          <p:cNvSpPr/>
+          <p:nvPr/>
+        </p:nvSpPr>
+        <p:spPr>
+          <a:xfrm>
+            <a:off x="7543800" y="3931920"/>
+            <a:ext cx="4099255" cy="868680"/>
           </a:xfrm>
           <a:prstGeom prst="roundRect">
             <a:avLst>
-              <a:gd name="adj" fmla="val 13333"/>
+              <a:gd name="adj" fmla="val 12632"/>
             </a:avLst>
           </a:prstGeom>
           <a:solidFill>
@@ -4817,14 +4800,14 @@
       </p:sp>
       <p:sp>
         <p:nvSpPr>
-          <p:cNvPr id="14" name="Text 11"/>
+          <p:cNvPr id="17" name="Text 14"/>
           <p:cNvSpPr txBox="1"/>
           <p:nvPr/>
         </p:nvSpPr>
         <p:spPr>
           <a:xfrm>
-            <a:off x="8046720" y="4069080"/>
-            <a:ext cx="3596335" cy="822960"/>
+            <a:off x="7543800" y="3931920"/>
+            <a:ext cx="4099255" cy="868680"/>
           </a:xfrm>
           <a:prstGeom prst="rect">
             <a:avLst/>
@@ -4840,7 +4823,7 @@
               <a:buNone/>
             </a:pPr>
             <a:r>
-              <a:rPr lang="en-US" sz="1900" b="1" dirty="0">
+              <a:rPr lang="en-US" sz="2200" b="1" dirty="0">
                 <a:solidFill>
                   <a:srgbClr val="003C6C"/>
                 </a:solidFill>
@@ -4848,9 +4831,48 @@
                 <a:ea typeface="Calibri" pitchFamily="34" charset="-122"/>
                 <a:cs typeface="Calibri" pitchFamily="34" charset="-120"/>
               </a:rPr>
-              <a:t>Same button. New capability.</a:t>
+              <a:t>100% of bases, 100% of span</a:t>
             </a:r>
-            <a:endParaRPr lang="en-US" sz="1900" dirty="0"/>
+            <a:endParaRPr lang="en-US" sz="2200" dirty="0"/>
+          </a:p>
+        </p:txBody>
+      </p:sp>
+      <p:sp>
+        <p:nvSpPr>
+          <p:cNvPr id="18" name="Text 15"/>
+          <p:cNvSpPr txBox="1"/>
+          <p:nvPr/>
+        </p:nvSpPr>
+        <p:spPr>
+          <a:xfrm>
+            <a:off x="7543800" y="4983480"/>
+            <a:ext cx="4099255" cy="1371600"/>
+          </a:xfrm>
+          <a:prstGeom prst="rect">
+            <a:avLst/>
+          </a:prstGeom>
+          <a:noFill/>
+          <a:ln/>
+        </p:spPr>
+        <p:txBody>
+          <a:bodyPr wrap="square" lIns="0" tIns="0" rIns="0" bIns="0" rtlCol="0" anchor="t"/>
+          <a:lstStyle/>
+          <a:p>
+            <a:pPr indent="0" marL="0">
+              <a:buNone/>
+            </a:pPr>
+            <a:r>
+              <a:rPr lang="en-US" sz="1600" dirty="0">
+                <a:solidFill>
+                  <a:srgbClr val="18293B"/>
+                </a:solidFill>
+                <a:latin typeface="Calibri" pitchFamily="34" charset="0"/>
+                <a:ea typeface="Calibri" pitchFamily="34" charset="-122"/>
+                <a:cs typeface="Calibri" pitchFamily="34" charset="-120"/>
+              </a:rPr>
+              <a:t>About 115 ms for this 10.7 kb gene. GRCh38 is a path in the graph too, so hg38 can be the source. The same haplotypes also appear in hgConvert's assembly menu.</a:t>
+            </a:r>
+            <a:endParaRPr lang="en-US" sz="1600" dirty="0"/>
           </a:p>
         </p:txBody>
       </p:sp>
@@ -4919,7 +4941,7 @@
                 <a:ea typeface="Calibri" pitchFamily="34" charset="-122"/>
                 <a:cs typeface="Calibri" pitchFamily="34" charset="-120"/>
               </a:rPr>
-              <a:t>...and arrive with the reference's annotations</a:t>
+              <a:t>...and the reference's tracks come along</a:t>
             </a:r>
             <a:endParaRPr lang="en-US" sz="3200" dirty="0"/>
           </a:p>
@@ -7582,7 +7604,7 @@
                 <a:ea typeface="Calibri" pitchFamily="34" charset="-122"/>
                 <a:cs typeface="Calibri" pitchFamily="34" charset="-120"/>
               </a:rPr>
-              <a:t>A sequence in hand</a:t>
+              <a:t>A sequence GRCh38 doesn't have</a:t>
             </a:r>
             <a:endParaRPr lang="en-US" sz="2200" dirty="0"/>
           </a:p>
@@ -7621,7 +7643,7 @@
                 <a:ea typeface="Calibri" pitchFamily="34" charset="-122"/>
                 <a:cs typeface="Calibri" pitchFamily="34" charset="-120"/>
               </a:rPr>
-              <a:t>Which haplotypes carry this sequence, and where on each? Then map it, and look at it.</a:t>
+              <a:t>A researcher assembles an insertion from long reads. It isn't in the reference. Which HPRC haplotypes carry it, and what does it look like there?</a:t>
             </a:r>
             <a:endParaRPr lang="en-US" sz="1900" dirty="0"/>
           </a:p>
@@ -7660,7 +7682,7 @@
                 <a:ea typeface="Calibri" pitchFamily="34" charset="-122"/>
                 <a:cs typeface="Calibri" pitchFamily="34" charset="-120"/>
               </a:rPr>
-              <a:t>every carrying haplotype, ranked; mapped as a track on the one she chose</a:t>
+              <a:t>two carriers found in seconds; her insertion mapped as a track on a genome that has it</a:t>
             </a:r>
             <a:endParaRPr lang="en-US" sz="1500" dirty="0"/>
           </a:p>
@@ -7853,7 +7875,7 @@
                 <a:ea typeface="Calibri" pitchFamily="34" charset="-122"/>
                 <a:cs typeface="Calibri" pitchFamily="34" charset="-120"/>
               </a:rPr>
-              <a:t>A gene on a reference</a:t>
+              <a:t>A gene you know, on a genome you don't</a:t>
             </a:r>
             <a:endParaRPr lang="en-US" sz="2200" dirty="0"/>
           </a:p>
@@ -7892,7 +7914,7 @@
                 <a:ea typeface="Calibri" pitchFamily="34" charset="-122"/>
                 <a:cs typeface="Calibri" pitchFamily="34" charset="-120"/>
               </a:rPr>
-              <a:t>This gene is on GRCh38 (or CHM13). Where is it on HG02015? And can I see its annotation there?</a:t>
+              <a:t>The same researcher is curating a gene on GRCh38, ClinVar and GWAS open, and wants to see it on one HPRC individual.</a:t>
             </a:r>
             <a:endParaRPr lang="en-US" sz="1900" dirty="0"/>
           </a:p>
@@ -7931,7 +7953,7 @@
                 <a:ea typeface="Calibri" pitchFamily="34" charset="-122"/>
                 <a:cs typeface="Calibri" pitchFamily="34" charset="-120"/>
               </a:rPr>
-              <a:t>the gene on HG02015 in ~100 ms, with the reference's annotation drawn around it</a:t>
+              <a:t>HG02015 in ~100 ms, with the reference's tracks drawn around the gene, over a chain built on the spot</a:t>
             </a:r>
             <a:endParaRPr lang="en-US" sz="1500" dirty="0"/>
           </a:p>
@@ -22876,7 +22898,7 @@
                 <a:ea typeface="Calibri" pitchFamily="34" charset="-122"/>
                 <a:cs typeface="Calibri" pitchFamily="34" charset="-120"/>
               </a:rPr>
-              <a:t>A sequence in hand</a:t>
+              <a:t>A sequence GRCh38 doesn't have</a:t>
             </a:r>
             <a:endParaRPr lang="en-US" sz="2200" dirty="0"/>
           </a:p>
@@ -22915,7 +22937,7 @@
                 <a:ea typeface="Calibri" pitchFamily="34" charset="-122"/>
                 <a:cs typeface="Calibri" pitchFamily="34" charset="-120"/>
               </a:rPr>
-              <a:t>Which haplotypes carry this sequence, and where on each? Then map it, and look at it.</a:t>
+              <a:t>A researcher assembles an insertion from long reads. It isn't in the reference. Which HPRC haplotypes carry it, and what does it look like there?</a:t>
             </a:r>
             <a:endParaRPr lang="en-US" sz="1900" dirty="0"/>
           </a:p>
@@ -22993,7 +23015,7 @@
                 <a:ea typeface="Calibri" pitchFamily="34" charset="-122"/>
                 <a:cs typeface="Calibri" pitchFamily="34" charset="-120"/>
               </a:rPr>
-              <a:t>BLAT, one assembly at a time</a:t>
+              <a:t>BLAT: one assembly at a time, blind to the graph</a:t>
             </a:r>
             <a:endParaRPr lang="en-US" sz="2400" dirty="0"/>
           </a:p>
@@ -23147,7 +23169,7 @@
                 <a:ea typeface="Calibri" pitchFamily="34" charset="-122"/>
                 <a:cs typeface="Calibri" pitchFamily="34" charset="-120"/>
               </a:rPr>
-              <a:t>A gene on a reference</a:t>
+              <a:t>A gene you know, on a genome you don't</a:t>
             </a:r>
             <a:endParaRPr lang="en-US" sz="2200" dirty="0"/>
           </a:p>
@@ -23186,7 +23208,7 @@
                 <a:ea typeface="Calibri" pitchFamily="34" charset="-122"/>
                 <a:cs typeface="Calibri" pitchFamily="34" charset="-120"/>
               </a:rPr>
-              <a:t>This gene is on GRCh38 (or CHM13). Where is it on HG02015? And can I see its annotation there?</a:t>
+              <a:t>The same researcher is curating a gene on GRCh38, ClinVar and GWAS open, and wants to see it on one HPRC individual.</a:t>
             </a:r>
             <a:endParaRPr lang="en-US" sz="1900" dirty="0"/>
           </a:p>
@@ -23264,7 +23286,7 @@
                 <a:ea typeface="Calibri" pitchFamily="34" charset="-122"/>
                 <a:cs typeface="Calibri" pitchFamily="34" charset="-120"/>
               </a:rPr>
-              <a:t>56 chain pairs; only the haplotype's own tracks</a:t>
+              <a:t>QuickLift: only where a chain already exists</a:t>
             </a:r>
             <a:endParaRPr lang="en-US" sz="2400" dirty="0"/>
           </a:p>
@@ -25531,7 +25553,7 @@
                 <a:ea typeface="Calibri" pitchFamily="34" charset="-122"/>
                 <a:cs typeface="Calibri" pitchFamily="34" charset="-120"/>
               </a:rPr>
-              <a:t>Story 1: one sequence, every haplotype carrying it</a:t>
+              <a:t>Story 1: paste the insertion, see who carries it</a:t>
             </a:r>
             <a:endParaRPr lang="en-US" sz="3200" dirty="0"/>
           </a:p>

</xml_diff>

<commit_message>
Talk: existing tools need compute and a terminal, not 'no tools'
</commit_message>
<xml_diff>
--- a/talk/HPRC2026_talk.pptx
+++ b/talk/HPRC2026_talk.pptx
@@ -2240,7 +2240,7 @@
               <a:t>[0:15-1:00]
 HPRC release 2 is the most complete picture of human variation we have: 464 haplotypes, in one graph. Two of those haplotypes, GRCh38 and CHM13, carry almost everything we know about the human genome: the gene models, the clinical variants, the regulatory annotation, and everyone's own tracks.
 (pause)
-A scientist can open any of the 464 assemblies today. What they cannot do is ask where their sequence lives across them, or take a locus they know on GRCh38 and see it, with its annotation, on one of the new haplotypes. This talk is about closing that gap.</a:t>
+The tools to work with the graph exist: vg giraffe maps to it, odgi and the r-index query it, halLiftover and impg move coordinates across it. But every one of them wants a large index on disk, real compute, and a command-line workflow that takes time to set up and time to run. A clinician, or a researcher outside a genomics group, never gets past that step. So in practice release 2 is browsed, one assembly at a time, and the graph itself goes unused. This talk is about removing that barrier.</a:t>
             </a:r>
             <a:endParaRPr lang="en-US" dirty="0"/>
           </a:p>
@@ -2593,11 +2593,11 @@
             <a:r>
               <a:rPr lang="en-US" dirty="0"/>
               <a:t>[1:00-1:55]
-Concretely, three things a scientist cannot yet do with release 2, interactively.
-Place a sequence across haplotypes: given a sequence, which of the 464 carry it, where, and what does the region look like on each? Search today works one assembly at a time.
-Move a locus onto a haplotype: take coordinates known on GRCh38 or CHM13 to an arbitrary release 2 haplotype. Pairwise lift-over exists for a handful of assembly pairs, not for 464.
-And bring the annotation along: see the reference's gene models, ClinVar, GWAS, or your own tracks on a release 2 haplotype. Each assembly has its own CAT and Liftoff genes, and nothing else follows.
-The graph already aligns all 464 haplotypes. Interactive access to that alignment is what has been missing.</a:t>
+Concretely, three things release 2 can already do, but only from the command line.
+Place a sequence across haplotypes: which of the 464 carry it, where, and what does each region look like? Today that is a giraffe index, a mapping run, and a terminal session before the first answer.
+Move a locus onto a haplotype: take coordinates known on GRCh38 or CHM13 to an arbitrary release 2 haplotype. Today that is halLiftover or impg over the whole alignment, per request, or a ready-made chain for the handful of pairs that have one.
+And bring the annotation along: see the reference's gene models, ClinVar, GWAS, or your own tracks on a release 2 haplotype. Today you lift every track yourself, per haplotype, before anyone can look.
+None of this is impossible. The graph already holds the answers. Reaching them takes compute, disk, and bioinformatics expertise that most clinicians and many researchers do not have, and time that even the experts would rather spend elsewhere.</a:t>
             </a:r>
             <a:endParaRPr lang="en-US" dirty="0"/>
           </a:p>
@@ -2689,7 +2689,7 @@
 I will follow two use cases through the rest of the talk.
 Use case 1, sequence search. A researcher has a sequence that is not in GRCh38: an insertion assembled from a sample, a probe, a contig. Which release 2 haplotypes carry it, and where on each?
 Use case 2, coordinate translation. A researcher knows a gene on GRCh38 or CHM13 and wants to see it, with its annotation, on a specific release 2 haplotype.
-Today the first is not available interactively at all, and the second only for the few assembly pairs that happen to have a chain. Both are shown live on the release 2 graph in this talk.</a:t>
+Today the first means a giraffe index and a terminal session; the second, a ready-made chain for a few assembly pairs and a halLiftover run for every other one. Both are shown live, in a web page, on the release 2 graph in this talk.</a:t>
             </a:r>
             <a:endParaRPr lang="en-US" dirty="0"/>
           </a:p>
@@ -21298,7 +21298,7 @@
                 <a:ea typeface="Calibri" pitchFamily="34" charset="-122"/>
                 <a:cs typeface="Calibri" pitchFamily="34" charset="-120"/>
               </a:rPr>
-              <a:t>Release 2 is the most complete picture of human variation we have. A scientist can open any of these assemblies today.</a:t>
+              <a:t>Release 2 is the most complete picture of human variation we have, and the tools to work with it exist.</a:t>
             </a:r>
             <a:endParaRPr lang="en-US" sz="2100" dirty="0"/>
           </a:p>
@@ -21312,8 +21312,8 @@
         </p:nvSpPr>
         <p:spPr>
           <a:xfrm>
-            <a:off x="6400800" y="5074920"/>
-            <a:ext cx="5212080" cy="1097280"/>
+            <a:off x="6400800" y="4937760"/>
+            <a:ext cx="5212080" cy="1280160"/>
           </a:xfrm>
           <a:prstGeom prst="rect">
             <a:avLst/>
@@ -21337,7 +21337,7 @@
                 <a:ea typeface="Calibri" pitchFamily="34" charset="-122"/>
                 <a:cs typeface="Calibri" pitchFamily="34" charset="-120"/>
               </a:rPr>
-              <a:t>What they cannot do is ask where a sequence lives across them, or carry what we know from GRCh38 onto one.</a:t>
+              <a:t>Every one of them needs a large index, real compute, and a command-line workflow. Most clinicians and many researchers never get past that.</a:t>
             </a:r>
             <a:endParaRPr lang="en-US" sz="2100" dirty="0"/>
           </a:p>
@@ -22981,7 +22981,7 @@
                 <a:ea typeface="Calibri" pitchFamily="34" charset="-122"/>
                 <a:cs typeface="Calibri" pitchFamily="34" charset="-120"/>
               </a:rPr>
-              <a:t>Three things a scientist cannot yet do with release 2</a:t>
+              <a:t>Possible on release 2, only in a terminal</a:t>
             </a:r>
             <a:endParaRPr lang="en-US" sz="3200" dirty="0"/>
           </a:p>
@@ -23174,7 +23174,7 @@
                 <a:ea typeface="Calibri" pitchFamily="34" charset="-122"/>
                 <a:cs typeface="Calibri" pitchFamily="34" charset="-120"/>
               </a:rPr>
-              <a:t>Given a sequence, learn which of the 464 haplotypes carry it, where, and what the region looks like on each. Search today works one assembly at a time.</a:t>
+              <a:t>Which of the 464 haplotypes carry a sequence, where, and what does each region look like? Today: a giraffe index, a mapping run, and a terminal session before the first answer.</a:t>
             </a:r>
             <a:endParaRPr lang="en-US" sz="1600" dirty="0"/>
           </a:p>
@@ -23328,7 +23328,7 @@
                 <a:ea typeface="Calibri" pitchFamily="34" charset="-122"/>
                 <a:cs typeface="Calibri" pitchFamily="34" charset="-120"/>
               </a:rPr>
-              <a:t>Take coordinates known on GRCh38 or CHM13 to an arbitrary release 2 haplotype. Pairwise lift-over exists for a handful of assembly pairs, not for 464.</a:t>
+              <a:t>Take coordinates known on GRCh38 or CHM13 to an arbitrary release 2 haplotype. Today: halLiftover or impg over the whole alignment, per request, or a ready-made chain for a handful of pairs.</a:t>
             </a:r>
             <a:endParaRPr lang="en-US" sz="1600" dirty="0"/>
           </a:p>
@@ -23482,7 +23482,7 @@
                 <a:ea typeface="Calibri" pitchFamily="34" charset="-122"/>
                 <a:cs typeface="Calibri" pitchFamily="34" charset="-120"/>
               </a:rPr>
-              <a:t>See the reference's gene models, ClinVar, GWAS or one's own tracks on a release 2 haplotype. Each assembly has its own CAT and Liftoff genes; nothing else follows.</a:t>
+              <a:t>See the reference's gene models, ClinVar, GWAS or one's own tracks on a release 2 haplotype. Today: lift every track yourself, per haplotype, before anyone can look.</a:t>
             </a:r>
             <a:endParaRPr lang="en-US" sz="1600" dirty="0"/>
           </a:p>
@@ -23521,7 +23521,7 @@
                 <a:ea typeface="Calibri" pitchFamily="34" charset="-122"/>
                 <a:cs typeface="Calibri" pitchFamily="34" charset="-120"/>
               </a:rPr>
-              <a:t>The graph already aligns all 464 haplotypes. Interactive access to that alignment is what has been missing.</a:t>
+              <a:t>The graph already holds the answers. Reaching them takes resources and expertise most clinicians and many researchers do not have.</a:t>
             </a:r>
             <a:endParaRPr lang="en-US" sz="2000" dirty="0"/>
           </a:p>
@@ -23902,7 +23902,7 @@
                 <a:ea typeface="Calibri" pitchFamily="34" charset="-122"/>
                 <a:cs typeface="Calibri" pitchFamily="34" charset="-120"/>
               </a:rPr>
-              <a:t>not available interactively</a:t>
+              <a:t>a large index and a terminal</a:t>
             </a:r>
             <a:endParaRPr lang="en-US" sz="2200" dirty="0"/>
           </a:p>
@@ -24173,7 +24173,7 @@
                 <a:ea typeface="Calibri" pitchFamily="34" charset="-122"/>
                 <a:cs typeface="Calibri" pitchFamily="34" charset="-120"/>
               </a:rPr>
-              <a:t>only for the few pairs with a chain</a:t>
+              <a:t>a few chains; a script for the rest</a:t>
             </a:r>
             <a:endParaRPr lang="en-US" sz="2200" dirty="0"/>
           </a:p>

</xml_diff>

<commit_message>
Talk: tag-array slide reduced to three points tied to the tools
</commit_message>
<xml_diff>
--- a/talk/HPRC2026_talk.pptx
+++ b/talk/HPRC2026_talk.pptx
@@ -1336,7 +1336,7 @@
           <a:p>
             <a:r>
               <a:rPr lang="en-US" dirty="0"/>
-              <a:t>[7:30-8:05]
+              <a:t>[7:10-7:45]
 What this enables on release 2: one search across all 464 haplotypes instead of one assembly at a time; sequences absent from the reference are found on the haplotypes that carry them, together with how many carry them; and any carrier can be opened with the sequence as a track, with another carrier costing no remapping.
 One detail this room will notice: MAPQ is zero by design. In a graph where every locus exists hundreds of times, mapping quality carries no information; per-haplotype identity and coverage replace it.</a:t>
             </a:r>
@@ -1426,7 +1426,7 @@
           <a:p>
             <a:r>
               <a:rPr lang="en-US" dirty="0"/>
-              <a:t>[8:05-8:40]
+              <a:t>[7:45-8:20]
 Use case 2: a gene known on a reference, on a specific release 2 haplotype.
 Moving a locus between assemblies today relies on a pairwise chain. The Genome Browser can draw one assembly's tracks on another, but only over a prebuilt chain between the two, and chains are built on request, one pair at a time. 464 haplotypes are more than two hundred thousand pairs; chains exist for fifty-six of them. For an arbitrary release 2 haplotype, such as HG02015, no chain exists.
 The graph already contains the alignment for every pair. It has to be usable on demand, and that is exactly what the walk I showed produces.</a:t>
@@ -1517,7 +1517,7 @@
           <a:p>
             <a:r>
               <a:rPr lang="en-US" dirty="0"/>
-              <a:t>[8:40-10:20]  Start the recording; slow down at the landing.
+              <a:t>[8:20-10:00]  Start the recording; slow down at the landing.
 Now the same request on the release 2 graph. Source: the gene as known on the reference, here HLA-DMA on CHM13, ten kilobases on chromosome 6; GRCh38 is a path in this graph too, so it works identically as the source. Target: HG02015 paternal, chosen from all 464; the picker can be restricted to haplotypes that contain the region.
 Translated in about a hundred milliseconds, covering a hundred percent of bases.
 Opening the result is the part I care about most. HG02015 has its own CAT and Liftoff genes from release 2. What it does not have is everything that exists once, on one reference: ClinVar, the GWAS catalog, ENCODE, a lab's own tracks. Here they are, drawn at their translated positions, with the differences between the two assemblies marked.
@@ -1609,7 +1609,7 @@
           <a:p>
             <a:r>
               <a:rPr lang="en-US" dirty="0"/>
-              <a:t>[10:20-10:55]
+              <a:t>[10:00-10:35]
 Before, a locus could be moved only between assembly pairs with a prebuilt chain, and a release 2 haplotype without one showed only its own tracks. Now any of the 464 haplotypes can be the target, from GRCh38 or CHM13, in about a hundred milliseconds; the reference's tracks are drawn there over an alignment built for that region, with the differences marked.
 The thousands of tracks that exist once, on one reference, will never be rebuilt 464 times. With this, any release 2 haplotype can borrow them for the region under study.</a:t>
             </a:r>
@@ -1699,7 +1699,7 @@
           <a:p>
             <a:r>
               <a:rPr lang="en-US" dirty="0"/>
-              <a:t>[10:55-11:35]
+              <a:t>[10:35-11:15]
 Who is this for? For clinicians and curators: is this insertion private to my patient, or carried by HPRC individuals, and which ones? ClinVar and GWAS context on the haplotype that actually carries the patient's allele. And the complex loci where one reference misleads: HLA, KIR, CYP2D6, LPA, SMN, seen on many haplotypes with the reference annotation drawn there.
 For researchers and graph builders: place contigs, probes, primers or guide RNAs on every haplotype at once; move any annotation, including your own tracks, onto any assembly; and inspect the graph's alignment itself, because the Alignment Differences track is the graph, drawn base by base.
 No pipeline, no download. A browser tab, and a sequence or a position.</a:t>
@@ -1790,7 +1790,7 @@
           <a:p>
             <a:r>
               <a:rPr lang="en-US" dirty="0"/>
-              <a:t>[11:35-12:20]
+              <a:t>[11:15-12:00]
 None of this matters if it takes a minute. So: is it fast enough to sit behind a web page?
 Exon-scale intervals translate in about twenty milliseconds, a ten-kilobase gene in about a tenth of a second, a hundred kilobases in under a second, a megabase in about four.
 And it serves many people at once: throughput goes from six to sixty queries a second and saturates around eight cores. Read that as "one box serves about sixty queries a second", not as perfect scaling; the single-thread number was warm-up-limited.</a:t>
@@ -1881,7 +1881,7 @@
           <a:p>
             <a:r>
               <a:rPr lang="en-US" dirty="0"/>
-              <a:t>[12:20-13:00]
+              <a:t>[12:00-12:40]
 So, the two use cases. Sequence search: every carrying haplotype found in seconds, and the sequence viewed as a track on any of them. Coordinate translation: any of the 464 haplotypes as the target in about a hundred milliseconds, with the reference's annotation drawn there.
 Release 2 becomes something a scientist can query, not only browse. The next step is the public UCSC Genome Browser. It is available on the development browser now; bring us your hardest region.
 (Advance to thanks. Let it breathe. Then questions.)</a:t>
@@ -1972,7 +1972,7 @@
           <a:p>
             <a:r>
               <a:rPr lang="en-US" dirty="0"/>
-              <a:t>[13:00-13:15]
+              <a:t>[12:40-12:55]
 None of this was mine alone: Jouni Sirén, Benedict Paten, and a lot of help from the Computational Genomics Lab and the Genome Browser team. Thank you. Questions.</a:t>
             </a:r>
             <a:endParaRPr lang="en-US" dirty="0"/>
@@ -2959,11 +2959,10 @@
           <a:p>
             <a:r>
               <a:rPr lang="en-US" dirty="0"/>
-              <a:t>[3:50-4:50]
-Here is the whole idea on a toy graph. Three haplotypes, one BWT over their sequences. The tag array runs alongside the BWT: for every BWT position, the graph node and offset it came from.
-A query is two steps. The r-index finds the BWT interval for a pattern, exactly as an FM-index would. Then two rank queries on the run-length tag structure return the distinct graph positions in that interval. No scan, no decompression, no redundancy: one hit per graph position, however many haplotypes share it.
-It stays small because similar suffixes sit together, so tags come in long runs: from v1.1 to v2.0 the sequence grew fivefold and the tag runs only doubled. We build it per chromosome and merge through the multi-string BWT. For release 2: 464 haplotypes, 2.6 terabases, 26 billion tag runs, 149 gigabytes, plus a 23 gigabyte sampled tag array that serves coordinate translation.
-Notice what is missing: nothing anywhere says CHM13-to-HG02015. That is what makes any-to-any translation across the 464 haplotypes possible.</a:t>
+              <a:t>[3:50-4:30]
+This is the idea on a toy graph, and it is all you need for the rest of the talk. Three haplotypes, indexed together. Alongside the index sits the tag array: for every position, the graph node it came from.
+Three consequences. One index holds all 464 haplotypes, so a sequence is found once, however many haplotypes carry it. Every match knows its node, so a hit is a position in the graph, not a line in one assembly. And every node knows its haplotypes, so we can ask who passes through a node and get each haplotype with its own coordinate. That last one is what moves a locus from one haplotype to another.
+Notice what is missing: nothing anywhere says CHM13-to-HG02015. There is no pairwise index, which is why any of the 464 can be translated to any other. The details are in the paper; I am happy to go into them in questions.</a:t>
             </a:r>
             <a:endParaRPr lang="en-US" dirty="0"/>
           </a:p>
@@ -3051,7 +3050,7 @@
           <a:p>
             <a:r>
               <a:rPr lang="en-US" dirty="0"/>
-              <a:t>[4:50-6:10]
+              <a:t>[4:30-5:50]
 With that one property in hand, translating a region stops being a lookup and becomes a walk.
 (1) Find the query interval's nodes on the source haplotype's path.
 (2) At those nodes, ask the tag arrays who else is standing here. Every haplotype comes back at once.
@@ -3145,7 +3144,7 @@
           <a:p>
             <a:r>
               <a:rPr lang="en-US" dirty="0"/>
-              <a:t>[6:10-7:30]  Start the recording; narrate over it.
+              <a:t>[5:50-7:10]  Start the recording; narrate over it.
 Use case 1: a sequence that is not in the reference. This is the Pangenome Mapping page.
 The sequence is pasted and mapped once, to the whole release 2 graph, with vg giraffe, in a few seconds. The result is something no single-assembly search can give: exactly two of the 464 haplotypes carry this sequence, HG01167 hap1 and HG04157 paternal, and GRCh38 is not one of them. They are ranked by identity, with coverage beside it.
 Selecting HG01167 opens it in the browser: the sequence is drawn as a track with base-level differences, in the context of that haplotype's own annotation. Selecting a different carrier re-uses the same alignment; nothing is remapped.</a:t>
@@ -25540,7 +25539,7 @@
                 <a:ea typeface="Calibri" pitchFamily="34" charset="-122"/>
                 <a:cs typeface="Calibri" pitchFamily="34" charset="-120"/>
               </a:rPr>
-              <a:t>Tag arrays: every BWT position knows its node</a:t>
+              <a:t>Tag arrays: an index that knows the graph</a:t>
             </a:r>
             <a:endParaRPr lang="en-US" sz="3200" dirty="0"/>
           </a:p>
@@ -25681,7 +25680,7 @@
                 <a:ea typeface="Calibri" pitchFamily="34" charset="-122"/>
                 <a:cs typeface="Calibri" pitchFamily="34" charset="-120"/>
               </a:rPr>
-              <a:t>Query</a:t>
+              <a:t>One index, all 464 haplotypes</a:t>
             </a:r>
             <a:endParaRPr lang="en-US" sz="1800" dirty="0"/>
           </a:p>
@@ -25720,7 +25719,7 @@
                 <a:ea typeface="Calibri" pitchFamily="34" charset="-122"/>
                 <a:cs typeface="Calibri" pitchFamily="34" charset="-120"/>
               </a:rPr>
-              <a:t>The r-index finds the BWT interval for a pattern; two rank queries on the run-length tag structure return the distinct graph positions in it. No scan, no redundancy.</a:t>
+              <a:t>Every haplotype's sequence, indexed together. A sequence is found once, however many haplotypes carry it.</a:t>
             </a:r>
             <a:endParaRPr lang="en-US" sz="1500" dirty="0"/>
           </a:p>
@@ -25759,7 +25758,7 @@
                 <a:ea typeface="Calibri" pitchFamily="34" charset="-122"/>
                 <a:cs typeface="Calibri" pitchFamily="34" charset="-120"/>
               </a:rPr>
-              <a:t>Runs, not positions</a:t>
+              <a:t>Every match knows its node</a:t>
             </a:r>
             <a:endParaRPr lang="en-US" sz="1800" dirty="0"/>
           </a:p>
@@ -25798,7 +25797,7 @@
                 <a:ea typeface="Calibri" pitchFamily="34" charset="-122"/>
                 <a:cs typeface="Calibri" pitchFamily="34" charset="-120"/>
               </a:rPr>
-              <a:t>Similar suffixes sit together, so tags come in long runs. Bases grew 5x from v1.1 to v2.0; tag runs only 2x.</a:t>
+              <a:t>Each position in the index is tagged with its place in the graph. A hit is a graph position, not a line in one assembly.</a:t>
             </a:r>
             <a:endParaRPr lang="en-US" sz="1500" dirty="0"/>
           </a:p>
@@ -25837,7 +25836,7 @@
                 <a:ea typeface="Calibri" pitchFamily="34" charset="-122"/>
                 <a:cs typeface="Calibri" pitchFamily="34" charset="-120"/>
               </a:rPr>
-              <a:t>Built at HPRC scale</a:t>
+              <a:t>Every node knows its haplotypes</a:t>
             </a:r>
             <a:endParaRPr lang="en-US" sz="1800" dirty="0"/>
           </a:p>
@@ -25876,7 +25875,7 @@
                 <a:ea typeface="Calibri" pitchFamily="34" charset="-122"/>
                 <a:cs typeface="Calibri" pitchFamily="34" charset="-120"/>
               </a:rPr>
-              <a:t>Per chromosome, merged through the multi-string BWT. v2.0: 464 haplotypes, 2.6 Tbp, 26 billion tag runs, 149 GiB; a 23 GiB sampled tag array serves translation.</a:t>
+              <a:t>Ask a node who passes through it and get every haplotype, with its own coordinate. That is what moves a locus from one haplotype to another.</a:t>
             </a:r>
             <a:endParaRPr lang="en-US" sz="1500" dirty="0"/>
           </a:p>
@@ -25890,7 +25889,7 @@
         </p:nvSpPr>
         <p:spPr>
           <a:xfrm>
-            <a:off x="8046720" y="5852160"/>
+            <a:off x="8046720" y="5760720"/>
             <a:ext cx="3596335" cy="548640"/>
           </a:xfrm>
           <a:prstGeom prst="roundRect">
@@ -25917,7 +25916,7 @@
         </p:nvSpPr>
         <p:spPr>
           <a:xfrm>
-            <a:off x="8046720" y="5852160"/>
+            <a:off x="8046720" y="5760720"/>
             <a:ext cx="3596335" cy="548640"/>
           </a:xfrm>
           <a:prstGeom prst="rect">
@@ -25934,7 +25933,7 @@
               <a:buNone/>
             </a:pPr>
             <a:r>
-              <a:rPr lang="en-US" sz="1600" b="1" dirty="0">
+              <a:rPr lang="en-US" sz="1400" b="1" dirty="0">
                 <a:solidFill>
                   <a:srgbClr val="003C6C"/>
                 </a:solidFill>
@@ -25942,9 +25941,9 @@
                 <a:ea typeface="Calibri" pitchFamily="34" charset="-122"/>
                 <a:cs typeface="Calibri" pitchFamily="34" charset="-120"/>
               </a:rPr>
-              <a:t>No pairwise index anywhere.</a:t>
+              <a:t>Any haplotype to any other. No pairwise index.</a:t>
             </a:r>
-            <a:endParaRPr lang="en-US" sz="1600" dirty="0"/>
+            <a:endParaRPr lang="en-US" sz="1400" dirty="0"/>
           </a:p>
         </p:txBody>
       </p:sp>
@@ -25956,7 +25955,7 @@
         </p:nvSpPr>
         <p:spPr>
           <a:xfrm>
-            <a:off x="548640" y="6217920"/>
+            <a:off x="548640" y="6400800"/>
             <a:ext cx="11094415" cy="365760"/>
           </a:xfrm>
           <a:prstGeom prst="rect">

</xml_diff>

<commit_message>
Talk: translation figure builds up step by step across the four slides
</commit_message>
<xml_diff>
--- a/talk/HPRC2026_talk.pptx
+++ b/talk/HPRC2026_talk.pptx
@@ -4262,7 +4262,7 @@
       </p:sp>
       <p:pic>
         <p:nvPicPr>
-          <p:cNvPr id="5" name="Image 0" descr="/Users/seeskand/Documents/HPRC/2026/hprc_2026_poster/talk/figures/translation.png">    </p:cNvPr>
+          <p:cNvPr id="5" name="Image 0" descr="/Users/seeskand/Documents/HPRC/2026/hprc_2026_poster/talk/figures/translation_step3.png">    </p:cNvPr>
           <p:cNvPicPr>
             <a:picLocks noChangeAspect="1"/>
           </p:cNvPicPr>
@@ -4277,7 +4277,7 @@
         <p:spPr>
           <a:xfrm>
             <a:off x="548640" y="1417320"/>
-            <a:ext cx="6949440" cy="4428944"/>
+            <a:ext cx="6949440" cy="4516749"/>
           </a:xfrm>
           <a:prstGeom prst="rect">
             <a:avLst/>
@@ -4750,7 +4750,7 @@
       </p:sp>
       <p:pic>
         <p:nvPicPr>
-          <p:cNvPr id="5" name="Image 0" descr="/Users/seeskand/Documents/HPRC/2026/hprc_2026_poster/talk/figures/translation.png">    </p:cNvPr>
+          <p:cNvPr id="5" name="Image 0" descr="/Users/seeskand/Documents/HPRC/2026/hprc_2026_poster/talk/figures/translation_step4.png">    </p:cNvPr>
           <p:cNvPicPr>
             <a:picLocks noChangeAspect="1"/>
           </p:cNvPicPr>
@@ -4765,7 +4765,7 @@
         <p:spPr>
           <a:xfrm>
             <a:off x="548640" y="1417320"/>
-            <a:ext cx="6949440" cy="4428944"/>
+            <a:ext cx="6949440" cy="4516749"/>
           </a:xfrm>
           <a:prstGeom prst="rect">
             <a:avLst/>
@@ -28143,7 +28143,7 @@
       </p:sp>
       <p:pic>
         <p:nvPicPr>
-          <p:cNvPr id="5" name="Image 0" descr="/Users/seeskand/Documents/HPRC/2026/hprc_2026_poster/talk/figures/translation.png">    </p:cNvPr>
+          <p:cNvPr id="5" name="Image 0" descr="/Users/seeskand/Documents/HPRC/2026/hprc_2026_poster/talk/figures/translation_step1.png">    </p:cNvPr>
           <p:cNvPicPr>
             <a:picLocks noChangeAspect="1"/>
           </p:cNvPicPr>
@@ -28158,7 +28158,7 @@
         <p:spPr>
           <a:xfrm>
             <a:off x="548640" y="1417320"/>
-            <a:ext cx="6949440" cy="4428944"/>
+            <a:ext cx="6949440" cy="4516749"/>
           </a:xfrm>
           <a:prstGeom prst="rect">
             <a:avLst/>
@@ -28421,7 +28421,7 @@
       </p:sp>
       <p:pic>
         <p:nvPicPr>
-          <p:cNvPr id="5" name="Image 0" descr="/Users/seeskand/Documents/HPRC/2026/hprc_2026_poster/talk/figures/translation.png">    </p:cNvPr>
+          <p:cNvPr id="5" name="Image 0" descr="/Users/seeskand/Documents/HPRC/2026/hprc_2026_poster/talk/figures/translation_step2.png">    </p:cNvPr>
           <p:cNvPicPr>
             <a:picLocks noChangeAspect="1"/>
           </p:cNvPicPr>
@@ -28436,7 +28436,7 @@
         <p:spPr>
           <a:xfrm>
             <a:off x="548640" y="1417320"/>
-            <a:ext cx="6949440" cy="4428944"/>
+            <a:ext cx="6949440" cy="4516749"/>
           </a:xfrm>
           <a:prstGeom prst="rect">
             <a:avLst/>

</xml_diff>

<commit_message>
Talk: slide 5 bridges from the use cases to the index that makes them interactive
</commit_message>
<xml_diff>
--- a/talk/HPRC2026_talk.pptx
+++ b/talk/HPRC2026_talk.pptx
@@ -3051,9 +3051,10 @@
             <a:r>
               <a:rPr lang="en-US" dirty="0"/>
               <a:t>[2:35-3:10]
-What we built, in one picture. One index over the HPRC release 2 graph, a tag-array index, which I will explain in a moment. Every position in the BWT knows its graph position, and every node knows every haplotype crossing it.
-Two capabilities sit on top of it. Sequence search: a sequence is mapped once, to the whole graph, every haplotype that carries it is reported, and the hit can be viewed on any of them. Coordinate translation: a locus on any haplotype is translated to any other, and the source's annotation is drawn there over an alignment built on demand.
-Both run inside the UCSC Genome Browser, on the release 2 graph, today.</a:t>
+So what would it take to do this in a web page, where a user waits a second and not an hour? Both use cases come down to two questions the index underneath has to answer in milliseconds.
+Where in the graph is this sequence? Asked once, against all 464 haplotypes, not 464 times against one assembly each, and for any sequence, of any length.
+And: who passes through this node, and where? Answered for any haplotype against any other, without a pairwise alignment prepared in advance for each of the more than two hundred thousand pairs.
+Nothing that existed answered both, at that scale, at interactive speed. So before any tool, we built the index: a tag array index over the release 2 graph. Built once. Everything you will see in the rest of this talk is a query against it. Let me spend three slides on what it is.</a:t>
             </a:r>
             <a:endParaRPr lang="en-US" dirty="0"/>
           </a:p>
@@ -26288,7 +26289,7 @@
                 <a:ea typeface="Calibri" pitchFamily="34" charset="-122"/>
                 <a:cs typeface="Calibri" pitchFamily="34" charset="-120"/>
               </a:rPr>
-              <a:t>Two capabilities on one index of the release 2 graph</a:t>
+              <a:t>Two questions, answered in milliseconds</a:t>
             </a:r>
             <a:endParaRPr lang="en-US" sz="3200" dirty="0"/>
           </a:p>
@@ -26341,15 +26342,40 @@
         </p:nvSpPr>
         <p:spPr>
           <a:xfrm>
-            <a:off x="548640" y="1508760"/>
-            <a:ext cx="11094415" cy="1234440"/>
+            <a:off x="548640" y="1417320"/>
+            <a:ext cx="5364328" cy="2514600"/>
           </a:xfrm>
           <a:prstGeom prst="roundRect">
             <a:avLst>
-              <a:gd name="adj" fmla="val 8889"/>
+              <a:gd name="adj" fmla="val 4364"/>
             </a:avLst>
           </a:prstGeom>
           <a:solidFill>
+            <a:srgbClr val="EDF1F6"/>
+          </a:solidFill>
+          <a:ln w="12700">
+            <a:solidFill>
+              <a:srgbClr val="DCE3EB"/>
+            </a:solidFill>
+            <a:prstDash val="solid"/>
+          </a:ln>
+        </p:spPr>
+      </p:sp>
+      <p:sp>
+        <p:nvSpPr>
+          <p:cNvPr id="5" name="Shape 3"/>
+          <p:cNvSpPr/>
+          <p:nvPr/>
+        </p:nvSpPr>
+        <p:spPr>
+          <a:xfrm>
+            <a:off x="868680" y="1737360"/>
+            <a:ext cx="731520" cy="731520"/>
+          </a:xfrm>
+          <a:prstGeom prst="ellipse">
+            <a:avLst/>
+          </a:prstGeom>
+          <a:solidFill>
             <a:srgbClr val="003C6C"/>
           </a:solidFill>
           <a:ln w="12700">
@@ -26360,16 +26386,347 @@
           </a:ln>
         </p:spPr>
       </p:sp>
-      <p:sp>
-        <p:nvSpPr>
-          <p:cNvPr id="5" name="Text 3"/>
+      <p:pic>
+        <p:nvPicPr>
+          <p:cNvPr id="6" name="Image 0" descr="preencoded.png">    </p:cNvPr>
+          <p:cNvPicPr>
+            <a:picLocks noChangeAspect="1"/>
+          </p:cNvPicPr>
+          <p:nvPr/>
+        </p:nvPicPr>
+        <p:blipFill>
+          <a:blip r:embed="rId1"/>
+          <a:stretch>
+            <a:fillRect/>
+          </a:stretch>
+        </p:blipFill>
+        <p:spPr>
+          <a:xfrm>
+            <a:off x="1058875" y="1927555"/>
+            <a:ext cx="351130" cy="351130"/>
+          </a:xfrm>
+          <a:prstGeom prst="rect">
+            <a:avLst/>
+          </a:prstGeom>
+        </p:spPr>
+      </p:pic>
+      <p:sp>
+        <p:nvSpPr>
+          <p:cNvPr id="7" name="Text 4"/>
           <p:cNvSpPr txBox="1"/>
           <p:nvPr/>
         </p:nvSpPr>
         <p:spPr>
           <a:xfrm>
-            <a:off x="548640" y="1618488"/>
-            <a:ext cx="11094415" cy="457200"/>
+            <a:off x="1828800" y="1783080"/>
+            <a:ext cx="3718408" cy="685800"/>
+          </a:xfrm>
+          <a:prstGeom prst="rect">
+            <a:avLst/>
+          </a:prstGeom>
+          <a:noFill/>
+          <a:ln/>
+        </p:spPr>
+        <p:txBody>
+          <a:bodyPr wrap="square" lIns="0" tIns="0" rIns="0" bIns="0" rtlCol="0" anchor="ctr"/>
+          <a:lstStyle/>
+          <a:p>
+            <a:pPr indent="0" marL="0">
+              <a:buNone/>
+            </a:pPr>
+            <a:r>
+              <a:rPr lang="en-US" sz="2000" b="1" dirty="0">
+                <a:solidFill>
+                  <a:srgbClr val="003C6C"/>
+                </a:solidFill>
+                <a:latin typeface="Calibri" pitchFamily="34" charset="0"/>
+                <a:ea typeface="Calibri" pitchFamily="34" charset="-122"/>
+                <a:cs typeface="Calibri" pitchFamily="34" charset="-120"/>
+              </a:rPr>
+              <a:t>Where in the graph is this sequence?</a:t>
+            </a:r>
+            <a:endParaRPr lang="en-US" sz="2000" dirty="0"/>
+          </a:p>
+        </p:txBody>
+      </p:sp>
+      <p:sp>
+        <p:nvSpPr>
+          <p:cNvPr id="8" name="Text 5"/>
+          <p:cNvSpPr txBox="1"/>
+          <p:nvPr/>
+        </p:nvSpPr>
+        <p:spPr>
+          <a:xfrm>
+            <a:off x="868680" y="2606040"/>
+            <a:ext cx="4724248" cy="1234440"/>
+          </a:xfrm>
+          <a:prstGeom prst="rect">
+            <a:avLst/>
+          </a:prstGeom>
+          <a:noFill/>
+          <a:ln/>
+        </p:spPr>
+        <p:txBody>
+          <a:bodyPr wrap="square" lIns="0" tIns="0" rIns="0" bIns="0" rtlCol="0" anchor="t"/>
+          <a:lstStyle/>
+          <a:p>
+            <a:pPr indent="0" marL="0">
+              <a:buNone/>
+            </a:pPr>
+            <a:r>
+              <a:rPr lang="en-US" sz="1700" dirty="0">
+                <a:solidFill>
+                  <a:srgbClr val="18293B"/>
+                </a:solidFill>
+                <a:latin typeface="Calibri" pitchFamily="34" charset="0"/>
+                <a:ea typeface="Calibri" pitchFamily="34" charset="-122"/>
+                <a:cs typeface="Calibri" pitchFamily="34" charset="-120"/>
+              </a:rPr>
+              <a:t>Asked once against all 464 haplotypes, not 464 times against one assembly each. Any sequence, any length.</a:t>
+            </a:r>
+            <a:endParaRPr lang="en-US" sz="1700" dirty="0"/>
+          </a:p>
+        </p:txBody>
+      </p:sp>
+      <p:sp>
+        <p:nvSpPr>
+          <p:cNvPr id="9" name="Shape 6"/>
+          <p:cNvSpPr/>
+          <p:nvPr/>
+        </p:nvSpPr>
+        <p:spPr>
+          <a:xfrm>
+            <a:off x="3230804" y="4023360"/>
+            <a:ext cx="0" cy="457200"/>
+          </a:xfrm>
+          <a:prstGeom prst="line">
+            <a:avLst/>
+          </a:prstGeom>
+          <a:noFill/>
+          <a:ln w="25400">
+            <a:solidFill>
+              <a:srgbClr val="003C6C"/>
+            </a:solidFill>
+            <a:prstDash val="solid"/>
+            <a:tailEnd type="triangle"/>
+          </a:ln>
+        </p:spPr>
+      </p:sp>
+      <p:sp>
+        <p:nvSpPr>
+          <p:cNvPr id="10" name="Shape 7"/>
+          <p:cNvSpPr/>
+          <p:nvPr/>
+        </p:nvSpPr>
+        <p:spPr>
+          <a:xfrm>
+            <a:off x="6278728" y="1417320"/>
+            <a:ext cx="5364328" cy="2514600"/>
+          </a:xfrm>
+          <a:prstGeom prst="roundRect">
+            <a:avLst>
+              <a:gd name="adj" fmla="val 4364"/>
+            </a:avLst>
+          </a:prstGeom>
+          <a:solidFill>
+            <a:srgbClr val="EDF1F6"/>
+          </a:solidFill>
+          <a:ln w="12700">
+            <a:solidFill>
+              <a:srgbClr val="DCE3EB"/>
+            </a:solidFill>
+            <a:prstDash val="solid"/>
+          </a:ln>
+        </p:spPr>
+      </p:sp>
+      <p:sp>
+        <p:nvSpPr>
+          <p:cNvPr id="11" name="Shape 8"/>
+          <p:cNvSpPr/>
+          <p:nvPr/>
+        </p:nvSpPr>
+        <p:spPr>
+          <a:xfrm>
+            <a:off x="6598768" y="1737360"/>
+            <a:ext cx="731520" cy="731520"/>
+          </a:xfrm>
+          <a:prstGeom prst="ellipse">
+            <a:avLst/>
+          </a:prstGeom>
+          <a:solidFill>
+            <a:srgbClr val="003C6C"/>
+          </a:solidFill>
+          <a:ln w="12700">
+            <a:solidFill>
+              <a:srgbClr val="003C6C"/>
+            </a:solidFill>
+            <a:prstDash val="solid"/>
+          </a:ln>
+        </p:spPr>
+      </p:sp>
+      <p:pic>
+        <p:nvPicPr>
+          <p:cNvPr id="12" name="Image 1" descr="preencoded.png">    </p:cNvPr>
+          <p:cNvPicPr>
+            <a:picLocks noChangeAspect="1"/>
+          </p:cNvPicPr>
+          <p:nvPr/>
+        </p:nvPicPr>
+        <p:blipFill>
+          <a:blip r:embed="rId2"/>
+          <a:stretch>
+            <a:fillRect/>
+          </a:stretch>
+        </p:blipFill>
+        <p:spPr>
+          <a:xfrm>
+            <a:off x="6788963" y="1927555"/>
+            <a:ext cx="351130" cy="351130"/>
+          </a:xfrm>
+          <a:prstGeom prst="rect">
+            <a:avLst/>
+          </a:prstGeom>
+        </p:spPr>
+      </p:pic>
+      <p:sp>
+        <p:nvSpPr>
+          <p:cNvPr id="13" name="Text 9"/>
+          <p:cNvSpPr txBox="1"/>
+          <p:nvPr/>
+        </p:nvSpPr>
+        <p:spPr>
+          <a:xfrm>
+            <a:off x="7558888" y="1783080"/>
+            <a:ext cx="3718408" cy="685800"/>
+          </a:xfrm>
+          <a:prstGeom prst="rect">
+            <a:avLst/>
+          </a:prstGeom>
+          <a:noFill/>
+          <a:ln/>
+        </p:spPr>
+        <p:txBody>
+          <a:bodyPr wrap="square" lIns="0" tIns="0" rIns="0" bIns="0" rtlCol="0" anchor="ctr"/>
+          <a:lstStyle/>
+          <a:p>
+            <a:pPr indent="0" marL="0">
+              <a:buNone/>
+            </a:pPr>
+            <a:r>
+              <a:rPr lang="en-US" sz="2000" b="1" dirty="0">
+                <a:solidFill>
+                  <a:srgbClr val="003C6C"/>
+                </a:solidFill>
+                <a:latin typeface="Calibri" pitchFamily="34" charset="0"/>
+                <a:ea typeface="Calibri" pitchFamily="34" charset="-122"/>
+                <a:cs typeface="Calibri" pitchFamily="34" charset="-120"/>
+              </a:rPr>
+              <a:t>Who passes through this node, and where?</a:t>
+            </a:r>
+            <a:endParaRPr lang="en-US" sz="2000" dirty="0"/>
+          </a:p>
+        </p:txBody>
+      </p:sp>
+      <p:sp>
+        <p:nvSpPr>
+          <p:cNvPr id="14" name="Text 10"/>
+          <p:cNvSpPr txBox="1"/>
+          <p:nvPr/>
+        </p:nvSpPr>
+        <p:spPr>
+          <a:xfrm>
+            <a:off x="6598768" y="2606040"/>
+            <a:ext cx="4724248" cy="1234440"/>
+          </a:xfrm>
+          <a:prstGeom prst="rect">
+            <a:avLst/>
+          </a:prstGeom>
+          <a:noFill/>
+          <a:ln/>
+        </p:spPr>
+        <p:txBody>
+          <a:bodyPr wrap="square" lIns="0" tIns="0" rIns="0" bIns="0" rtlCol="0" anchor="t"/>
+          <a:lstStyle/>
+          <a:p>
+            <a:pPr indent="0" marL="0">
+              <a:buNone/>
+            </a:pPr>
+            <a:r>
+              <a:rPr lang="en-US" sz="1700" dirty="0">
+                <a:solidFill>
+                  <a:srgbClr val="18293B"/>
+                </a:solidFill>
+                <a:latin typeface="Calibri" pitchFamily="34" charset="0"/>
+                <a:ea typeface="Calibri" pitchFamily="34" charset="-122"/>
+                <a:cs typeface="Calibri" pitchFamily="34" charset="-120"/>
+              </a:rPr>
+              <a:t>Answered for any haplotype against any other, without a pairwise alignment prepared for each of the 200,000+ pairs.</a:t>
+            </a:r>
+            <a:endParaRPr lang="en-US" sz="1700" dirty="0"/>
+          </a:p>
+        </p:txBody>
+      </p:sp>
+      <p:sp>
+        <p:nvSpPr>
+          <p:cNvPr id="15" name="Shape 11"/>
+          <p:cNvSpPr/>
+          <p:nvPr/>
+        </p:nvSpPr>
+        <p:spPr>
+          <a:xfrm>
+            <a:off x="8960891" y="4023360"/>
+            <a:ext cx="0" cy="457200"/>
+          </a:xfrm>
+          <a:prstGeom prst="line">
+            <a:avLst/>
+          </a:prstGeom>
+          <a:noFill/>
+          <a:ln w="25400">
+            <a:solidFill>
+              <a:srgbClr val="003C6C"/>
+            </a:solidFill>
+            <a:prstDash val="solid"/>
+            <a:tailEnd type="triangle"/>
+          </a:ln>
+        </p:spPr>
+      </p:sp>
+      <p:sp>
+        <p:nvSpPr>
+          <p:cNvPr id="16" name="Shape 12"/>
+          <p:cNvSpPr/>
+          <p:nvPr/>
+        </p:nvSpPr>
+        <p:spPr>
+          <a:xfrm>
+            <a:off x="548640" y="4572000"/>
+            <a:ext cx="11094415" cy="1325880"/>
+          </a:xfrm>
+          <a:prstGeom prst="roundRect">
+            <a:avLst>
+              <a:gd name="adj" fmla="val 8276"/>
+            </a:avLst>
+          </a:prstGeom>
+          <a:solidFill>
+            <a:srgbClr val="003C6C"/>
+          </a:solidFill>
+          <a:ln w="12700">
+            <a:solidFill>
+              <a:srgbClr val="003C6C"/>
+            </a:solidFill>
+            <a:prstDash val="solid"/>
+          </a:ln>
+        </p:spPr>
+      </p:sp>
+      <p:sp>
+        <p:nvSpPr>
+          <p:cNvPr id="17" name="Text 13"/>
+          <p:cNvSpPr txBox="1"/>
+          <p:nvPr/>
+        </p:nvSpPr>
+        <p:spPr>
+          <a:xfrm>
+            <a:off x="548640" y="4690872"/>
+            <a:ext cx="11094415" cy="502920"/>
           </a:xfrm>
           <a:prstGeom prst="rect">
             <a:avLst/>
@@ -26385,7 +26742,7 @@
               <a:buNone/>
             </a:pPr>
             <a:r>
-              <a:rPr lang="en-US" sz="2200" b="1" dirty="0">
+              <a:rPr lang="en-US" sz="2400" b="1" dirty="0">
                 <a:solidFill>
                   <a:srgbClr val="FFFFFF"/>
                 </a:solidFill>
@@ -26393,22 +26750,22 @@
                 <a:ea typeface="Calibri" pitchFamily="34" charset="-122"/>
                 <a:cs typeface="Calibri" pitchFamily="34" charset="-120"/>
               </a:rPr>
-              <a:t>Tag-array index over the HPRC release 2 graph</a:t>
+              <a:t>One index answers both: the tag array index</a:t>
             </a:r>
-            <a:endParaRPr lang="en-US" sz="2200" dirty="0"/>
+            <a:endParaRPr lang="en-US" sz="2400" dirty="0"/>
           </a:p>
         </p:txBody>
       </p:sp>
       <p:sp>
         <p:nvSpPr>
-          <p:cNvPr id="6" name="Text 4"/>
+          <p:cNvPr id="18" name="Text 14"/>
           <p:cNvSpPr txBox="1"/>
           <p:nvPr/>
         </p:nvSpPr>
         <p:spPr>
           <a:xfrm>
-            <a:off x="548640" y="2130552"/>
-            <a:ext cx="11094415" cy="365760"/>
+            <a:off x="548640" y="5257800"/>
+            <a:ext cx="11094415" cy="411480"/>
           </a:xfrm>
           <a:prstGeom prst="rect">
             <a:avLst/>
@@ -26432,365 +26789,9 @@
                 <a:ea typeface="Calibri" pitchFamily="34" charset="-122"/>
                 <a:cs typeface="Calibri" pitchFamily="34" charset="-120"/>
               </a:rPr>
-              <a:t>464 haplotypes  •  every BWT position knows its graph position  •  every node knows every haplotype crossing it</a:t>
+              <a:t>Built once over the release 2 graph. Everything in the rest of this talk is a query against it.</a:t>
             </a:r>
             <a:endParaRPr lang="en-US" sz="1600" dirty="0"/>
-          </a:p>
-        </p:txBody>
-      </p:sp>
-      <p:sp>
-        <p:nvSpPr>
-          <p:cNvPr id="7" name="Shape 5"/>
-          <p:cNvSpPr/>
-          <p:nvPr/>
-        </p:nvSpPr>
-        <p:spPr>
-          <a:xfrm>
-            <a:off x="3230804" y="2743200"/>
-            <a:ext cx="0" cy="457200"/>
-          </a:xfrm>
-          <a:prstGeom prst="line">
-            <a:avLst/>
-          </a:prstGeom>
-          <a:noFill/>
-          <a:ln w="25400">
-            <a:solidFill>
-              <a:srgbClr val="003C6C"/>
-            </a:solidFill>
-            <a:prstDash val="solid"/>
-            <a:tailEnd type="triangle"/>
-          </a:ln>
-        </p:spPr>
-      </p:sp>
-      <p:sp>
-        <p:nvSpPr>
-          <p:cNvPr id="8" name="Shape 6"/>
-          <p:cNvSpPr/>
-          <p:nvPr/>
-        </p:nvSpPr>
-        <p:spPr>
-          <a:xfrm>
-            <a:off x="548640" y="3200400"/>
-            <a:ext cx="5364328" cy="2651760"/>
-          </a:xfrm>
-          <a:prstGeom prst="roundRect">
-            <a:avLst>
-              <a:gd name="adj" fmla="val 4138"/>
-            </a:avLst>
-          </a:prstGeom>
-          <a:solidFill>
-            <a:srgbClr val="EDF1F6"/>
-          </a:solidFill>
-          <a:ln w="12700">
-            <a:solidFill>
-              <a:srgbClr val="DCE3EB"/>
-            </a:solidFill>
-            <a:prstDash val="solid"/>
-          </a:ln>
-        </p:spPr>
-      </p:sp>
-      <p:sp>
-        <p:nvSpPr>
-          <p:cNvPr id="9" name="Shape 7"/>
-          <p:cNvSpPr/>
-          <p:nvPr/>
-        </p:nvSpPr>
-        <p:spPr>
-          <a:xfrm>
-            <a:off x="868680" y="3520440"/>
-            <a:ext cx="731520" cy="731520"/>
-          </a:xfrm>
-          <a:prstGeom prst="ellipse">
-            <a:avLst/>
-          </a:prstGeom>
-          <a:solidFill>
-            <a:srgbClr val="003C6C"/>
-          </a:solidFill>
-          <a:ln w="12700">
-            <a:solidFill>
-              <a:srgbClr val="003C6C"/>
-            </a:solidFill>
-            <a:prstDash val="solid"/>
-          </a:ln>
-        </p:spPr>
-      </p:sp>
-      <p:pic>
-        <p:nvPicPr>
-          <p:cNvPr id="10" name="Image 0" descr="preencoded.png">    </p:cNvPr>
-          <p:cNvPicPr>
-            <a:picLocks noChangeAspect="1"/>
-          </p:cNvPicPr>
-          <p:nvPr/>
-        </p:nvPicPr>
-        <p:blipFill>
-          <a:blip r:embed="rId1"/>
-          <a:stretch>
-            <a:fillRect/>
-          </a:stretch>
-        </p:blipFill>
-        <p:spPr>
-          <a:xfrm>
-            <a:off x="1058875" y="3710635"/>
-            <a:ext cx="351130" cy="351130"/>
-          </a:xfrm>
-          <a:prstGeom prst="rect">
-            <a:avLst/>
-          </a:prstGeom>
-        </p:spPr>
-      </p:pic>
-      <p:sp>
-        <p:nvSpPr>
-          <p:cNvPr id="11" name="Text 8"/>
-          <p:cNvSpPr txBox="1"/>
-          <p:nvPr/>
-        </p:nvSpPr>
-        <p:spPr>
-          <a:xfrm>
-            <a:off x="1828800" y="3611880"/>
-            <a:ext cx="3718408" cy="502920"/>
-          </a:xfrm>
-          <a:prstGeom prst="rect">
-            <a:avLst/>
-          </a:prstGeom>
-          <a:noFill/>
-          <a:ln/>
-        </p:spPr>
-        <p:txBody>
-          <a:bodyPr wrap="square" lIns="0" tIns="0" rIns="0" bIns="0" rtlCol="0" anchor="t"/>
-          <a:lstStyle/>
-          <a:p>
-            <a:pPr indent="0" marL="0">
-              <a:buNone/>
-            </a:pPr>
-            <a:r>
-              <a:rPr lang="en-US" sz="2200" b="1" dirty="0">
-                <a:solidFill>
-                  <a:srgbClr val="003C6C"/>
-                </a:solidFill>
-                <a:latin typeface="Calibri" pitchFamily="34" charset="0"/>
-                <a:ea typeface="Calibri" pitchFamily="34" charset="-122"/>
-                <a:cs typeface="Calibri" pitchFamily="34" charset="-120"/>
-              </a:rPr>
-              <a:t>Sequence search</a:t>
-            </a:r>
-            <a:endParaRPr lang="en-US" sz="2200" dirty="0"/>
-          </a:p>
-        </p:txBody>
-      </p:sp>
-      <p:sp>
-        <p:nvSpPr>
-          <p:cNvPr id="12" name="Text 9"/>
-          <p:cNvSpPr txBox="1"/>
-          <p:nvPr/>
-        </p:nvSpPr>
-        <p:spPr>
-          <a:xfrm>
-            <a:off x="868680" y="4389120"/>
-            <a:ext cx="4724248" cy="1371600"/>
-          </a:xfrm>
-          <a:prstGeom prst="rect">
-            <a:avLst/>
-          </a:prstGeom>
-          <a:noFill/>
-          <a:ln/>
-        </p:spPr>
-        <p:txBody>
-          <a:bodyPr wrap="square" lIns="0" tIns="0" rIns="0" bIns="0" rtlCol="0" anchor="t"/>
-          <a:lstStyle/>
-          <a:p>
-            <a:pPr indent="0" marL="0">
-              <a:buNone/>
-            </a:pPr>
-            <a:r>
-              <a:rPr lang="en-US" sz="1700" dirty="0">
-                <a:solidFill>
-                  <a:srgbClr val="18293B"/>
-                </a:solidFill>
-                <a:latin typeface="Calibri" pitchFamily="34" charset="0"/>
-                <a:ea typeface="Calibri" pitchFamily="34" charset="-122"/>
-                <a:cs typeface="Calibri" pitchFamily="34" charset="-120"/>
-              </a:rPr>
-              <a:t>A sequence is mapped once, to the whole graph. Every haplotype that carries it is reported, and the hit can be viewed on any of them.</a:t>
-            </a:r>
-            <a:endParaRPr lang="en-US" sz="1700" dirty="0"/>
-          </a:p>
-        </p:txBody>
-      </p:sp>
-      <p:sp>
-        <p:nvSpPr>
-          <p:cNvPr id="13" name="Shape 10"/>
-          <p:cNvSpPr/>
-          <p:nvPr/>
-        </p:nvSpPr>
-        <p:spPr>
-          <a:xfrm>
-            <a:off x="8960891" y="2743200"/>
-            <a:ext cx="0" cy="457200"/>
-          </a:xfrm>
-          <a:prstGeom prst="line">
-            <a:avLst/>
-          </a:prstGeom>
-          <a:noFill/>
-          <a:ln w="25400">
-            <a:solidFill>
-              <a:srgbClr val="003C6C"/>
-            </a:solidFill>
-            <a:prstDash val="solid"/>
-            <a:tailEnd type="triangle"/>
-          </a:ln>
-        </p:spPr>
-      </p:sp>
-      <p:sp>
-        <p:nvSpPr>
-          <p:cNvPr id="14" name="Shape 11"/>
-          <p:cNvSpPr/>
-          <p:nvPr/>
-        </p:nvSpPr>
-        <p:spPr>
-          <a:xfrm>
-            <a:off x="6278728" y="3200400"/>
-            <a:ext cx="5364328" cy="2651760"/>
-          </a:xfrm>
-          <a:prstGeom prst="roundRect">
-            <a:avLst>
-              <a:gd name="adj" fmla="val 4138"/>
-            </a:avLst>
-          </a:prstGeom>
-          <a:solidFill>
-            <a:srgbClr val="EDF1F6"/>
-          </a:solidFill>
-          <a:ln w="12700">
-            <a:solidFill>
-              <a:srgbClr val="DCE3EB"/>
-            </a:solidFill>
-            <a:prstDash val="solid"/>
-          </a:ln>
-        </p:spPr>
-      </p:sp>
-      <p:sp>
-        <p:nvSpPr>
-          <p:cNvPr id="15" name="Shape 12"/>
-          <p:cNvSpPr/>
-          <p:nvPr/>
-        </p:nvSpPr>
-        <p:spPr>
-          <a:xfrm>
-            <a:off x="6598768" y="3520440"/>
-            <a:ext cx="731520" cy="731520"/>
-          </a:xfrm>
-          <a:prstGeom prst="ellipse">
-            <a:avLst/>
-          </a:prstGeom>
-          <a:solidFill>
-            <a:srgbClr val="003C6C"/>
-          </a:solidFill>
-          <a:ln w="12700">
-            <a:solidFill>
-              <a:srgbClr val="003C6C"/>
-            </a:solidFill>
-            <a:prstDash val="solid"/>
-          </a:ln>
-        </p:spPr>
-      </p:sp>
-      <p:pic>
-        <p:nvPicPr>
-          <p:cNvPr id="16" name="Image 1" descr="preencoded.png">    </p:cNvPr>
-          <p:cNvPicPr>
-            <a:picLocks noChangeAspect="1"/>
-          </p:cNvPicPr>
-          <p:nvPr/>
-        </p:nvPicPr>
-        <p:blipFill>
-          <a:blip r:embed="rId2"/>
-          <a:stretch>
-            <a:fillRect/>
-          </a:stretch>
-        </p:blipFill>
-        <p:spPr>
-          <a:xfrm>
-            <a:off x="6788963" y="3710635"/>
-            <a:ext cx="351130" cy="351130"/>
-          </a:xfrm>
-          <a:prstGeom prst="rect">
-            <a:avLst/>
-          </a:prstGeom>
-        </p:spPr>
-      </p:pic>
-      <p:sp>
-        <p:nvSpPr>
-          <p:cNvPr id="17" name="Text 13"/>
-          <p:cNvSpPr txBox="1"/>
-          <p:nvPr/>
-        </p:nvSpPr>
-        <p:spPr>
-          <a:xfrm>
-            <a:off x="7558888" y="3611880"/>
-            <a:ext cx="3718408" cy="502920"/>
-          </a:xfrm>
-          <a:prstGeom prst="rect">
-            <a:avLst/>
-          </a:prstGeom>
-          <a:noFill/>
-          <a:ln/>
-        </p:spPr>
-        <p:txBody>
-          <a:bodyPr wrap="square" lIns="0" tIns="0" rIns="0" bIns="0" rtlCol="0" anchor="t"/>
-          <a:lstStyle/>
-          <a:p>
-            <a:pPr indent="0" marL="0">
-              <a:buNone/>
-            </a:pPr>
-            <a:r>
-              <a:rPr lang="en-US" sz="2200" b="1" dirty="0">
-                <a:solidFill>
-                  <a:srgbClr val="003C6C"/>
-                </a:solidFill>
-                <a:latin typeface="Calibri" pitchFamily="34" charset="0"/>
-                <a:ea typeface="Calibri" pitchFamily="34" charset="-122"/>
-                <a:cs typeface="Calibri" pitchFamily="34" charset="-120"/>
-              </a:rPr>
-              <a:t>Coordinate translation</a:t>
-            </a:r>
-            <a:endParaRPr lang="en-US" sz="2200" dirty="0"/>
-          </a:p>
-        </p:txBody>
-      </p:sp>
-      <p:sp>
-        <p:nvSpPr>
-          <p:cNvPr id="18" name="Text 14"/>
-          <p:cNvSpPr txBox="1"/>
-          <p:nvPr/>
-        </p:nvSpPr>
-        <p:spPr>
-          <a:xfrm>
-            <a:off x="6598768" y="4389120"/>
-            <a:ext cx="4724248" cy="1371600"/>
-          </a:xfrm>
-          <a:prstGeom prst="rect">
-            <a:avLst/>
-          </a:prstGeom>
-          <a:noFill/>
-          <a:ln/>
-        </p:spPr>
-        <p:txBody>
-          <a:bodyPr wrap="square" lIns="0" tIns="0" rIns="0" bIns="0" rtlCol="0" anchor="t"/>
-          <a:lstStyle/>
-          <a:p>
-            <a:pPr indent="0" marL="0">
-              <a:buNone/>
-            </a:pPr>
-            <a:r>
-              <a:rPr lang="en-US" sz="1700" dirty="0">
-                <a:solidFill>
-                  <a:srgbClr val="18293B"/>
-                </a:solidFill>
-                <a:latin typeface="Calibri" pitchFamily="34" charset="0"/>
-                <a:ea typeface="Calibri" pitchFamily="34" charset="-122"/>
-                <a:cs typeface="Calibri" pitchFamily="34" charset="-120"/>
-              </a:rPr>
-              <a:t>A locus on any haplotype is translated to any other haplotype, and the source's annotation is drawn there over an alignment built on demand.</a:t>
-            </a:r>
-            <a:endParaRPr lang="en-US" sz="1700" dirty="0"/>
           </a:p>
         </p:txBody>
       </p:sp>
@@ -26827,7 +26828,7 @@
                 <a:ea typeface="Calibri" pitchFamily="34" charset="-122"/>
                 <a:cs typeface="Calibri" pitchFamily="34" charset="-120"/>
               </a:rPr>
-              <a:t>Both run inside the UCSC Genome Browser, on the release 2 graph, today.</a:t>
+              <a:t>A web page can wait a second, not an hour. The index is what makes that possible.</a:t>
             </a:r>
             <a:endParaRPr lang="en-US" sz="2000" dirty="0"/>
           </a:p>

</xml_diff>

<commit_message>
Talk: replace the audience slide with three questions a release 2 user can now ask
</commit_message>
<xml_diff>
--- a/talk/HPRC2026_talk.pptx
+++ b/talk/HPRC2026_talk.pptx
@@ -1882,10 +1882,12 @@
           <a:p>
             <a:r>
               <a:rPr lang="en-US" dirty="0"/>
-              <a:t>[10:15-10:55]
-Who is this for? For clinicians and curators: is this insertion private to my patient, or carried by HPRC individuals, and which ones? ClinVar and GWAS context on the haplotype that actually carries the patient's allele. And the complex loci where one reference misleads: HLA, KIR, CYP2D6, LPA, SMN, seen on many haplotypes with the reference annotation drawn there.
-For researchers and graph builders: place contigs, probes, primers or guide RNAs on every haplotype at once; move any annotation, including your own tracks, onto any assembly; and inspect the graph's alignment itself, because the Alignment Differences track is the graph, drawn base by base.
-No pipeline, no download. A browser tab, and a sequence or a position.</a:t>
+              <a:t>[10:15-10:40]
+Put simply, three questions a release 2 user can now ask without leaving the browser.
+Is my sequence in any HPRC individual? Paste it, and get every haplotype that carries it and where.
+What does my locus look like on another haplotype? Give a position, pick a haplotype, and see it there with the reference annotation drawn on it.
+And where does that haplotype differ from the reference? Same view: the graph's alignment, base by base.
+A browser tab, and a sequence or a position. No pipeline, no download.</a:t>
             </a:r>
             <a:endParaRPr lang="en-US" dirty="0"/>
           </a:p>
@@ -1973,7 +1975,7 @@
           <a:p>
             <a:r>
               <a:rPr lang="en-US" dirty="0"/>
-              <a:t>[10:55-11:40]
+              <a:t>[10:40-11:25]
 None of this matters if it takes a minute. So: is it fast enough to sit behind a web page?
 Exon-scale intervals translate in about twenty milliseconds, a ten-kilobase gene in about a tenth of a second, a hundred kilobases in under a second, a megabase in about four.
 And it serves many people at once: throughput goes from six to sixty queries a second and saturates around eight cores. Read that as "one box serves about sixty queries a second", not as perfect scaling; the single-thread number was warm-up-limited.</a:t>
@@ -2064,7 +2066,7 @@
           <a:p>
             <a:r>
               <a:rPr lang="en-US" dirty="0"/>
-              <a:t>[11:40-12:20]
+              <a:t>[11:25-12:05]
 So, the two use cases. Sequence search: every carrying haplotype found in seconds, and the sequence viewed as a track on any of them. Coordinate translation: any of the 464 haplotypes as the target in about a hundred milliseconds, with the reference's annotation drawn there.
 Release 2 becomes something a scientist can query, not only browse. The next step is the public UCSC Genome Browser. It is available on the development browser now; bring us your hardest region.
 (Advance to thanks. Let it breathe. Then questions.)</a:t>
@@ -2155,7 +2157,7 @@
           <a:p>
             <a:r>
               <a:rPr lang="en-US" dirty="0"/>
-              <a:t>[12:20-12:35]
+              <a:t>[12:05-12:20]
 None of this was mine alone: Jouni Sirén, Benedict Paten, and a lot of help from the Computational Genomics Lab and the Genome Browser team. Thank you. Questions.</a:t>
             </a:r>
             <a:endParaRPr lang="en-US" dirty="0"/>
@@ -7511,7 +7513,7 @@
                 <a:ea typeface="Calibri" pitchFamily="34" charset="-122"/>
                 <a:cs typeface="Calibri" pitchFamily="34" charset="-120"/>
               </a:rPr>
-              <a:t>Who this is for</a:t>
+              <a:t>What a release 2 user can now ask</a:t>
             </a:r>
             <a:endParaRPr lang="en-US" sz="3200" dirty="0"/>
           </a:p>
@@ -7565,11 +7567,11 @@
         <p:spPr>
           <a:xfrm>
             <a:off x="548640" y="1325880"/>
-            <a:ext cx="5364328" cy="4206240"/>
+            <a:ext cx="3454298" cy="4114800"/>
           </a:xfrm>
           <a:prstGeom prst="roundRect">
             <a:avLst>
-              <a:gd name="adj" fmla="val 2609"/>
+              <a:gd name="adj" fmla="val 3177"/>
             </a:avLst>
           </a:prstGeom>
           <a:solidFill>
@@ -7592,7 +7594,7 @@
         <p:spPr>
           <a:xfrm>
             <a:off x="868680" y="1645920"/>
-            <a:ext cx="640080" cy="640080"/>
+            <a:ext cx="685800" cy="685800"/>
           </a:xfrm>
           <a:prstGeom prst="ellipse">
             <a:avLst/>
@@ -7624,8 +7626,8 @@
         </p:blipFill>
         <p:spPr>
           <a:xfrm>
-            <a:off x="1035101" y="1812341"/>
-            <a:ext cx="307238" cy="307238"/>
+            <a:off x="1046988" y="1824228"/>
+            <a:ext cx="329184" cy="329184"/>
           </a:xfrm>
           <a:prstGeom prst="rect">
             <a:avLst/>
@@ -7640,8 +7642,8 @@
         </p:nvSpPr>
         <p:spPr>
           <a:xfrm>
-            <a:off x="1691640" y="1709928"/>
-            <a:ext cx="3901288" cy="502920"/>
+            <a:off x="868680" y="2468880"/>
+            <a:ext cx="2814218" cy="914400"/>
           </a:xfrm>
           <a:prstGeom prst="rect">
             <a:avLst/>
@@ -7657,7 +7659,7 @@
               <a:buNone/>
             </a:pPr>
             <a:r>
-              <a:rPr lang="en-US" sz="2100" b="1" dirty="0">
+              <a:rPr lang="en-US" sz="1900" b="1" dirty="0">
                 <a:solidFill>
                   <a:srgbClr val="003C6C"/>
                 </a:solidFill>
@@ -7665,9 +7667,9 @@
                 <a:ea typeface="Calibri" pitchFamily="34" charset="-122"/>
                 <a:cs typeface="Calibri" pitchFamily="34" charset="-120"/>
               </a:rPr>
-              <a:t>Clinicians and variant curators</a:t>
+              <a:t>Is my sequence in any HPRC individual?</a:t>
             </a:r>
-            <a:endParaRPr lang="en-US" sz="2100" dirty="0"/>
+            <a:endParaRPr lang="en-US" sz="1900" dirty="0"/>
           </a:p>
         </p:txBody>
       </p:sp>
@@ -7679,8 +7681,8 @@
         </p:nvSpPr>
         <p:spPr>
           <a:xfrm>
-            <a:off x="868680" y="2468880"/>
-            <a:ext cx="4724248" cy="2926080"/>
+            <a:off x="868680" y="3474720"/>
+            <a:ext cx="2814218" cy="274320"/>
           </a:xfrm>
           <a:prstGeom prst="rect">
             <a:avLst/>
@@ -7692,15 +7694,50 @@
           <a:bodyPr wrap="square" lIns="0" tIns="0" rIns="0" bIns="0" rtlCol="0" anchor="t"/>
           <a:lstStyle/>
           <a:p>
-            <a:pPr marL="203200" indent="-203200">
-              <a:spcAft>
-                <a:spcPts val="900"/>
-              </a:spcAft>
-              <a:buSzPct val="100000"/>
-              <a:buChar char="•"/>
+            <a:pPr indent="0" marL="0">
+              <a:buNone/>
             </a:pPr>
             <a:r>
-              <a:rPr lang="en-US" sz="1600" dirty="0">
+              <a:rPr lang="en-US" sz="1200" b="1" spc="200" kern="0" dirty="0">
+                <a:solidFill>
+                  <a:srgbClr val="5B6B7C"/>
+                </a:solidFill>
+                <a:latin typeface="Calibri" pitchFamily="34" charset="0"/>
+                <a:ea typeface="Calibri" pitchFamily="34" charset="-122"/>
+                <a:cs typeface="Calibri" pitchFamily="34" charset="-120"/>
+              </a:rPr>
+              <a:t>you give</a:t>
+            </a:r>
+            <a:endParaRPr lang="en-US" sz="1200" dirty="0"/>
+          </a:p>
+        </p:txBody>
+      </p:sp>
+      <p:sp>
+        <p:nvSpPr>
+          <p:cNvPr id="9" name="Text 6"/>
+          <p:cNvSpPr txBox="1"/>
+          <p:nvPr/>
+        </p:nvSpPr>
+        <p:spPr>
+          <a:xfrm>
+            <a:off x="868680" y="3749040"/>
+            <a:ext cx="2814218" cy="457200"/>
+          </a:xfrm>
+          <a:prstGeom prst="rect">
+            <a:avLst/>
+          </a:prstGeom>
+          <a:noFill/>
+          <a:ln/>
+        </p:spPr>
+        <p:txBody>
+          <a:bodyPr wrap="square" lIns="0" tIns="0" rIns="0" bIns="0" rtlCol="0" anchor="t"/>
+          <a:lstStyle/>
+          <a:p>
+            <a:pPr indent="0" marL="0">
+              <a:buNone/>
+            </a:pPr>
+            <a:r>
+              <a:rPr lang="en-US" sz="1500" dirty="0">
                 <a:solidFill>
                   <a:srgbClr val="18293B"/>
                 </a:solidFill>
@@ -7708,20 +7745,77 @@
                 <a:ea typeface="Calibri" pitchFamily="34" charset="-122"/>
                 <a:cs typeface="Calibri" pitchFamily="34" charset="-120"/>
               </a:rPr>
-              <a:t>Is this insertion or SV sequence private to my patient, or carried by HPRC individuals? Which ones?</a:t>
+              <a:t>Paste a sequence.</a:t>
             </a:r>
-            <a:endParaRPr lang="en-US" sz="1600" dirty="0"/>
-          </a:p>
-          <a:p>
-            <a:pPr marL="203200" indent="-203200">
-              <a:spcAft>
-                <a:spcPts val="900"/>
-              </a:spcAft>
-              <a:buSzPct val="100000"/>
-              <a:buChar char="•"/>
+            <a:endParaRPr lang="en-US" sz="1500" dirty="0"/>
+          </a:p>
+        </p:txBody>
+      </p:sp>
+      <p:sp>
+        <p:nvSpPr>
+          <p:cNvPr id="10" name="Text 7"/>
+          <p:cNvSpPr txBox="1"/>
+          <p:nvPr/>
+        </p:nvSpPr>
+        <p:spPr>
+          <a:xfrm>
+            <a:off x="868680" y="4297680"/>
+            <a:ext cx="2814218" cy="274320"/>
+          </a:xfrm>
+          <a:prstGeom prst="rect">
+            <a:avLst/>
+          </a:prstGeom>
+          <a:noFill/>
+          <a:ln/>
+        </p:spPr>
+        <p:txBody>
+          <a:bodyPr wrap="square" lIns="0" tIns="0" rIns="0" bIns="0" rtlCol="0" anchor="t"/>
+          <a:lstStyle/>
+          <a:p>
+            <a:pPr indent="0" marL="0">
+              <a:buNone/>
             </a:pPr>
             <a:r>
-              <a:rPr lang="en-US" sz="1600" dirty="0">
+              <a:rPr lang="en-US" sz="1200" b="1" spc="200" kern="0" dirty="0">
+                <a:solidFill>
+                  <a:srgbClr val="5B6B7C"/>
+                </a:solidFill>
+                <a:latin typeface="Calibri" pitchFamily="34" charset="0"/>
+                <a:ea typeface="Calibri" pitchFamily="34" charset="-122"/>
+                <a:cs typeface="Calibri" pitchFamily="34" charset="-120"/>
+              </a:rPr>
+              <a:t>you get</a:t>
+            </a:r>
+            <a:endParaRPr lang="en-US" sz="1200" dirty="0"/>
+          </a:p>
+        </p:txBody>
+      </p:sp>
+      <p:sp>
+        <p:nvSpPr>
+          <p:cNvPr id="11" name="Text 8"/>
+          <p:cNvSpPr txBox="1"/>
+          <p:nvPr/>
+        </p:nvSpPr>
+        <p:spPr>
+          <a:xfrm>
+            <a:off x="868680" y="4572000"/>
+            <a:ext cx="2814218" cy="822960"/>
+          </a:xfrm>
+          <a:prstGeom prst="rect">
+            <a:avLst/>
+          </a:prstGeom>
+          <a:noFill/>
+          <a:ln/>
+        </p:spPr>
+        <p:txBody>
+          <a:bodyPr wrap="square" lIns="0" tIns="0" rIns="0" bIns="0" rtlCol="0" anchor="t"/>
+          <a:lstStyle/>
+          <a:p>
+            <a:pPr indent="0" marL="0">
+              <a:buNone/>
+            </a:pPr>
+            <a:r>
+              <a:rPr lang="en-US" sz="1500" dirty="0">
                 <a:solidFill>
                   <a:srgbClr val="18293B"/>
                 </a:solidFill>
@@ -7729,20 +7823,192 @@
                 <a:ea typeface="Calibri" pitchFamily="34" charset="-122"/>
                 <a:cs typeface="Calibri" pitchFamily="34" charset="-120"/>
               </a:rPr>
-              <a:t>ClinVar and GWAS context on the haplotype that actually carries the patient's allele.</a:t>
+              <a:t>Every haplotype that carries it, and where on each.</a:t>
             </a:r>
-            <a:endParaRPr lang="en-US" sz="1600" dirty="0"/>
-          </a:p>
-          <a:p>
-            <a:pPr marL="203200" indent="-203200">
-              <a:spcAft>
-                <a:spcPts val="900"/>
-              </a:spcAft>
-              <a:buSzPct val="100000"/>
-              <a:buChar char="•"/>
+            <a:endParaRPr lang="en-US" sz="1500" dirty="0"/>
+          </a:p>
+        </p:txBody>
+      </p:sp>
+      <p:sp>
+        <p:nvSpPr>
+          <p:cNvPr id="12" name="Shape 9"/>
+          <p:cNvSpPr/>
+          <p:nvPr/>
+        </p:nvSpPr>
+        <p:spPr>
+          <a:xfrm>
+            <a:off x="4368698" y="1325880"/>
+            <a:ext cx="3454298" cy="4114800"/>
+          </a:xfrm>
+          <a:prstGeom prst="roundRect">
+            <a:avLst>
+              <a:gd name="adj" fmla="val 3177"/>
+            </a:avLst>
+          </a:prstGeom>
+          <a:solidFill>
+            <a:srgbClr val="EDF1F6"/>
+          </a:solidFill>
+          <a:ln w="12700">
+            <a:solidFill>
+              <a:srgbClr val="DCE3EB"/>
+            </a:solidFill>
+            <a:prstDash val="solid"/>
+          </a:ln>
+        </p:spPr>
+      </p:sp>
+      <p:sp>
+        <p:nvSpPr>
+          <p:cNvPr id="13" name="Shape 10"/>
+          <p:cNvSpPr/>
+          <p:nvPr/>
+        </p:nvSpPr>
+        <p:spPr>
+          <a:xfrm>
+            <a:off x="4688738" y="1645920"/>
+            <a:ext cx="685800" cy="685800"/>
+          </a:xfrm>
+          <a:prstGeom prst="ellipse">
+            <a:avLst/>
+          </a:prstGeom>
+          <a:solidFill>
+            <a:srgbClr val="003C6C"/>
+          </a:solidFill>
+          <a:ln w="12700">
+            <a:solidFill>
+              <a:srgbClr val="003C6C"/>
+            </a:solidFill>
+            <a:prstDash val="solid"/>
+          </a:ln>
+        </p:spPr>
+      </p:sp>
+      <p:pic>
+        <p:nvPicPr>
+          <p:cNvPr id="14" name="Image 1" descr="preencoded.png">    </p:cNvPr>
+          <p:cNvPicPr>
+            <a:picLocks noChangeAspect="1"/>
+          </p:cNvPicPr>
+          <p:nvPr/>
+        </p:nvPicPr>
+        <p:blipFill>
+          <a:blip r:embed="rId2"/>
+          <a:stretch>
+            <a:fillRect/>
+          </a:stretch>
+        </p:blipFill>
+        <p:spPr>
+          <a:xfrm>
+            <a:off x="4867046" y="1824228"/>
+            <a:ext cx="329184" cy="329184"/>
+          </a:xfrm>
+          <a:prstGeom prst="rect">
+            <a:avLst/>
+          </a:prstGeom>
+        </p:spPr>
+      </p:pic>
+      <p:sp>
+        <p:nvSpPr>
+          <p:cNvPr id="15" name="Text 11"/>
+          <p:cNvSpPr txBox="1"/>
+          <p:nvPr/>
+        </p:nvSpPr>
+        <p:spPr>
+          <a:xfrm>
+            <a:off x="4688738" y="2468880"/>
+            <a:ext cx="2814218" cy="914400"/>
+          </a:xfrm>
+          <a:prstGeom prst="rect">
+            <a:avLst/>
+          </a:prstGeom>
+          <a:noFill/>
+          <a:ln/>
+        </p:spPr>
+        <p:txBody>
+          <a:bodyPr wrap="square" lIns="0" tIns="0" rIns="0" bIns="0" rtlCol="0" anchor="t"/>
+          <a:lstStyle/>
+          <a:p>
+            <a:pPr indent="0" marL="0">
+              <a:buNone/>
             </a:pPr>
             <a:r>
-              <a:rPr lang="en-US" sz="1600" dirty="0">
+              <a:rPr lang="en-US" sz="1900" b="1" dirty="0">
+                <a:solidFill>
+                  <a:srgbClr val="003C6C"/>
+                </a:solidFill>
+                <a:latin typeface="Calibri" pitchFamily="34" charset="0"/>
+                <a:ea typeface="Calibri" pitchFamily="34" charset="-122"/>
+                <a:cs typeface="Calibri" pitchFamily="34" charset="-120"/>
+              </a:rPr>
+              <a:t>What does my locus look like on another haplotype?</a:t>
+            </a:r>
+            <a:endParaRPr lang="en-US" sz="1900" dirty="0"/>
+          </a:p>
+        </p:txBody>
+      </p:sp>
+      <p:sp>
+        <p:nvSpPr>
+          <p:cNvPr id="16" name="Text 12"/>
+          <p:cNvSpPr txBox="1"/>
+          <p:nvPr/>
+        </p:nvSpPr>
+        <p:spPr>
+          <a:xfrm>
+            <a:off x="4688738" y="3474720"/>
+            <a:ext cx="2814218" cy="274320"/>
+          </a:xfrm>
+          <a:prstGeom prst="rect">
+            <a:avLst/>
+          </a:prstGeom>
+          <a:noFill/>
+          <a:ln/>
+        </p:spPr>
+        <p:txBody>
+          <a:bodyPr wrap="square" lIns="0" tIns="0" rIns="0" bIns="0" rtlCol="0" anchor="t"/>
+          <a:lstStyle/>
+          <a:p>
+            <a:pPr indent="0" marL="0">
+              <a:buNone/>
+            </a:pPr>
+            <a:r>
+              <a:rPr lang="en-US" sz="1200" b="1" spc="200" kern="0" dirty="0">
+                <a:solidFill>
+                  <a:srgbClr val="5B6B7C"/>
+                </a:solidFill>
+                <a:latin typeface="Calibri" pitchFamily="34" charset="0"/>
+                <a:ea typeface="Calibri" pitchFamily="34" charset="-122"/>
+                <a:cs typeface="Calibri" pitchFamily="34" charset="-120"/>
+              </a:rPr>
+              <a:t>you give</a:t>
+            </a:r>
+            <a:endParaRPr lang="en-US" sz="1200" dirty="0"/>
+          </a:p>
+        </p:txBody>
+      </p:sp>
+      <p:sp>
+        <p:nvSpPr>
+          <p:cNvPr id="17" name="Text 13"/>
+          <p:cNvSpPr txBox="1"/>
+          <p:nvPr/>
+        </p:nvSpPr>
+        <p:spPr>
+          <a:xfrm>
+            <a:off x="4688738" y="3749040"/>
+            <a:ext cx="2814218" cy="457200"/>
+          </a:xfrm>
+          <a:prstGeom prst="rect">
+            <a:avLst/>
+          </a:prstGeom>
+          <a:noFill/>
+          <a:ln/>
+        </p:spPr>
+        <p:txBody>
+          <a:bodyPr wrap="square" lIns="0" tIns="0" rIns="0" bIns="0" rtlCol="0" anchor="t"/>
+          <a:lstStyle/>
+          <a:p>
+            <a:pPr indent="0" marL="0">
+              <a:buNone/>
+            </a:pPr>
+            <a:r>
+              <a:rPr lang="en-US" sz="1500" dirty="0">
                 <a:solidFill>
                   <a:srgbClr val="18293B"/>
                 </a:solidFill>
@@ -7750,26 +8016,104 @@
                 <a:ea typeface="Calibri" pitchFamily="34" charset="-122"/>
                 <a:cs typeface="Calibri" pitchFamily="34" charset="-120"/>
               </a:rPr>
-              <a:t>Loci where one reference misleads: HLA, KIR, CYP2D6, LPA, SMN1/2, seen on many haplotypes with the reference annotation drawn there.</a:t>
+              <a:t>Give a position and pick a haplotype.</a:t>
             </a:r>
-            <a:endParaRPr lang="en-US" sz="1600" dirty="0"/>
+            <a:endParaRPr lang="en-US" sz="1500" dirty="0"/>
           </a:p>
         </p:txBody>
       </p:sp>
       <p:sp>
         <p:nvSpPr>
-          <p:cNvPr id="9" name="Shape 6"/>
-          <p:cNvSpPr/>
-          <p:nvPr/>
-        </p:nvSpPr>
-        <p:spPr>
-          <a:xfrm>
-            <a:off x="6278728" y="1325880"/>
-            <a:ext cx="5364328" cy="4206240"/>
+          <p:cNvPr id="18" name="Text 14"/>
+          <p:cNvSpPr txBox="1"/>
+          <p:nvPr/>
+        </p:nvSpPr>
+        <p:spPr>
+          <a:xfrm>
+            <a:off x="4688738" y="4297680"/>
+            <a:ext cx="2814218" cy="274320"/>
+          </a:xfrm>
+          <a:prstGeom prst="rect">
+            <a:avLst/>
+          </a:prstGeom>
+          <a:noFill/>
+          <a:ln/>
+        </p:spPr>
+        <p:txBody>
+          <a:bodyPr wrap="square" lIns="0" tIns="0" rIns="0" bIns="0" rtlCol="0" anchor="t"/>
+          <a:lstStyle/>
+          <a:p>
+            <a:pPr indent="0" marL="0">
+              <a:buNone/>
+            </a:pPr>
+            <a:r>
+              <a:rPr lang="en-US" sz="1200" b="1" spc="200" kern="0" dirty="0">
+                <a:solidFill>
+                  <a:srgbClr val="5B6B7C"/>
+                </a:solidFill>
+                <a:latin typeface="Calibri" pitchFamily="34" charset="0"/>
+                <a:ea typeface="Calibri" pitchFamily="34" charset="-122"/>
+                <a:cs typeface="Calibri" pitchFamily="34" charset="-120"/>
+              </a:rPr>
+              <a:t>you get</a:t>
+            </a:r>
+            <a:endParaRPr lang="en-US" sz="1200" dirty="0"/>
+          </a:p>
+        </p:txBody>
+      </p:sp>
+      <p:sp>
+        <p:nvSpPr>
+          <p:cNvPr id="19" name="Text 15"/>
+          <p:cNvSpPr txBox="1"/>
+          <p:nvPr/>
+        </p:nvSpPr>
+        <p:spPr>
+          <a:xfrm>
+            <a:off x="4688738" y="4572000"/>
+            <a:ext cx="2814218" cy="822960"/>
+          </a:xfrm>
+          <a:prstGeom prst="rect">
+            <a:avLst/>
+          </a:prstGeom>
+          <a:noFill/>
+          <a:ln/>
+        </p:spPr>
+        <p:txBody>
+          <a:bodyPr wrap="square" lIns="0" tIns="0" rIns="0" bIns="0" rtlCol="0" anchor="t"/>
+          <a:lstStyle/>
+          <a:p>
+            <a:pPr indent="0" marL="0">
+              <a:buNone/>
+            </a:pPr>
+            <a:r>
+              <a:rPr lang="en-US" sz="1500" dirty="0">
+                <a:solidFill>
+                  <a:srgbClr val="18293B"/>
+                </a:solidFill>
+                <a:latin typeface="Calibri" pitchFamily="34" charset="0"/>
+                <a:ea typeface="Calibri" pitchFamily="34" charset="-122"/>
+                <a:cs typeface="Calibri" pitchFamily="34" charset="-120"/>
+              </a:rPr>
+              <a:t>The locus on that haplotype, with the reference annotation drawn there.</a:t>
+            </a:r>
+            <a:endParaRPr lang="en-US" sz="1500" dirty="0"/>
+          </a:p>
+        </p:txBody>
+      </p:sp>
+      <p:sp>
+        <p:nvSpPr>
+          <p:cNvPr id="20" name="Shape 16"/>
+          <p:cNvSpPr/>
+          <p:nvPr/>
+        </p:nvSpPr>
+        <p:spPr>
+          <a:xfrm>
+            <a:off x="8188757" y="1325880"/>
+            <a:ext cx="3454298" cy="4114800"/>
           </a:xfrm>
           <a:prstGeom prst="roundRect">
             <a:avLst>
-              <a:gd name="adj" fmla="val 2609"/>
+              <a:gd name="adj" fmla="val 3177"/>
             </a:avLst>
           </a:prstGeom>
           <a:solidFill>
@@ -7785,14 +8129,14 @@
       </p:sp>
       <p:sp>
         <p:nvSpPr>
-          <p:cNvPr id="10" name="Shape 7"/>
-          <p:cNvSpPr/>
-          <p:nvPr/>
-        </p:nvSpPr>
-        <p:spPr>
-          <a:xfrm>
-            <a:off x="6598768" y="1645920"/>
-            <a:ext cx="640080" cy="640080"/>
+          <p:cNvPr id="21" name="Shape 17"/>
+          <p:cNvSpPr/>
+          <p:nvPr/>
+        </p:nvSpPr>
+        <p:spPr>
+          <a:xfrm>
+            <a:off x="8508797" y="1645920"/>
+            <a:ext cx="685800" cy="685800"/>
           </a:xfrm>
           <a:prstGeom prst="ellipse">
             <a:avLst/>
@@ -7810,22 +8154,22 @@
       </p:sp>
       <p:pic>
         <p:nvPicPr>
-          <p:cNvPr id="11" name="Image 1" descr="preencoded.png">    </p:cNvPr>
+          <p:cNvPr id="22" name="Image 2" descr="preencoded.png">    </p:cNvPr>
           <p:cNvPicPr>
             <a:picLocks noChangeAspect="1"/>
           </p:cNvPicPr>
           <p:nvPr/>
         </p:nvPicPr>
         <p:blipFill>
-          <a:blip r:embed="rId2"/>
+          <a:blip r:embed="rId3"/>
           <a:stretch>
             <a:fillRect/>
           </a:stretch>
         </p:blipFill>
         <p:spPr>
           <a:xfrm>
-            <a:off x="6765188" y="1812341"/>
-            <a:ext cx="307238" cy="307238"/>
+            <a:off x="8687105" y="1824228"/>
+            <a:ext cx="329184" cy="329184"/>
           </a:xfrm>
           <a:prstGeom prst="rect">
             <a:avLst/>
@@ -7834,14 +8178,14 @@
       </p:pic>
       <p:sp>
         <p:nvSpPr>
-          <p:cNvPr id="12" name="Text 8"/>
+          <p:cNvPr id="23" name="Text 18"/>
           <p:cNvSpPr txBox="1"/>
           <p:nvPr/>
         </p:nvSpPr>
         <p:spPr>
           <a:xfrm>
-            <a:off x="7421728" y="1709928"/>
-            <a:ext cx="3901288" cy="502920"/>
+            <a:off x="8508797" y="2468880"/>
+            <a:ext cx="2814218" cy="914400"/>
           </a:xfrm>
           <a:prstGeom prst="rect">
             <a:avLst/>
@@ -7857,7 +8201,7 @@
               <a:buNone/>
             </a:pPr>
             <a:r>
-              <a:rPr lang="en-US" sz="2100" b="1" dirty="0">
+              <a:rPr lang="en-US" sz="1900" b="1" dirty="0">
                 <a:solidFill>
                   <a:srgbClr val="003C6C"/>
                 </a:solidFill>
@@ -7865,22 +8209,22 @@
                 <a:ea typeface="Calibri" pitchFamily="34" charset="-122"/>
                 <a:cs typeface="Calibri" pitchFamily="34" charset="-120"/>
               </a:rPr>
-              <a:t>Researchers and graph builders</a:t>
+              <a:t>Where does that haplotype differ from the reference?</a:t>
             </a:r>
-            <a:endParaRPr lang="en-US" sz="2100" dirty="0"/>
+            <a:endParaRPr lang="en-US" sz="1900" dirty="0"/>
           </a:p>
         </p:txBody>
       </p:sp>
       <p:sp>
         <p:nvSpPr>
-          <p:cNvPr id="13" name="Text 9"/>
+          <p:cNvPr id="24" name="Text 19"/>
           <p:cNvSpPr txBox="1"/>
           <p:nvPr/>
         </p:nvSpPr>
         <p:spPr>
           <a:xfrm>
-            <a:off x="6598768" y="2468880"/>
-            <a:ext cx="4724248" cy="2926080"/>
+            <a:off x="8508797" y="3474720"/>
+            <a:ext cx="2814218" cy="274320"/>
           </a:xfrm>
           <a:prstGeom prst="rect">
             <a:avLst/>
@@ -7892,15 +8236,50 @@
           <a:bodyPr wrap="square" lIns="0" tIns="0" rIns="0" bIns="0" rtlCol="0" anchor="t"/>
           <a:lstStyle/>
           <a:p>
-            <a:pPr marL="203200" indent="-203200">
-              <a:spcAft>
-                <a:spcPts val="900"/>
-              </a:spcAft>
-              <a:buSzPct val="100000"/>
-              <a:buChar char="•"/>
+            <a:pPr indent="0" marL="0">
+              <a:buNone/>
             </a:pPr>
             <a:r>
-              <a:rPr lang="en-US" sz="1600" dirty="0">
+              <a:rPr lang="en-US" sz="1200" b="1" spc="200" kern="0" dirty="0">
+                <a:solidFill>
+                  <a:srgbClr val="5B6B7C"/>
+                </a:solidFill>
+                <a:latin typeface="Calibri" pitchFamily="34" charset="0"/>
+                <a:ea typeface="Calibri" pitchFamily="34" charset="-122"/>
+                <a:cs typeface="Calibri" pitchFamily="34" charset="-120"/>
+              </a:rPr>
+              <a:t>you give</a:t>
+            </a:r>
+            <a:endParaRPr lang="en-US" sz="1200" dirty="0"/>
+          </a:p>
+        </p:txBody>
+      </p:sp>
+      <p:sp>
+        <p:nvSpPr>
+          <p:cNvPr id="25" name="Text 20"/>
+          <p:cNvSpPr txBox="1"/>
+          <p:nvPr/>
+        </p:nvSpPr>
+        <p:spPr>
+          <a:xfrm>
+            <a:off x="8508797" y="3749040"/>
+            <a:ext cx="2814218" cy="457200"/>
+          </a:xfrm>
+          <a:prstGeom prst="rect">
+            <a:avLst/>
+          </a:prstGeom>
+          <a:noFill/>
+          <a:ln/>
+        </p:spPr>
+        <p:txBody>
+          <a:bodyPr wrap="square" lIns="0" tIns="0" rIns="0" bIns="0" rtlCol="0" anchor="t"/>
+          <a:lstStyle/>
+          <a:p>
+            <a:pPr indent="0" marL="0">
+              <a:buNone/>
+            </a:pPr>
+            <a:r>
+              <a:rPr lang="en-US" sz="1500" dirty="0">
                 <a:solidFill>
                   <a:srgbClr val="18293B"/>
                 </a:solidFill>
@@ -7908,20 +8287,77 @@
                 <a:ea typeface="Calibri" pitchFamily="34" charset="-122"/>
                 <a:cs typeface="Calibri" pitchFamily="34" charset="-120"/>
               </a:rPr>
-              <a:t>Place contigs, probes, primers or guide RNAs on every haplotype at once; see which haplotypes lack the site.</a:t>
+              <a:t>Same view.</a:t>
             </a:r>
-            <a:endParaRPr lang="en-US" sz="1600" dirty="0"/>
-          </a:p>
-          <a:p>
-            <a:pPr marL="203200" indent="-203200">
-              <a:spcAft>
-                <a:spcPts val="900"/>
-              </a:spcAft>
-              <a:buSzPct val="100000"/>
-              <a:buChar char="•"/>
+            <a:endParaRPr lang="en-US" sz="1500" dirty="0"/>
+          </a:p>
+        </p:txBody>
+      </p:sp>
+      <p:sp>
+        <p:nvSpPr>
+          <p:cNvPr id="26" name="Text 21"/>
+          <p:cNvSpPr txBox="1"/>
+          <p:nvPr/>
+        </p:nvSpPr>
+        <p:spPr>
+          <a:xfrm>
+            <a:off x="8508797" y="4297680"/>
+            <a:ext cx="2814218" cy="274320"/>
+          </a:xfrm>
+          <a:prstGeom prst="rect">
+            <a:avLst/>
+          </a:prstGeom>
+          <a:noFill/>
+          <a:ln/>
+        </p:spPr>
+        <p:txBody>
+          <a:bodyPr wrap="square" lIns="0" tIns="0" rIns="0" bIns="0" rtlCol="0" anchor="t"/>
+          <a:lstStyle/>
+          <a:p>
+            <a:pPr indent="0" marL="0">
+              <a:buNone/>
             </a:pPr>
             <a:r>
-              <a:rPr lang="en-US" sz="1600" dirty="0">
+              <a:rPr lang="en-US" sz="1200" b="1" spc="200" kern="0" dirty="0">
+                <a:solidFill>
+                  <a:srgbClr val="5B6B7C"/>
+                </a:solidFill>
+                <a:latin typeface="Calibri" pitchFamily="34" charset="0"/>
+                <a:ea typeface="Calibri" pitchFamily="34" charset="-122"/>
+                <a:cs typeface="Calibri" pitchFamily="34" charset="-120"/>
+              </a:rPr>
+              <a:t>you get</a:t>
+            </a:r>
+            <a:endParaRPr lang="en-US" sz="1200" dirty="0"/>
+          </a:p>
+        </p:txBody>
+      </p:sp>
+      <p:sp>
+        <p:nvSpPr>
+          <p:cNvPr id="27" name="Text 22"/>
+          <p:cNvSpPr txBox="1"/>
+          <p:nvPr/>
+        </p:nvSpPr>
+        <p:spPr>
+          <a:xfrm>
+            <a:off x="8508797" y="4572000"/>
+            <a:ext cx="2814218" cy="822960"/>
+          </a:xfrm>
+          <a:prstGeom prst="rect">
+            <a:avLst/>
+          </a:prstGeom>
+          <a:noFill/>
+          <a:ln/>
+        </p:spPr>
+        <p:txBody>
+          <a:bodyPr wrap="square" lIns="0" tIns="0" rIns="0" bIns="0" rtlCol="0" anchor="t"/>
+          <a:lstStyle/>
+          <a:p>
+            <a:pPr indent="0" marL="0">
+              <a:buNone/>
+            </a:pPr>
+            <a:r>
+              <a:rPr lang="en-US" sz="1500" dirty="0">
                 <a:solidFill>
                   <a:srgbClr val="18293B"/>
                 </a:solidFill>
@@ -7929,36 +8365,15 @@
                 <a:ea typeface="Calibri" pitchFamily="34" charset="-122"/>
                 <a:cs typeface="Calibri" pitchFamily="34" charset="-120"/>
               </a:rPr>
-              <a:t>Move any reference annotation, or your own tracks, onto any assembly; compare a locus across individuals.</a:t>
+              <a:t>The graph's alignment, base by base, in the Alignment Differences track.</a:t>
             </a:r>
-            <a:endParaRPr lang="en-US" sz="1600" dirty="0"/>
-          </a:p>
-          <a:p>
-            <a:pPr marL="203200" indent="-203200">
-              <a:spcAft>
-                <a:spcPts val="900"/>
-              </a:spcAft>
-              <a:buSzPct val="100000"/>
-              <a:buChar char="•"/>
-            </a:pPr>
-            <a:r>
-              <a:rPr lang="en-US" sz="1600" dirty="0">
-                <a:solidFill>
-                  <a:srgbClr val="18293B"/>
-                </a:solidFill>
-                <a:latin typeface="Calibri" pitchFamily="34" charset="0"/>
-                <a:ea typeface="Calibri" pitchFamily="34" charset="-122"/>
-                <a:cs typeface="Calibri" pitchFamily="34" charset="-120"/>
-              </a:rPr>
-              <a:t>Inspect the graph's alignment itself: the Alignment Differences track is the graph, drawn base by base.</a:t>
-            </a:r>
-            <a:endParaRPr lang="en-US" sz="1600" dirty="0"/>
+            <a:endParaRPr lang="en-US" sz="1500" dirty="0"/>
           </a:p>
         </p:txBody>
       </p:sp>
       <p:sp>
         <p:nvSpPr>
-          <p:cNvPr id="14" name="Text 10"/>
+          <p:cNvPr id="28" name="Text 23"/>
           <p:cNvSpPr txBox="1"/>
           <p:nvPr/>
         </p:nvSpPr>
@@ -7989,7 +8404,7 @@
                 <a:ea typeface="Calibri" pitchFamily="34" charset="-122"/>
                 <a:cs typeface="Calibri" pitchFamily="34" charset="-120"/>
               </a:rPr>
-              <a:t>No pipeline, no download: a browser tab, and a sequence or a position.</a:t>
+              <a:t>A browser tab, and a sequence or a position. No pipeline, no download.</a:t>
             </a:r>
             <a:endParaRPr lang="en-US" sz="2000" dirty="0"/>
           </a:p>

</xml_diff>

<commit_message>
Talk: replace 'arbitrary haplotype' with plain wording
</commit_message>
<xml_diff>
--- a/talk/HPRC2026_talk.pptx
+++ b/talk/HPRC2026_talk.pptx
@@ -1611,7 +1611,7 @@
               <a:rPr lang="en-US" dirty="0"/>
               <a:t>[7:25-8:00]
 Use case 2: a gene known on a reference, on a specific release 2 haplotype.
-Moving a locus between assemblies today relies on a pairwise chain. The Genome Browser can draw one assembly's tracks on another, but only over a prebuilt chain between the two, and chains are built on request, one pair at a time. 464 haplotypes are more than two hundred thousand pairs; chains exist for fifty-six of them. For an arbitrary release 2 haplotype, such as HG02015, no chain exists.
+Moving a locus between assemblies today relies on a pairwise chain. The Genome Browser can draw one assembly's tracks on another, but only over a prebuilt chain between the two, and chains are built on request, one pair at a time. 464 haplotypes are more than two hundred thousand pairs; chains exist for fifty-six of them. For most release 2 haplotypes, HG02015 among them, no chain exists.
 The graph already contains the alignment for every pair. It has to be usable on demand, and that is exactly what the walk I showed produces.</a:t>
             </a:r>
             <a:endParaRPr lang="en-US" dirty="0"/>
@@ -2780,7 +2780,7 @@
               <a:t>[1:00-1:55]
 Concretely, three things release 2 can already do, but only from the command line.
 Place a sequence across haplotypes: which of the 464 carry it, where, and what does each region look like? Today that is a giraffe index, a mapping run, and a terminal session before the first answer.
-Move a locus onto a haplotype: take coordinates known on GRCh38 or CHM13 to an arbitrary release 2 haplotype. Today that is halLiftover or impg over the whole alignment, per request, or a ready-made chain for the handful of pairs that have one.
+Move a locus onto a haplotype: take coordinates known on GRCh38 or CHM13 to any release 2 haplotype you choose. Today that is halLiftover or impg over the whole alignment, per request, or a ready-made chain for the handful of pairs that have one.
 And bring the annotation along: see the reference's gene models, ClinVar, GWAS, or your own tracks on a release 2 haplotype. Today you lift every track yourself, per haplotype, before anyone can look.
 None of this is impossible. The graph already holds the answers. Reaching them takes compute, disk, and bioinformatics expertise that most clinicians and many researchers do not have, and time that even the experts would rather spend elsewhere.</a:t>
             </a:r>
@@ -6374,7 +6374,7 @@
                 <a:ea typeface="Calibri" pitchFamily="34" charset="-122"/>
                 <a:cs typeface="Calibri" pitchFamily="34" charset="-120"/>
               </a:rPr>
-              <a:t>For an arbitrary release 2 haplotype, such as HG02015, no chain exists.</a:t>
+              <a:t>For most release 2 haplotypes, HG02015 among them, no chain exists.</a:t>
             </a:r>
             <a:endParaRPr lang="en-US" sz="1900" dirty="0"/>
           </a:p>
@@ -25169,7 +25169,7 @@
                 <a:ea typeface="Calibri" pitchFamily="34" charset="-122"/>
                 <a:cs typeface="Calibri" pitchFamily="34" charset="-120"/>
               </a:rPr>
-              <a:t>Take coordinates known on GRCh38 or CHM13 to an arbitrary release 2 haplotype. Today: halLiftover or impg over the whole alignment, per request, or a ready-made chain for a handful of pairs.</a:t>
+              <a:t>Take coordinates known on GRCh38 or CHM13 to any release 2 haplotype you choose. Today: halLiftover or impg over the whole alignment, per request, or a ready-made chain for a handful of pairs.</a:t>
             </a:r>
             <a:endParaRPr lang="en-US" sz="1600" dirty="0"/>
           </a:p>

</xml_diff>

<commit_message>
Talk: opening script ties 2 of 464 to the questions that follow
</commit_message>
<xml_diff>
--- a/talk/HPRC2026_talk.pptx
+++ b/talk/HPRC2026_talk.pptx
@@ -1338,7 +1338,7 @@
           <a:p>
             <a:r>
               <a:rPr lang="en-US" dirty="0"/>
-              <a:t>[5:10-5:30]
+              <a:t>[5:20-5:40]
 Four. Walk the graph between anchors, one base at a time, and group the bases that share an offset into blocks. A block breaks on an indel, never on a SNP; an inversion starts a new chain. That is exactly what a chain file means.
 So the output is not a coordinate. It is a chain, and the browser already knows what to do with a chain. If the target does not contain the interval, you get fewer positions, never invented ones.</a:t>
             </a:r>
@@ -1428,7 +1428,7 @@
           <a:p>
             <a:r>
               <a:rPr lang="en-US" dirty="0"/>
-              <a:t>[5:30-6:50]  Start the recording; narrate over it.
+              <a:t>[5:40-7:00]  Start the recording; narrate over it.
 Use case 1: a sequence that is not in the reference. This is the Pangenome Mapping page.
 The sequence is pasted and mapped once, to the whole release 2 graph, with vg giraffe, in a few seconds. The result is something no single-assembly search can give: exactly two of the 464 haplotypes carry this sequence, HG01167 hap1 and HG04157 paternal, and GRCh38 is not one of them. They are ranked by identity, with coverage beside it.
 Selecting HG01167 opens it in the browser: the sequence is drawn as a track with base-level differences, in the context of that haplotype's own annotation. Selecting a different carrier re-uses the same alignment; nothing is remapped.</a:t>
@@ -1519,7 +1519,7 @@
           <a:p>
             <a:r>
               <a:rPr lang="en-US" dirty="0"/>
-              <a:t>[6:50-7:25]
+              <a:t>[7:00-7:35]
 What this enables on release 2: one search across all 464 haplotypes instead of one assembly at a time; sequences absent from the reference are found on the haplotypes that carry them, together with how many carry them; and any carrier can be opened with the sequence as a track, with another carrier costing no remapping.
 One detail this room will notice: MAPQ is zero by design. In a graph where every locus exists hundreds of times, mapping quality carries no information; per-haplotype identity and coverage replace it.</a:t>
             </a:r>
@@ -1609,7 +1609,7 @@
           <a:p>
             <a:r>
               <a:rPr lang="en-US" dirty="0"/>
-              <a:t>[7:25-8:00]
+              <a:t>[7:35-8:10]
 Use case 2: a gene known on a reference, on a specific release 2 haplotype.
 Moving a locus between assemblies today relies on a pairwise chain. The Genome Browser can draw one assembly's tracks on another, but only over a prebuilt chain between the two, and chains are built on request, one pair at a time. 464 haplotypes are more than two hundred thousand pairs; chains exist for fifty-six of them. For most release 2 haplotypes, HG02015 among them, no chain exists.
 The graph already contains the alignment for every pair. It has to be usable on demand, and that is exactly what the walk I showed produces.</a:t>
@@ -1700,7 +1700,7 @@
           <a:p>
             <a:r>
               <a:rPr lang="en-US" dirty="0"/>
-              <a:t>[8:00-9:40]  Start the recording; slow down at the landing.
+              <a:t>[8:10-9:50]  Start the recording; slow down at the landing.
 Now the same request on the release 2 graph. Source: the gene as known on the reference, here HLA-DMA on CHM13, ten kilobases on chromosome 6; GRCh38 is a path in this graph too, so it works identically as the source. Target: HG02015 paternal, chosen from all 464; the picker can be restricted to haplotypes that contain the region.
 Translated in about a hundred milliseconds, covering a hundred percent of bases.
 Opening the result is the part I care about most. HG02015 has its own CAT and Liftoff genes from release 2. What it does not have is everything that exists once, on one reference: ClinVar, the GWAS catalog, ENCODE, a lab's own tracks. Here they are, drawn at their translated positions, with the differences between the two assemblies marked.
@@ -1792,7 +1792,7 @@
           <a:p>
             <a:r>
               <a:rPr lang="en-US" dirty="0"/>
-              <a:t>[9:40-10:15]
+              <a:t>[9:50-10:25]
 Before, a locus could be moved only between assembly pairs with a prebuilt chain, and a release 2 haplotype without one showed only its own tracks. Now any of the 464 haplotypes can be the target, from GRCh38 or CHM13, in about a hundred milliseconds; the reference's tracks are drawn there over an alignment built for that region, with the differences marked.
 The thousands of tracks that exist once, on one reference, will never be rebuilt 464 times. With this, any release 2 haplotype can borrow them for the region under study.</a:t>
             </a:r>
@@ -1882,7 +1882,7 @@
           <a:p>
             <a:r>
               <a:rPr lang="en-US" dirty="0"/>
-              <a:t>[10:15-10:40]
+              <a:t>[10:25-10:50]
 Put simply, three questions a release 2 user can now ask without leaving the browser.
 Is my sequence in any HPRC individual? Paste it, and get every haplotype that carries it and where.
 What does my locus look like on another haplotype? Give a position, pick a haplotype, and see it there with the reference annotation drawn on it.
@@ -1975,7 +1975,7 @@
           <a:p>
             <a:r>
               <a:rPr lang="en-US" dirty="0"/>
-              <a:t>[10:40-11:25]
+              <a:t>[10:50-11:35]
 None of this matters if it takes a minute. So: is it fast enough to sit behind a web page?
 Exon-scale intervals translate in about twenty milliseconds, a ten-kilobase gene in about a tenth of a second, a hundred kilobases in under a second, a megabase in about four.
 And it serves many people at once: throughput goes from six to sixty queries a second and saturates around eight cores. Read that as "one box serves about sixty queries a second", not as perfect scaling; the single-thread number was warm-up-limited.</a:t>
@@ -2066,7 +2066,7 @@
           <a:p>
             <a:r>
               <a:rPr lang="en-US" dirty="0"/>
-              <a:t>[11:25-12:05]
+              <a:t>[11:35-12:15]
 So, the two use cases. Sequence search: every carrying haplotype found in seconds, and the sequence viewed as a track on any of them. Coordinate translation: any of the 464 haplotypes as the target in about a hundred milliseconds, with the reference's annotation drawn there.
 Release 2 becomes something a scientist can query, not only browse. The next step is the public UCSC Genome Browser. It is available on the development browser now; bring us your hardest region.
 (Advance to thanks. Let it breathe. Then questions.)</a:t>
@@ -2157,7 +2157,7 @@
           <a:p>
             <a:r>
               <a:rPr lang="en-US" dirty="0"/>
-              <a:t>[12:05-12:20]
+              <a:t>[12:15-12:30]
 None of this was mine alone: Jouni Sirén, Benedict Paten, and a lot of help from the Computational Genomics Lab and the Genome Browser team. Thank you. Questions.</a:t>
             </a:r>
             <a:endParaRPr lang="en-US" dirty="0"/>
@@ -2246,10 +2246,12 @@
           <a:p>
             <a:r>
               <a:rPr lang="en-US" dirty="0"/>
-              <a:t>[0:15-1:00]
-HPRC release 2 is the most complete picture of human variation we have: 464 haplotypes, in one graph. Two of those haplotypes, GRCh38 and CHM13, carry almost everything we know about the human genome: the gene models, the clinical variants, the regulatory annotation, and everyone's own tracks.
+              <a:t>[0:15-1:10]
+HPRC release 2 is 464 haplotypes in one graph: the most complete picture of human variation we have ever had.
 (pause)
-The tools to work with the graph exist: vg giraffe maps to it, odgi and the r-index query it, halLiftover and impg move coordinates across it. But every one of them wants a large index on disk, real compute, and a command-line workflow that takes time to set up and time to run. A clinician, or a researcher outside a genomics group, never gets past that step. So in practice release 2 is browsed, one assembly at a time, and the graph itself goes unused. This talk is about removing that barrier.</a:t>
+Now look at how our knowledge sits on those 464. Two of them, GRCh38 and CHM13, carry almost everything we know: the gene models, ClinVar, the GWAS catalog, the regulatory annotation, every track anyone has ever built. The other 462 are the reason release 2 exists. They carry what the two references miss: the insertions that are not in GRCh38, the alleles at HLA or LPA, the segmental duplications the reference gets wrong. And they carry almost none of our annotation.
+So the value of release 2 depends on traffic in both directions. Our knowledge has to travel from the two onto the 462: take a gene we understand on GRCh38 and see it on another haplotype. And sequence has to travel from the 462 back to the two: take something that is not in the reference, find which haplotypes carry it, and see it next to what we already know.
+Both directions are possible today, if you have a cluster and a terminal. For everyone else, release 2 is 464 assemblies to browse one at a time. That is the gap.</a:t>
             </a:r>
             <a:endParaRPr lang="en-US" dirty="0"/>
           </a:p>
@@ -2777,7 +2779,7 @@
           <a:p>
             <a:r>
               <a:rPr lang="en-US" dirty="0"/>
-              <a:t>[1:00-1:55]
+              <a:t>[1:10-2:05]
 Concretely, three things release 2 can already do, but only from the command line.
 Place a sequence across haplotypes: which of the 464 carry it, where, and what does each region look like? Today that is a giraffe index, a mapping run, and a terminal session before the first answer.
 Move a locus onto a haplotype: take coordinates known on GRCh38 or CHM13 to any release 2 haplotype you choose. Today that is halLiftover or impg over the whole alignment, per request, or a ready-made chain for the handful of pairs that have one.
@@ -2870,7 +2872,7 @@
           <a:p>
             <a:r>
               <a:rPr lang="en-US" dirty="0"/>
-              <a:t>[1:55-2:35]
+              <a:t>[2:05-2:45]
 I will follow two use cases through the rest of the talk.
 Use case 1, sequence search. A researcher has a sequence that is not in GRCh38: an insertion assembled from a sample, a probe, a contig. Which release 2 haplotypes carry it, and where on each?
 Use case 2, coordinate translation. A researcher knows a gene on GRCh38 or CHM13 and wants to see it, with its annotation, on a specific release 2 haplotype.
@@ -2962,7 +2964,7 @@
           <a:p>
             <a:r>
               <a:rPr lang="en-US" dirty="0"/>
-              <a:t>[2:35-3:10]
+              <a:t>[2:45-3:20]
 So what would it take to do this in a web page, where a user waits a second and not an hour? Both use cases come down to two questions the index underneath has to answer in milliseconds.
 Where in the graph is this sequence? Asked once, against all 464 haplotypes, not 464 times against one assembly each, and for any sequence, of any length.
 And: who passes through this node, and where? Answered for any haplotype against any other, without a pairwise alignment prepared in advance for each of the more than two hundred thousand pairs.
@@ -3054,7 +3056,7 @@
           <a:p>
             <a:r>
               <a:rPr lang="en-US" dirty="0"/>
-              <a:t>[3:10-4:10]
+              <a:t>[3:20-4:20]
 Here is the index on a toy graph, and it is all you need for the rest of the talk. Three haplotypes, one text, one BWT. Alongside the BWT sits the tag array: every BWT position carries a tag, the node and offset in the graph that character came from. On the right, the same thing as columns: search a pattern the way any FM-index does, read the tags in the interval, and you have the graph positions.
 Three consequences. One index answers for every haplotype: all 464 are indexed together, so a sequence is looked up once and found on every haplotype that carries it. Every match knows its place in the graph: a hit is a node and an offset, not a line in one assembly. And every node knows who visits it: ask a node and get every haplotype passing through it, each with its own coordinate. That last one is how a locus moves from one haplotype to another.
 Earlier pangenome indexes made you choose: index the haplotypes and get every hit 464 times, or index the graph and lose parts of the haplotypes. Tag arrays keep the haplotypes and add the graph. Nothing is lost, nothing is repeated, and nothing anywhere says CHM13-to-HG02015: there is no pairwise index, which is why any of the 464 can be translated to any other. Details are in the paper and I am happy to go into them in questions.</a:t>
@@ -3145,7 +3147,7 @@
           <a:p>
             <a:r>
               <a:rPr lang="en-US" dirty="0"/>
-              <a:t>[4:10-4:30]
+              <a:t>[4:20-4:40]
 With that one property in hand, translating a region stops being a lookup and becomes a walk. Four steps, one click each.
 (click) One. Find the query interval's nodes on the source haplotype's path. The tag arrays give us those directly.</a:t>
             </a:r>
@@ -3235,7 +3237,7 @@
           <a:p>
             <a:r>
               <a:rPr lang="en-US" dirty="0"/>
-              <a:t>[4:30-4:45]
+              <a:t>[4:40-4:55]
 Two. At those nodes, ask the tag arrays who else is standing here. Every haplotype comes back at once, including the target we care about.</a:t>
             </a:r>
             <a:endParaRPr lang="en-US" dirty="0"/>
@@ -3324,7 +3326,7 @@
           <a:p>
             <a:r>
               <a:rPr lang="en-US" dirty="0"/>
-              <a:t>[4:45-5:10]
+              <a:t>[4:55-5:20]
 Three. Nodes that source and target each visit exactly once are unambiguous anchors. Orthology is inherited from the graph's alignment; what we add is that a repeat cannot manufacture a false anchor, and a colinearity check drops pairs whose spans disagree.</a:t>
             </a:r>
             <a:endParaRPr lang="en-US" dirty="0"/>

</xml_diff>

<commit_message>
Talk: opening slide names the clinician who cannot use a cluster
</commit_message>
<xml_diff>
--- a/talk/HPRC2026_talk.pptx
+++ b/talk/HPRC2026_talk.pptx
@@ -2251,7 +2251,7 @@
 (pause)
 Now look at how our knowledge sits on those 464. Two of them, GRCh38 and CHM13, carry almost everything we know: the gene models, ClinVar, the GWAS catalog, the regulatory annotation, every track anyone has ever built. The other 462 are the reason release 2 exists. They carry what the two references miss: the insertions that are not in GRCh38, the alleles at HLA or LPA, the segmental duplications the reference gets wrong. And they carry almost none of our annotation.
 So the value of release 2 depends on traffic in both directions. Our knowledge has to travel from the two onto the 462: take a gene we understand on GRCh38 and see it on another haplotype. And sequence has to travel from the 462 back to the two: take something that is not in the reference, find which haplotypes carry it, and see it next to what we already know.
-Both directions are possible today, if you have a cluster and a terminal. For everyone else, release 2 is 464 assemblies to browse one at a time. That is the gap.</a:t>
+Both directions are possible today, if you have a cluster and a terminal. A clinician has neither, and most researchers would rather not. For them, release 2 stays 464 assemblies to browse one at a time. That is the gap.</a:t>
             </a:r>
             <a:endParaRPr lang="en-US" dirty="0"/>
           </a:p>
@@ -11120,7 +11120,7 @@
                 <a:ea typeface="Calibri" pitchFamily="34" charset="-122"/>
                 <a:cs typeface="Calibri" pitchFamily="34" charset="-120"/>
               </a:rPr>
-              <a:t>For everyone else, release 2 is 464 assemblies to browse one at a time.</a:t>
+              <a:t>For a clinician, neither is an option: release 2 stays 464 assemblies to browse one at a time.</a:t>
             </a:r>
             <a:endParaRPr lang="en-US" sz="2000" dirty="0"/>
           </a:p>

</xml_diff>

<commit_message>
Talk: slide 2 states what is not possible in the browser today
</commit_message>
<xml_diff>
--- a/talk/HPRC2026_talk.pptx
+++ b/talk/HPRC2026_talk.pptx
@@ -1412,8 +1412,9 @@
               <a:rPr lang="en-US" dirty="0"/>
               <a:t>Talking points:
 - what a researcher cannot do here today
-- BLAT searches one assembly; lift-over needs a prebuilt chain; 56 chains vs 200,000+ pairs
-- the graph aligns all 464 already, but nothing in the browser uses it</a:t>
+- no search across haplotypes: BLAT is one assembly at a time
+- no lift-over to a haplotype without a prebuilt chain: 56 chains, 200,000+ pairs
+- the graph aligns all 464 already; nothing in the browser uses it</a:t>
             </a:r>
             <a:endParaRPr lang="en-US" dirty="0"/>
           </a:p>
@@ -7384,7 +7385,7 @@
                 <a:ea typeface="Calibri" pitchFamily="34" charset="-122"/>
                 <a:cs typeface="Calibri" pitchFamily="34" charset="-120"/>
               </a:rPr>
-              <a:t>In the Genome Browser today</a:t>
+              <a:t>Not possible in the Genome Browser today</a:t>
             </a:r>
             <a:endParaRPr lang="en-US" sz="3200" dirty="0"/>
           </a:p>
@@ -7444,11 +7445,11 @@
             <a:avLst/>
           </a:prstGeom>
           <a:solidFill>
-            <a:srgbClr val="003C6C"/>
+            <a:srgbClr val="E4572E"/>
           </a:solidFill>
           <a:ln w="12700">
             <a:solidFill>
-              <a:srgbClr val="003C6C"/>
+              <a:srgbClr val="E4572E"/>
             </a:solidFill>
             <a:prstDash val="solid"/>
           </a:ln>
@@ -7486,8 +7487,8 @@
         </p:nvSpPr>
         <p:spPr>
           <a:xfrm>
-            <a:off x="1417320" y="1490472"/>
-            <a:ext cx="4251960" cy="365760"/>
+            <a:off x="1417320" y="1463040"/>
+            <a:ext cx="4800600" cy="777240"/>
           </a:xfrm>
           <a:prstGeom prst="rect">
             <a:avLst/>
@@ -7511,7 +7512,7 @@
                 <a:ea typeface="Calibri" pitchFamily="34" charset="-122"/>
                 <a:cs typeface="Calibri" pitchFamily="34" charset="-120"/>
               </a:rPr>
-              <a:t>Search a sequence</a:t>
+              <a:t>Search a sequence across all 464 HPRC haplotypes</a:t>
             </a:r>
             <a:endParaRPr lang="en-US" sz="2000" dirty="0"/>
           </a:p>
@@ -7525,8 +7526,8 @@
         </p:nvSpPr>
         <p:spPr>
           <a:xfrm>
-            <a:off x="1417320" y="1892808"/>
-            <a:ext cx="4251960" cy="365760"/>
+            <a:off x="1417320" y="2221992"/>
+            <a:ext cx="4800600" cy="365760"/>
           </a:xfrm>
           <a:prstGeom prst="rect">
             <a:avLst/>
@@ -7542,7 +7543,7 @@
               <a:buNone/>
             </a:pPr>
             <a:r>
-              <a:rPr lang="en-US" sz="1700" dirty="0">
+              <a:rPr lang="en-US" sz="1500" dirty="0">
                 <a:solidFill>
                   <a:srgbClr val="5B6B7C"/>
                 </a:solidFill>
@@ -7550,9 +7551,9 @@
                 <a:ea typeface="Calibri" pitchFamily="34" charset="-122"/>
                 <a:cs typeface="Calibri" pitchFamily="34" charset="-120"/>
               </a:rPr>
-              <a:t>BLAT: one assembly at a time</a:t>
-            </a:r>
-            <a:endParaRPr lang="en-US" sz="1700" dirty="0"/>
+              <a:t>today: BLAT, one assembly at a time</a:t>
+            </a:r>
+            <a:endParaRPr lang="en-US" sz="1500" dirty="0"/>
           </a:p>
         </p:txBody>
       </p:sp>
@@ -7564,18 +7565,18 @@
         </p:nvSpPr>
         <p:spPr>
           <a:xfrm>
-            <a:off x="548640" y="2926080"/>
+            <a:off x="548640" y="2971800"/>
             <a:ext cx="640080" cy="640080"/>
           </a:xfrm>
           <a:prstGeom prst="ellipse">
             <a:avLst/>
           </a:prstGeom>
           <a:solidFill>
-            <a:srgbClr val="003C6C"/>
+            <a:srgbClr val="E4572E"/>
           </a:solidFill>
           <a:ln w="12700">
             <a:solidFill>
-              <a:srgbClr val="003C6C"/>
+              <a:srgbClr val="E4572E"/>
             </a:solidFill>
             <a:prstDash val="solid"/>
           </a:ln>
@@ -7597,7 +7598,7 @@
         </p:blipFill>
         <p:spPr>
           <a:xfrm>
-            <a:off x="715061" y="3092501"/>
+            <a:off x="715061" y="3138221"/>
             <a:ext cx="307238" cy="307238"/>
           </a:xfrm>
           <a:prstGeom prst="rect">
@@ -7613,8 +7614,8 @@
         </p:nvSpPr>
         <p:spPr>
           <a:xfrm>
-            <a:off x="1417320" y="2907792"/>
-            <a:ext cx="4251960" cy="365760"/>
+            <a:off x="1417320" y="2926080"/>
+            <a:ext cx="4800600" cy="777240"/>
           </a:xfrm>
           <a:prstGeom prst="rect">
             <a:avLst/>
@@ -7638,7 +7639,7 @@
                 <a:ea typeface="Calibri" pitchFamily="34" charset="-122"/>
                 <a:cs typeface="Calibri" pitchFamily="34" charset="-120"/>
               </a:rPr>
-              <a:t>Move a locus to another assembly</a:t>
+              <a:t>Move a locus onto any HPRC haplotype</a:t>
             </a:r>
             <a:endParaRPr lang="en-US" sz="2000" dirty="0"/>
           </a:p>
@@ -7652,8 +7653,8 @@
         </p:nvSpPr>
         <p:spPr>
           <a:xfrm>
-            <a:off x="1417320" y="3310128"/>
-            <a:ext cx="4251960" cy="365760"/>
+            <a:off x="1417320" y="3685032"/>
+            <a:ext cx="4800600" cy="365760"/>
           </a:xfrm>
           <a:prstGeom prst="rect">
             <a:avLst/>
@@ -7669,7 +7670,7 @@
               <a:buNone/>
             </a:pPr>
             <a:r>
-              <a:rPr lang="en-US" sz="1700" dirty="0">
+              <a:rPr lang="en-US" sz="1500" dirty="0">
                 <a:solidFill>
                   <a:srgbClr val="5B6B7C"/>
                 </a:solidFill>
@@ -7677,9 +7678,9 @@
                 <a:ea typeface="Calibri" pitchFamily="34" charset="-122"/>
                 <a:cs typeface="Calibri" pitchFamily="34" charset="-120"/>
               </a:rPr>
-              <a:t>QuickLift: only where a chain exists</a:t>
-            </a:r>
-            <a:endParaRPr lang="en-US" sz="1700" dirty="0"/>
+              <a:t>today: only between the few assembly pairs with a prebuilt chain</a:t>
+            </a:r>
+            <a:endParaRPr lang="en-US" sz="1500" dirty="0"/>
           </a:p>
         </p:txBody>
       </p:sp>
@@ -7691,18 +7692,18 @@
         </p:nvSpPr>
         <p:spPr>
           <a:xfrm>
-            <a:off x="548640" y="4343400"/>
+            <a:off x="548640" y="4434840"/>
             <a:ext cx="640080" cy="640080"/>
           </a:xfrm>
           <a:prstGeom prst="ellipse">
             <a:avLst/>
           </a:prstGeom>
           <a:solidFill>
-            <a:srgbClr val="003C6C"/>
+            <a:srgbClr val="E4572E"/>
           </a:solidFill>
           <a:ln w="12700">
             <a:solidFill>
-              <a:srgbClr val="003C6C"/>
+              <a:srgbClr val="E4572E"/>
             </a:solidFill>
             <a:prstDash val="solid"/>
           </a:ln>
@@ -7724,7 +7725,7 @@
         </p:blipFill>
         <p:spPr>
           <a:xfrm>
-            <a:off x="715061" y="4509821"/>
+            <a:off x="715061" y="4601261"/>
             <a:ext cx="307238" cy="307238"/>
           </a:xfrm>
           <a:prstGeom prst="rect">
@@ -7740,8 +7741,8 @@
         </p:nvSpPr>
         <p:spPr>
           <a:xfrm>
-            <a:off x="1417320" y="4325112"/>
-            <a:ext cx="4251960" cy="365760"/>
+            <a:off x="1417320" y="4389120"/>
+            <a:ext cx="4800600" cy="777240"/>
           </a:xfrm>
           <a:prstGeom prst="rect">
             <a:avLst/>
@@ -7765,7 +7766,7 @@
                 <a:ea typeface="Calibri" pitchFamily="34" charset="-122"/>
                 <a:cs typeface="Calibri" pitchFamily="34" charset="-120"/>
               </a:rPr>
-              <a:t>Use the release 2 graph</a:t>
+              <a:t>See the reference's annotation on an HPRC haplotype</a:t>
             </a:r>
             <a:endParaRPr lang="en-US" sz="2000" dirty="0"/>
           </a:p>
@@ -7779,8 +7780,8 @@
         </p:nvSpPr>
         <p:spPr>
           <a:xfrm>
-            <a:off x="1417320" y="4727448"/>
-            <a:ext cx="4251960" cy="365760"/>
+            <a:off x="1417320" y="5148072"/>
+            <a:ext cx="4800600" cy="365760"/>
           </a:xfrm>
           <a:prstGeom prst="rect">
             <a:avLst/>
@@ -7796,17 +7797,17 @@
               <a:buNone/>
             </a:pPr>
             <a:r>
-              <a:rPr lang="en-US" sz="1700" dirty="0">
-                <a:solidFill>
-                  <a:srgbClr val="E4572E"/>
-                </a:solidFill>
-                <a:latin typeface="Calibri" pitchFamily="34" charset="0"/>
-                <a:ea typeface="Calibri" pitchFamily="34" charset="-122"/>
-                <a:cs typeface="Calibri" pitchFamily="34" charset="-120"/>
-              </a:rPr>
-              <a:t>not possible</a:t>
-            </a:r>
-            <a:endParaRPr lang="en-US" sz="1700" dirty="0"/>
+              <a:rPr lang="en-US" sz="1500" dirty="0">
+                <a:solidFill>
+                  <a:srgbClr val="5B6B7C"/>
+                </a:solidFill>
+                <a:latin typeface="Calibri" pitchFamily="34" charset="0"/>
+                <a:ea typeface="Calibri" pitchFamily="34" charset="-122"/>
+                <a:cs typeface="Calibri" pitchFamily="34" charset="-120"/>
+              </a:rPr>
+              <a:t>today: only for those same few pairs</a:t>
+            </a:r>
+            <a:endParaRPr lang="en-US" sz="1500" dirty="0"/>
           </a:p>
         </p:txBody>
       </p:sp>
@@ -7826,8 +7827,8 @@
         </p:blipFill>
         <p:spPr>
           <a:xfrm>
-            <a:off x="6126480" y="1874520"/>
-            <a:ext cx="5516575" cy="1946560"/>
+            <a:off x="6675120" y="1874520"/>
+            <a:ext cx="4967935" cy="1752969"/>
           </a:xfrm>
           <a:prstGeom prst="rect">
             <a:avLst/>
@@ -7842,8 +7843,8 @@
         </p:nvSpPr>
         <p:spPr>
           <a:xfrm>
-            <a:off x="6126480" y="4003960"/>
-            <a:ext cx="5516575" cy="731520"/>
+            <a:off x="6675120" y="3810369"/>
+            <a:ext cx="4967935" cy="731520"/>
           </a:xfrm>
           <a:prstGeom prst="rect">
             <a:avLst/>

</xml_diff>

<commit_message>
Talk: roadmap slide with release, invisible translation, variant-to-haplotypes, and ancestry
</commit_message>
<xml_diff>
--- a/talk/HPRC2026_talk.pptx
+++ b/talk/HPRC2026_talk.pptx
@@ -968,8 +968,11 @@
             <a:r>
               <a:rPr lang="en-US" dirty="0"/>
               <a:t>Talking points:
-- what is done, what is planned
-- invite people to try it on the development browser</a:t>
+- release: both tools in the public browser; development browser today
+- translation already flows from In Other Genomes; it should be invisible everywhere
+- HPRC variant tracks on GRCh38: click a variant, see its release 2 carriers, go there
+- pclai local ancestry: color the carriers; helps pick which haplotypes to look at
+- the point: the pangenome as a thing browser users work with</a:t>
             </a:r>
             <a:endParaRPr lang="en-US" dirty="0"/>
           </a:p>
@@ -5125,7 +5128,7 @@
     <p:bg>
       <p:bgPr>
         <a:solidFill>
-          <a:srgbClr val="06294A"/>
+          <a:srgbClr val="FFFFFF"/>
         </a:solidFill>
       </p:bgPr>
     </p:bg>
@@ -5151,6 +5154,45 @@
         </p:nvSpPr>
         <p:spPr>
           <a:xfrm>
+            <a:off x="548640" y="384048"/>
+            <a:ext cx="8991295" cy="713232"/>
+          </a:xfrm>
+          <a:prstGeom prst="rect">
+            <a:avLst/>
+          </a:prstGeom>
+          <a:noFill/>
+          <a:ln/>
+        </p:spPr>
+        <p:txBody>
+          <a:bodyPr wrap="square" lIns="0" tIns="0" rIns="0" bIns="0" rtlCol="0" anchor="ctr"/>
+          <a:lstStyle/>
+          <a:p>
+            <a:pPr indent="0" marL="0">
+              <a:buNone/>
+            </a:pPr>
+            <a:r>
+              <a:rPr lang="en-US" sz="3200" b="1" dirty="0">
+                <a:solidFill>
+                  <a:srgbClr val="003C6C"/>
+                </a:solidFill>
+                <a:latin typeface="Calibri" pitchFamily="34" charset="0"/>
+                <a:ea typeface="Calibri" pitchFamily="34" charset="-122"/>
+                <a:cs typeface="Calibri" pitchFamily="34" charset="-120"/>
+              </a:rPr>
+              <a:t>Roadmap</a:t>
+            </a:r>
+            <a:endParaRPr lang="en-US" sz="3200" dirty="0"/>
+          </a:p>
+        </p:txBody>
+      </p:sp>
+      <p:sp>
+        <p:nvSpPr>
+          <p:cNvPr id="3" name="Text 1"/>
+          <p:cNvSpPr txBox="1"/>
+          <p:nvPr/>
+        </p:nvSpPr>
+        <p:spPr>
+          <a:xfrm>
             <a:off x="11185855" y="6446520"/>
             <a:ext cx="457200" cy="274320"/>
           </a:xfrm>
@@ -5170,7 +5212,7 @@
             <a:r>
               <a:rPr lang="en-US" sz="1000" dirty="0">
                 <a:solidFill>
-                  <a:srgbClr val="3D5A7A"/>
+                  <a:srgbClr val="D9E1E9"/>
                 </a:solidFill>
                 <a:latin typeface="Calibri" pitchFamily="34" charset="0"/>
                 <a:ea typeface="Calibri" pitchFamily="34" charset="-122"/>
@@ -5184,13 +5226,785 @@
       </p:sp>
       <p:sp>
         <p:nvSpPr>
-          <p:cNvPr id="3" name="Text 1"/>
-          <p:cNvSpPr txBox="1"/>
-          <p:nvPr/>
-        </p:nvSpPr>
-        <p:spPr>
-          <a:xfrm>
-            <a:off x="548640" y="1463040"/>
+          <p:cNvPr id="4" name="Shape 2"/>
+          <p:cNvSpPr/>
+          <p:nvPr/>
+        </p:nvSpPr>
+        <p:spPr>
+          <a:xfrm>
+            <a:off x="548640" y="1325880"/>
+            <a:ext cx="5364328" cy="2240280"/>
+          </a:xfrm>
+          <a:prstGeom prst="roundRect">
+            <a:avLst>
+              <a:gd name="adj" fmla="val 4898"/>
+            </a:avLst>
+          </a:prstGeom>
+          <a:solidFill>
+            <a:srgbClr val="EDF1F6"/>
+          </a:solidFill>
+          <a:ln w="12700">
+            <a:solidFill>
+              <a:srgbClr val="DCE3EB"/>
+            </a:solidFill>
+            <a:prstDash val="solid"/>
+          </a:ln>
+        </p:spPr>
+      </p:sp>
+      <p:sp>
+        <p:nvSpPr>
+          <p:cNvPr id="5" name="Shape 3"/>
+          <p:cNvSpPr/>
+          <p:nvPr/>
+        </p:nvSpPr>
+        <p:spPr>
+          <a:xfrm>
+            <a:off x="868680" y="1645920"/>
+            <a:ext cx="685800" cy="685800"/>
+          </a:xfrm>
+          <a:prstGeom prst="ellipse">
+            <a:avLst/>
+          </a:prstGeom>
+          <a:solidFill>
+            <a:srgbClr val="003C6C"/>
+          </a:solidFill>
+          <a:ln w="12700">
+            <a:solidFill>
+              <a:srgbClr val="003C6C"/>
+            </a:solidFill>
+            <a:prstDash val="solid"/>
+          </a:ln>
+        </p:spPr>
+      </p:sp>
+      <p:pic>
+        <p:nvPicPr>
+          <p:cNvPr id="6" name="Image 0" descr="preencoded.png">    </p:cNvPr>
+          <p:cNvPicPr>
+            <a:picLocks noChangeAspect="1"/>
+          </p:cNvPicPr>
+          <p:nvPr/>
+        </p:nvPicPr>
+        <p:blipFill>
+          <a:blip r:embed="rId1"/>
+          <a:stretch>
+            <a:fillRect/>
+          </a:stretch>
+        </p:blipFill>
+        <p:spPr>
+          <a:xfrm>
+            <a:off x="1046988" y="1824228"/>
+            <a:ext cx="329184" cy="329184"/>
+          </a:xfrm>
+          <a:prstGeom prst="rect">
+            <a:avLst/>
+          </a:prstGeom>
+        </p:spPr>
+      </p:pic>
+      <p:sp>
+        <p:nvSpPr>
+          <p:cNvPr id="7" name="Text 4"/>
+          <p:cNvSpPr txBox="1"/>
+          <p:nvPr/>
+        </p:nvSpPr>
+        <p:spPr>
+          <a:xfrm>
+            <a:off x="4449928" y="1691640"/>
+            <a:ext cx="1143000" cy="274320"/>
+          </a:xfrm>
+          <a:prstGeom prst="rect">
+            <a:avLst/>
+          </a:prstGeom>
+          <a:noFill/>
+          <a:ln/>
+        </p:spPr>
+        <p:txBody>
+          <a:bodyPr wrap="square" lIns="0" tIns="0" rIns="0" bIns="0" rtlCol="0" anchor="t"/>
+          <a:lstStyle/>
+          <a:p>
+            <a:pPr algn="r" indent="0" marL="0">
+              <a:buNone/>
+            </a:pPr>
+            <a:r>
+              <a:rPr lang="en-US" sz="1200" b="1" spc="200" kern="0" dirty="0">
+                <a:solidFill>
+                  <a:srgbClr val="003C6C"/>
+                </a:solidFill>
+                <a:latin typeface="Calibri" pitchFamily="34" charset="0"/>
+                <a:ea typeface="Calibri" pitchFamily="34" charset="-122"/>
+                <a:cs typeface="Calibri" pitchFamily="34" charset="-120"/>
+              </a:rPr>
+              <a:t>next</a:t>
+            </a:r>
+            <a:endParaRPr lang="en-US" sz="1200" dirty="0"/>
+          </a:p>
+        </p:txBody>
+      </p:sp>
+      <p:sp>
+        <p:nvSpPr>
+          <p:cNvPr id="8" name="Text 5"/>
+          <p:cNvSpPr txBox="1"/>
+          <p:nvPr/>
+        </p:nvSpPr>
+        <p:spPr>
+          <a:xfrm>
+            <a:off x="1737360" y="1737360"/>
+            <a:ext cx="2621128" cy="548640"/>
+          </a:xfrm>
+          <a:prstGeom prst="rect">
+            <a:avLst/>
+          </a:prstGeom>
+          <a:noFill/>
+          <a:ln/>
+        </p:spPr>
+        <p:txBody>
+          <a:bodyPr wrap="square" lIns="0" tIns="0" rIns="0" bIns="0" rtlCol="0" anchor="ctr"/>
+          <a:lstStyle/>
+          <a:p>
+            <a:pPr indent="0" marL="0">
+              <a:buNone/>
+            </a:pPr>
+            <a:r>
+              <a:rPr lang="en-US" sz="2100" b="1" dirty="0">
+                <a:solidFill>
+                  <a:srgbClr val="003C6C"/>
+                </a:solidFill>
+                <a:latin typeface="Calibri" pitchFamily="34" charset="0"/>
+                <a:ea typeface="Calibri" pitchFamily="34" charset="-122"/>
+                <a:cs typeface="Calibri" pitchFamily="34" charset="-120"/>
+              </a:rPr>
+              <a:t>Public release</a:t>
+            </a:r>
+            <a:endParaRPr lang="en-US" sz="2100" dirty="0"/>
+          </a:p>
+        </p:txBody>
+      </p:sp>
+      <p:sp>
+        <p:nvSpPr>
+          <p:cNvPr id="9" name="Text 6"/>
+          <p:cNvSpPr txBox="1"/>
+          <p:nvPr/>
+        </p:nvSpPr>
+        <p:spPr>
+          <a:xfrm>
+            <a:off x="868680" y="2514600"/>
+            <a:ext cx="4724248" cy="960120"/>
+          </a:xfrm>
+          <a:prstGeom prst="rect">
+            <a:avLst/>
+          </a:prstGeom>
+          <a:noFill/>
+          <a:ln/>
+        </p:spPr>
+        <p:txBody>
+          <a:bodyPr wrap="square" lIns="0" tIns="0" rIns="0" bIns="0" rtlCol="0" anchor="t"/>
+          <a:lstStyle/>
+          <a:p>
+            <a:pPr indent="0" marL="0">
+              <a:buNone/>
+            </a:pPr>
+            <a:r>
+              <a:rPr lang="en-US" sz="1600" dirty="0">
+                <a:solidFill>
+                  <a:srgbClr val="18293B"/>
+                </a:solidFill>
+                <a:latin typeface="Calibri" pitchFamily="34" charset="0"/>
+                <a:ea typeface="Calibri" pitchFamily="34" charset="-122"/>
+                <a:cs typeface="Calibri" pitchFamily="34" charset="-120"/>
+              </a:rPr>
+              <a:t>Both tools in the UCSC Genome Browser. On the development browser now.</a:t>
+            </a:r>
+            <a:endParaRPr lang="en-US" sz="1600" dirty="0"/>
+          </a:p>
+        </p:txBody>
+      </p:sp>
+      <p:sp>
+        <p:nvSpPr>
+          <p:cNvPr id="10" name="Shape 7"/>
+          <p:cNvSpPr/>
+          <p:nvPr/>
+        </p:nvSpPr>
+        <p:spPr>
+          <a:xfrm>
+            <a:off x="6278728" y="1325880"/>
+            <a:ext cx="5364328" cy="2240280"/>
+          </a:xfrm>
+          <a:prstGeom prst="roundRect">
+            <a:avLst>
+              <a:gd name="adj" fmla="val 4898"/>
+            </a:avLst>
+          </a:prstGeom>
+          <a:solidFill>
+            <a:srgbClr val="EDF1F6"/>
+          </a:solidFill>
+          <a:ln w="12700">
+            <a:solidFill>
+              <a:srgbClr val="DCE3EB"/>
+            </a:solidFill>
+            <a:prstDash val="solid"/>
+          </a:ln>
+        </p:spPr>
+      </p:sp>
+      <p:sp>
+        <p:nvSpPr>
+          <p:cNvPr id="11" name="Shape 8"/>
+          <p:cNvSpPr/>
+          <p:nvPr/>
+        </p:nvSpPr>
+        <p:spPr>
+          <a:xfrm>
+            <a:off x="6598768" y="1645920"/>
+            <a:ext cx="685800" cy="685800"/>
+          </a:xfrm>
+          <a:prstGeom prst="ellipse">
+            <a:avLst/>
+          </a:prstGeom>
+          <a:solidFill>
+            <a:srgbClr val="003C6C"/>
+          </a:solidFill>
+          <a:ln w="12700">
+            <a:solidFill>
+              <a:srgbClr val="003C6C"/>
+            </a:solidFill>
+            <a:prstDash val="solid"/>
+          </a:ln>
+        </p:spPr>
+      </p:sp>
+      <p:pic>
+        <p:nvPicPr>
+          <p:cNvPr id="12" name="Image 1" descr="preencoded.png">    </p:cNvPr>
+          <p:cNvPicPr>
+            <a:picLocks noChangeAspect="1"/>
+          </p:cNvPicPr>
+          <p:nvPr/>
+        </p:nvPicPr>
+        <p:blipFill>
+          <a:blip r:embed="rId2"/>
+          <a:stretch>
+            <a:fillRect/>
+          </a:stretch>
+        </p:blipFill>
+        <p:spPr>
+          <a:xfrm>
+            <a:off x="6777076" y="1824228"/>
+            <a:ext cx="329184" cy="329184"/>
+          </a:xfrm>
+          <a:prstGeom prst="rect">
+            <a:avLst/>
+          </a:prstGeom>
+        </p:spPr>
+      </p:pic>
+      <p:sp>
+        <p:nvSpPr>
+          <p:cNvPr id="13" name="Text 9"/>
+          <p:cNvSpPr txBox="1"/>
+          <p:nvPr/>
+        </p:nvSpPr>
+        <p:spPr>
+          <a:xfrm>
+            <a:off x="10180015" y="1691640"/>
+            <a:ext cx="1143000" cy="274320"/>
+          </a:xfrm>
+          <a:prstGeom prst="rect">
+            <a:avLst/>
+          </a:prstGeom>
+          <a:noFill/>
+          <a:ln/>
+        </p:spPr>
+        <p:txBody>
+          <a:bodyPr wrap="square" lIns="0" tIns="0" rIns="0" bIns="0" rtlCol="0" anchor="t"/>
+          <a:lstStyle/>
+          <a:p>
+            <a:pPr algn="r" indent="0" marL="0">
+              <a:buNone/>
+            </a:pPr>
+            <a:r>
+              <a:rPr lang="en-US" sz="1200" b="1" spc="200" kern="0" dirty="0">
+                <a:solidFill>
+                  <a:srgbClr val="003C6C"/>
+                </a:solidFill>
+                <a:latin typeface="Calibri" pitchFamily="34" charset="0"/>
+                <a:ea typeface="Calibri" pitchFamily="34" charset="-122"/>
+                <a:cs typeface="Calibri" pitchFamily="34" charset="-120"/>
+              </a:rPr>
+              <a:t>next</a:t>
+            </a:r>
+            <a:endParaRPr lang="en-US" sz="1200" dirty="0"/>
+          </a:p>
+        </p:txBody>
+      </p:sp>
+      <p:sp>
+        <p:nvSpPr>
+          <p:cNvPr id="14" name="Text 10"/>
+          <p:cNvSpPr txBox="1"/>
+          <p:nvPr/>
+        </p:nvSpPr>
+        <p:spPr>
+          <a:xfrm>
+            <a:off x="7467448" y="1737360"/>
+            <a:ext cx="2621128" cy="548640"/>
+          </a:xfrm>
+          <a:prstGeom prst="rect">
+            <a:avLst/>
+          </a:prstGeom>
+          <a:noFill/>
+          <a:ln/>
+        </p:spPr>
+        <p:txBody>
+          <a:bodyPr wrap="square" lIns="0" tIns="0" rIns="0" bIns="0" rtlCol="0" anchor="ctr"/>
+          <a:lstStyle/>
+          <a:p>
+            <a:pPr indent="0" marL="0">
+              <a:buNone/>
+            </a:pPr>
+            <a:r>
+              <a:rPr lang="en-US" sz="2100" b="1" dirty="0">
+                <a:solidFill>
+                  <a:srgbClr val="003C6C"/>
+                </a:solidFill>
+                <a:latin typeface="Calibri" pitchFamily="34" charset="0"/>
+                <a:ea typeface="Calibri" pitchFamily="34" charset="-122"/>
+                <a:cs typeface="Calibri" pitchFamily="34" charset="-120"/>
+              </a:rPr>
+              <a:t>Translation that just works</a:t>
+            </a:r>
+            <a:endParaRPr lang="en-US" sz="2100" dirty="0"/>
+          </a:p>
+        </p:txBody>
+      </p:sp>
+      <p:sp>
+        <p:nvSpPr>
+          <p:cNvPr id="15" name="Text 11"/>
+          <p:cNvSpPr txBox="1"/>
+          <p:nvPr/>
+        </p:nvSpPr>
+        <p:spPr>
+          <a:xfrm>
+            <a:off x="6598768" y="2514600"/>
+            <a:ext cx="4724248" cy="960120"/>
+          </a:xfrm>
+          <a:prstGeom prst="rect">
+            <a:avLst/>
+          </a:prstGeom>
+          <a:noFill/>
+          <a:ln/>
+        </p:spPr>
+        <p:txBody>
+          <a:bodyPr wrap="square" lIns="0" tIns="0" rIns="0" bIns="0" rtlCol="0" anchor="t"/>
+          <a:lstStyle/>
+          <a:p>
+            <a:pPr indent="0" marL="0">
+              <a:buNone/>
+            </a:pPr>
+            <a:r>
+              <a:rPr lang="en-US" sz="1600" dirty="0">
+                <a:solidFill>
+                  <a:srgbClr val="18293B"/>
+                </a:solidFill>
+                <a:latin typeface="Calibri" pitchFamily="34" charset="0"/>
+                <a:ea typeface="Calibri" pitchFamily="34" charset="-122"/>
+                <a:cs typeface="Calibri" pitchFamily="34" charset="-120"/>
+              </a:rPr>
+              <a:t>Coordinates and tracks follow you from haplotype to haplotype. No conversion step to think about.</a:t>
+            </a:r>
+            <a:endParaRPr lang="en-US" sz="1600" dirty="0"/>
+          </a:p>
+        </p:txBody>
+      </p:sp>
+      <p:sp>
+        <p:nvSpPr>
+          <p:cNvPr id="16" name="Shape 12"/>
+          <p:cNvSpPr/>
+          <p:nvPr/>
+        </p:nvSpPr>
+        <p:spPr>
+          <a:xfrm>
+            <a:off x="548640" y="3840480"/>
+            <a:ext cx="5364328" cy="2240280"/>
+          </a:xfrm>
+          <a:prstGeom prst="roundRect">
+            <a:avLst>
+              <a:gd name="adj" fmla="val 4898"/>
+            </a:avLst>
+          </a:prstGeom>
+          <a:solidFill>
+            <a:srgbClr val="EDF1F6"/>
+          </a:solidFill>
+          <a:ln w="12700">
+            <a:solidFill>
+              <a:srgbClr val="DCE3EB"/>
+            </a:solidFill>
+            <a:prstDash val="solid"/>
+          </a:ln>
+        </p:spPr>
+      </p:sp>
+      <p:sp>
+        <p:nvSpPr>
+          <p:cNvPr id="17" name="Shape 13"/>
+          <p:cNvSpPr/>
+          <p:nvPr/>
+        </p:nvSpPr>
+        <p:spPr>
+          <a:xfrm>
+            <a:off x="868680" y="4160520"/>
+            <a:ext cx="685800" cy="685800"/>
+          </a:xfrm>
+          <a:prstGeom prst="ellipse">
+            <a:avLst/>
+          </a:prstGeom>
+          <a:solidFill>
+            <a:srgbClr val="0E7C9C"/>
+          </a:solidFill>
+          <a:ln w="12700">
+            <a:solidFill>
+              <a:srgbClr val="0E7C9C"/>
+            </a:solidFill>
+            <a:prstDash val="solid"/>
+          </a:ln>
+        </p:spPr>
+      </p:sp>
+      <p:pic>
+        <p:nvPicPr>
+          <p:cNvPr id="18" name="Image 2" descr="preencoded.png">    </p:cNvPr>
+          <p:cNvPicPr>
+            <a:picLocks noChangeAspect="1"/>
+          </p:cNvPicPr>
+          <p:nvPr/>
+        </p:nvPicPr>
+        <p:blipFill>
+          <a:blip r:embed="rId3"/>
+          <a:stretch>
+            <a:fillRect/>
+          </a:stretch>
+        </p:blipFill>
+        <p:spPr>
+          <a:xfrm>
+            <a:off x="1046988" y="4338828"/>
+            <a:ext cx="329184" cy="329184"/>
+          </a:xfrm>
+          <a:prstGeom prst="rect">
+            <a:avLst/>
+          </a:prstGeom>
+        </p:spPr>
+      </p:pic>
+      <p:sp>
+        <p:nvSpPr>
+          <p:cNvPr id="19" name="Text 14"/>
+          <p:cNvSpPr txBox="1"/>
+          <p:nvPr/>
+        </p:nvSpPr>
+        <p:spPr>
+          <a:xfrm>
+            <a:off x="4449928" y="4206240"/>
+            <a:ext cx="1143000" cy="274320"/>
+          </a:xfrm>
+          <a:prstGeom prst="rect">
+            <a:avLst/>
+          </a:prstGeom>
+          <a:noFill/>
+          <a:ln/>
+        </p:spPr>
+        <p:txBody>
+          <a:bodyPr wrap="square" lIns="0" tIns="0" rIns="0" bIns="0" rtlCol="0" anchor="t"/>
+          <a:lstStyle/>
+          <a:p>
+            <a:pPr algn="r" indent="0" marL="0">
+              <a:buNone/>
+            </a:pPr>
+            <a:r>
+              <a:rPr lang="en-US" sz="1200" b="1" spc="200" kern="0" dirty="0">
+                <a:solidFill>
+                  <a:srgbClr val="0E7C9C"/>
+                </a:solidFill>
+                <a:latin typeface="Calibri" pitchFamily="34" charset="0"/>
+                <a:ea typeface="Calibri" pitchFamily="34" charset="-122"/>
+                <a:cs typeface="Calibri" pitchFamily="34" charset="-120"/>
+              </a:rPr>
+              <a:t>planned</a:t>
+            </a:r>
+            <a:endParaRPr lang="en-US" sz="1200" dirty="0"/>
+          </a:p>
+        </p:txBody>
+      </p:sp>
+      <p:sp>
+        <p:nvSpPr>
+          <p:cNvPr id="20" name="Text 15"/>
+          <p:cNvSpPr txBox="1"/>
+          <p:nvPr/>
+        </p:nvSpPr>
+        <p:spPr>
+          <a:xfrm>
+            <a:off x="1737360" y="4251960"/>
+            <a:ext cx="2621128" cy="548640"/>
+          </a:xfrm>
+          <a:prstGeom prst="rect">
+            <a:avLst/>
+          </a:prstGeom>
+          <a:noFill/>
+          <a:ln/>
+        </p:spPr>
+        <p:txBody>
+          <a:bodyPr wrap="square" lIns="0" tIns="0" rIns="0" bIns="0" rtlCol="0" anchor="ctr"/>
+          <a:lstStyle/>
+          <a:p>
+            <a:pPr indent="0" marL="0">
+              <a:buNone/>
+            </a:pPr>
+            <a:r>
+              <a:rPr lang="en-US" sz="2100" b="1" dirty="0">
+                <a:solidFill>
+                  <a:srgbClr val="003C6C"/>
+                </a:solidFill>
+                <a:latin typeface="Calibri" pitchFamily="34" charset="0"/>
+                <a:ea typeface="Calibri" pitchFamily="34" charset="-122"/>
+                <a:cs typeface="Calibri" pitchFamily="34" charset="-120"/>
+              </a:rPr>
+              <a:t>From a variant to its haplotypes</a:t>
+            </a:r>
+            <a:endParaRPr lang="en-US" sz="2100" dirty="0"/>
+          </a:p>
+        </p:txBody>
+      </p:sp>
+      <p:sp>
+        <p:nvSpPr>
+          <p:cNvPr id="21" name="Text 16"/>
+          <p:cNvSpPr txBox="1"/>
+          <p:nvPr/>
+        </p:nvSpPr>
+        <p:spPr>
+          <a:xfrm>
+            <a:off x="868680" y="5029200"/>
+            <a:ext cx="4724248" cy="960120"/>
+          </a:xfrm>
+          <a:prstGeom prst="rect">
+            <a:avLst/>
+          </a:prstGeom>
+          <a:noFill/>
+          <a:ln/>
+        </p:spPr>
+        <p:txBody>
+          <a:bodyPr wrap="square" lIns="0" tIns="0" rIns="0" bIns="0" rtlCol="0" anchor="t"/>
+          <a:lstStyle/>
+          <a:p>
+            <a:pPr indent="0" marL="0">
+              <a:buNone/>
+            </a:pPr>
+            <a:r>
+              <a:rPr lang="en-US" sz="1600" dirty="0">
+                <a:solidFill>
+                  <a:srgbClr val="18293B"/>
+                </a:solidFill>
+                <a:latin typeface="Calibri" pitchFamily="34" charset="0"/>
+                <a:ea typeface="Calibri" pitchFamily="34" charset="-122"/>
+                <a:cs typeface="Calibri" pitchFamily="34" charset="-120"/>
+              </a:rPr>
+              <a:t>Click an HPRC variant on GRCh38, see which release 2 haplotypes carry it, and jump to the sequence there.</a:t>
+            </a:r>
+            <a:endParaRPr lang="en-US" sz="1600" dirty="0"/>
+          </a:p>
+        </p:txBody>
+      </p:sp>
+      <p:sp>
+        <p:nvSpPr>
+          <p:cNvPr id="22" name="Shape 17"/>
+          <p:cNvSpPr/>
+          <p:nvPr/>
+        </p:nvSpPr>
+        <p:spPr>
+          <a:xfrm>
+            <a:off x="6278728" y="3840480"/>
+            <a:ext cx="5364328" cy="2240280"/>
+          </a:xfrm>
+          <a:prstGeom prst="roundRect">
+            <a:avLst>
+              <a:gd name="adj" fmla="val 4898"/>
+            </a:avLst>
+          </a:prstGeom>
+          <a:solidFill>
+            <a:srgbClr val="EDF1F6"/>
+          </a:solidFill>
+          <a:ln w="12700">
+            <a:solidFill>
+              <a:srgbClr val="DCE3EB"/>
+            </a:solidFill>
+            <a:prstDash val="solid"/>
+          </a:ln>
+        </p:spPr>
+      </p:sp>
+      <p:sp>
+        <p:nvSpPr>
+          <p:cNvPr id="23" name="Shape 18"/>
+          <p:cNvSpPr/>
+          <p:nvPr/>
+        </p:nvSpPr>
+        <p:spPr>
+          <a:xfrm>
+            <a:off x="6598768" y="4160520"/>
+            <a:ext cx="685800" cy="685800"/>
+          </a:xfrm>
+          <a:prstGeom prst="ellipse">
+            <a:avLst/>
+          </a:prstGeom>
+          <a:solidFill>
+            <a:srgbClr val="0E7C9C"/>
+          </a:solidFill>
+          <a:ln w="12700">
+            <a:solidFill>
+              <a:srgbClr val="0E7C9C"/>
+            </a:solidFill>
+            <a:prstDash val="solid"/>
+          </a:ln>
+        </p:spPr>
+      </p:sp>
+      <p:pic>
+        <p:nvPicPr>
+          <p:cNvPr id="24" name="Image 3" descr="preencoded.png">    </p:cNvPr>
+          <p:cNvPicPr>
+            <a:picLocks noChangeAspect="1"/>
+          </p:cNvPicPr>
+          <p:nvPr/>
+        </p:nvPicPr>
+        <p:blipFill>
+          <a:blip r:embed="rId4"/>
+          <a:stretch>
+            <a:fillRect/>
+          </a:stretch>
+        </p:blipFill>
+        <p:spPr>
+          <a:xfrm>
+            <a:off x="6777076" y="4338828"/>
+            <a:ext cx="329184" cy="329184"/>
+          </a:xfrm>
+          <a:prstGeom prst="rect">
+            <a:avLst/>
+          </a:prstGeom>
+        </p:spPr>
+      </p:pic>
+      <p:sp>
+        <p:nvSpPr>
+          <p:cNvPr id="25" name="Text 19"/>
+          <p:cNvSpPr txBox="1"/>
+          <p:nvPr/>
+        </p:nvSpPr>
+        <p:spPr>
+          <a:xfrm>
+            <a:off x="10180015" y="4206240"/>
+            <a:ext cx="1143000" cy="274320"/>
+          </a:xfrm>
+          <a:prstGeom prst="rect">
+            <a:avLst/>
+          </a:prstGeom>
+          <a:noFill/>
+          <a:ln/>
+        </p:spPr>
+        <p:txBody>
+          <a:bodyPr wrap="square" lIns="0" tIns="0" rIns="0" bIns="0" rtlCol="0" anchor="t"/>
+          <a:lstStyle/>
+          <a:p>
+            <a:pPr algn="r" indent="0" marL="0">
+              <a:buNone/>
+            </a:pPr>
+            <a:r>
+              <a:rPr lang="en-US" sz="1200" b="1" spc="200" kern="0" dirty="0">
+                <a:solidFill>
+                  <a:srgbClr val="0E7C9C"/>
+                </a:solidFill>
+                <a:latin typeface="Calibri" pitchFamily="34" charset="0"/>
+                <a:ea typeface="Calibri" pitchFamily="34" charset="-122"/>
+                <a:cs typeface="Calibri" pitchFamily="34" charset="-120"/>
+              </a:rPr>
+              <a:t>planned</a:t>
+            </a:r>
+            <a:endParaRPr lang="en-US" sz="1200" dirty="0"/>
+          </a:p>
+        </p:txBody>
+      </p:sp>
+      <p:sp>
+        <p:nvSpPr>
+          <p:cNvPr id="26" name="Text 20"/>
+          <p:cNvSpPr txBox="1"/>
+          <p:nvPr/>
+        </p:nvSpPr>
+        <p:spPr>
+          <a:xfrm>
+            <a:off x="7467448" y="4251960"/>
+            <a:ext cx="2621128" cy="548640"/>
+          </a:xfrm>
+          <a:prstGeom prst="rect">
+            <a:avLst/>
+          </a:prstGeom>
+          <a:noFill/>
+          <a:ln/>
+        </p:spPr>
+        <p:txBody>
+          <a:bodyPr wrap="square" lIns="0" tIns="0" rIns="0" bIns="0" rtlCol="0" anchor="ctr"/>
+          <a:lstStyle/>
+          <a:p>
+            <a:pPr indent="0" marL="0">
+              <a:buNone/>
+            </a:pPr>
+            <a:r>
+              <a:rPr lang="en-US" sz="2100" b="1" dirty="0">
+                <a:solidFill>
+                  <a:srgbClr val="003C6C"/>
+                </a:solidFill>
+                <a:latin typeface="Calibri" pitchFamily="34" charset="0"/>
+                <a:ea typeface="Calibri" pitchFamily="34" charset="-122"/>
+                <a:cs typeface="Calibri" pitchFamily="34" charset="-120"/>
+              </a:rPr>
+              <a:t>Ancestry in the results</a:t>
+            </a:r>
+            <a:endParaRPr lang="en-US" sz="2100" dirty="0"/>
+          </a:p>
+        </p:txBody>
+      </p:sp>
+      <p:sp>
+        <p:nvSpPr>
+          <p:cNvPr id="27" name="Text 21"/>
+          <p:cNvSpPr txBox="1"/>
+          <p:nvPr/>
+        </p:nvSpPr>
+        <p:spPr>
+          <a:xfrm>
+            <a:off x="6598768" y="5029200"/>
+            <a:ext cx="4724248" cy="960120"/>
+          </a:xfrm>
+          <a:prstGeom prst="rect">
+            <a:avLst/>
+          </a:prstGeom>
+          <a:noFill/>
+          <a:ln/>
+        </p:spPr>
+        <p:txBody>
+          <a:bodyPr wrap="square" lIns="0" tIns="0" rIns="0" bIns="0" rtlCol="0" anchor="t"/>
+          <a:lstStyle/>
+          <a:p>
+            <a:pPr indent="0" marL="0">
+              <a:buNone/>
+            </a:pPr>
+            <a:r>
+              <a:rPr lang="en-US" sz="1600" dirty="0">
+                <a:solidFill>
+                  <a:srgbClr val="18293B"/>
+                </a:solidFill>
+                <a:latin typeface="Calibri" pitchFamily="34" charset="0"/>
+                <a:ea typeface="Calibri" pitchFamily="34" charset="-122"/>
+                <a:cs typeface="Calibri" pitchFamily="34" charset="-120"/>
+              </a:rPr>
+              <a:t>Mapping results colored by local ancestry (pclai): where the carriers sit in ancestry space, and which haplotypes to examine.</a:t>
+            </a:r>
+            <a:endParaRPr lang="en-US" sz="1600" dirty="0"/>
+          </a:p>
+        </p:txBody>
+      </p:sp>
+      <p:sp>
+        <p:nvSpPr>
+          <p:cNvPr id="28" name="Text 22"/>
+          <p:cNvSpPr txBox="1"/>
+          <p:nvPr/>
+        </p:nvSpPr>
+        <p:spPr>
+          <a:xfrm>
+            <a:off x="548640" y="6172200"/>
             <a:ext cx="11094415" cy="548640"/>
           </a:xfrm>
           <a:prstGeom prst="rect">
@@ -5200,102 +6014,24 @@
           <a:ln/>
         </p:spPr>
         <p:txBody>
-          <a:bodyPr wrap="square" lIns="0" tIns="0" rIns="0" bIns="0" rtlCol="0" anchor="t"/>
+          <a:bodyPr wrap="square" lIns="0" tIns="0" rIns="0" bIns="0" rtlCol="0" anchor="ctr"/>
           <a:lstStyle/>
           <a:p>
             <a:pPr algn="ctr" indent="0" marL="0">
               <a:buNone/>
             </a:pPr>
             <a:r>
-              <a:rPr lang="en-US" sz="2000" b="1" spc="300" kern="0" dirty="0">
-                <a:solidFill>
-                  <a:srgbClr val="FDC700"/>
-                </a:solidFill>
-                <a:latin typeface="Calibri" pitchFamily="34" charset="0"/>
-                <a:ea typeface="Calibri" pitchFamily="34" charset="-122"/>
-                <a:cs typeface="Calibri" pitchFamily="34" charset="-120"/>
-              </a:rPr>
-              <a:t>Next</a:t>
+              <a:rPr lang="en-US" sz="2000" i="1" dirty="0">
+                <a:solidFill>
+                  <a:srgbClr val="003C6C"/>
+                </a:solidFill>
+                <a:latin typeface="Calibri" pitchFamily="34" charset="0"/>
+                <a:ea typeface="Calibri" pitchFamily="34" charset="-122"/>
+                <a:cs typeface="Calibri" pitchFamily="34" charset="-120"/>
+              </a:rPr>
+              <a:t>The pangenome becomes something a browser user works with, not something they know about.</a:t>
             </a:r>
             <a:endParaRPr lang="en-US" sz="2000" dirty="0"/>
-          </a:p>
-        </p:txBody>
-      </p:sp>
-      <p:sp>
-        <p:nvSpPr>
-          <p:cNvPr id="4" name="Text 2"/>
-          <p:cNvSpPr txBox="1"/>
-          <p:nvPr/>
-        </p:nvSpPr>
-        <p:spPr>
-          <a:xfrm>
-            <a:off x="548640" y="2194560"/>
-            <a:ext cx="11094415" cy="914400"/>
-          </a:xfrm>
-          <a:prstGeom prst="rect">
-            <a:avLst/>
-          </a:prstGeom>
-          <a:noFill/>
-          <a:ln/>
-        </p:spPr>
-        <p:txBody>
-          <a:bodyPr wrap="square" lIns="0" tIns="0" rIns="0" bIns="0" rtlCol="0" anchor="ctr"/>
-          <a:lstStyle/>
-          <a:p>
-            <a:pPr algn="ctr" indent="0" marL="0">
-              <a:buNone/>
-            </a:pPr>
-            <a:r>
-              <a:rPr lang="en-US" sz="4000" b="1" dirty="0">
-                <a:solidFill>
-                  <a:srgbClr val="FFFFFF"/>
-                </a:solidFill>
-                <a:latin typeface="Calibri" pitchFamily="34" charset="0"/>
-                <a:ea typeface="Calibri" pitchFamily="34" charset="-122"/>
-                <a:cs typeface="Calibri" pitchFamily="34" charset="-120"/>
-              </a:rPr>
-              <a:t>Public release in the UCSC Genome Browser</a:t>
-            </a:r>
-            <a:endParaRPr lang="en-US" sz="4000" dirty="0"/>
-          </a:p>
-        </p:txBody>
-      </p:sp>
-      <p:sp>
-        <p:nvSpPr>
-          <p:cNvPr id="5" name="Text 3"/>
-          <p:cNvSpPr txBox="1"/>
-          <p:nvPr/>
-        </p:nvSpPr>
-        <p:spPr>
-          <a:xfrm>
-            <a:off x="548640" y="3383280"/>
-            <a:ext cx="11094415" cy="548640"/>
-          </a:xfrm>
-          <a:prstGeom prst="rect">
-            <a:avLst/>
-          </a:prstGeom>
-          <a:noFill/>
-          <a:ln/>
-        </p:spPr>
-        <p:txBody>
-          <a:bodyPr wrap="square" lIns="0" tIns="0" rIns="0" bIns="0" rtlCol="0" anchor="t"/>
-          <a:lstStyle/>
-          <a:p>
-            <a:pPr algn="ctr" indent="0" marL="0">
-              <a:buNone/>
-            </a:pPr>
-            <a:r>
-              <a:rPr lang="en-US" sz="2400" i="1" dirty="0">
-                <a:solidFill>
-                  <a:srgbClr val="C6D3DF"/>
-                </a:solidFill>
-                <a:latin typeface="Calibri" pitchFamily="34" charset="0"/>
-                <a:ea typeface="Calibri" pitchFamily="34" charset="-122"/>
-                <a:cs typeface="Calibri" pitchFamily="34" charset="-120"/>
-              </a:rPr>
-              <a:t>On the development browser now.</a:t>
-            </a:r>
-            <a:endParaRPr lang="en-US" sz="2400" dirty="0"/>
           </a:p>
         </p:txBody>
       </p:sp>

</xml_diff>

<commit_message>
Talk: roadmap as four bullets
</commit_message>
<xml_diff>
--- a/talk/HPRC2026_talk.pptx
+++ b/talk/HPRC2026_talk.pptx
@@ -971,8 +971,7 @@
 - release: both tools in the public browser; development browser today
 - translation already flows from In Other Genomes; it should be invisible everywhere
 - HPRC variant tracks on GRCh38: click a variant, see its release 2 carriers, go there
-- pclai local ancestry: color the carriers; helps pick which haplotypes to look at
-- the point: the pangenome as a thing browser users work with</a:t>
+- pclai local ancestry: color the carriers; helps pick which haplotypes to look at</a:t>
             </a:r>
             <a:endParaRPr lang="en-US" dirty="0"/>
           </a:p>
@@ -5226,90 +5225,14 @@
       </p:sp>
       <p:sp>
         <p:nvSpPr>
-          <p:cNvPr id="4" name="Shape 2"/>
-          <p:cNvSpPr/>
-          <p:nvPr/>
-        </p:nvSpPr>
-        <p:spPr>
-          <a:xfrm>
-            <a:off x="548640" y="1325880"/>
-            <a:ext cx="5364328" cy="2240280"/>
-          </a:xfrm>
-          <a:prstGeom prst="roundRect">
-            <a:avLst>
-              <a:gd name="adj" fmla="val 4898"/>
-            </a:avLst>
-          </a:prstGeom>
-          <a:solidFill>
-            <a:srgbClr val="EDF1F6"/>
-          </a:solidFill>
-          <a:ln w="12700">
-            <a:solidFill>
-              <a:srgbClr val="DCE3EB"/>
-            </a:solidFill>
-            <a:prstDash val="solid"/>
-          </a:ln>
-        </p:spPr>
-      </p:sp>
-      <p:sp>
-        <p:nvSpPr>
-          <p:cNvPr id="5" name="Shape 3"/>
-          <p:cNvSpPr/>
-          <p:nvPr/>
-        </p:nvSpPr>
-        <p:spPr>
-          <a:xfrm>
-            <a:off x="868680" y="1645920"/>
-            <a:ext cx="685800" cy="685800"/>
-          </a:xfrm>
-          <a:prstGeom prst="ellipse">
-            <a:avLst/>
-          </a:prstGeom>
-          <a:solidFill>
-            <a:srgbClr val="003C6C"/>
-          </a:solidFill>
-          <a:ln w="12700">
-            <a:solidFill>
-              <a:srgbClr val="003C6C"/>
-            </a:solidFill>
-            <a:prstDash val="solid"/>
-          </a:ln>
-        </p:spPr>
-      </p:sp>
-      <p:pic>
-        <p:nvPicPr>
-          <p:cNvPr id="6" name="Image 0" descr="preencoded.png">    </p:cNvPr>
-          <p:cNvPicPr>
-            <a:picLocks noChangeAspect="1"/>
-          </p:cNvPicPr>
-          <p:nvPr/>
-        </p:nvPicPr>
-        <p:blipFill>
-          <a:blip r:embed="rId1"/>
-          <a:stretch>
-            <a:fillRect/>
-          </a:stretch>
-        </p:blipFill>
-        <p:spPr>
-          <a:xfrm>
-            <a:off x="1046988" y="1824228"/>
-            <a:ext cx="329184" cy="329184"/>
-          </a:xfrm>
-          <a:prstGeom prst="rect">
-            <a:avLst/>
-          </a:prstGeom>
-        </p:spPr>
-      </p:pic>
-      <p:sp>
-        <p:nvSpPr>
-          <p:cNvPr id="7" name="Text 4"/>
-          <p:cNvSpPr txBox="1"/>
-          <p:nvPr/>
-        </p:nvSpPr>
-        <p:spPr>
-          <a:xfrm>
-            <a:off x="4449928" y="1691640"/>
-            <a:ext cx="1143000" cy="274320"/>
+          <p:cNvPr id="4" name="Text 2"/>
+          <p:cNvSpPr txBox="1"/>
+          <p:nvPr/>
+        </p:nvSpPr>
+        <p:spPr>
+          <a:xfrm>
+            <a:off x="822960" y="1691640"/>
+            <a:ext cx="10545775" cy="4114800"/>
           </a:xfrm>
           <a:prstGeom prst="rect">
             <a:avLst/>
@@ -5321,89 +5244,15 @@
           <a:bodyPr wrap="square" lIns="0" tIns="0" rIns="0" bIns="0" rtlCol="0" anchor="t"/>
           <a:lstStyle/>
           <a:p>
-            <a:pPr algn="r" indent="0" marL="0">
-              <a:buNone/>
-            </a:pPr>
-            <a:r>
-              <a:rPr lang="en-US" sz="1200" b="1" spc="200" kern="0" dirty="0">
-                <a:solidFill>
-                  <a:srgbClr val="003C6C"/>
-                </a:solidFill>
-                <a:latin typeface="Calibri" pitchFamily="34" charset="0"/>
-                <a:ea typeface="Calibri" pitchFamily="34" charset="-122"/>
-                <a:cs typeface="Calibri" pitchFamily="34" charset="-120"/>
-              </a:rPr>
-              <a:t>next</a:t>
-            </a:r>
-            <a:endParaRPr lang="en-US" sz="1200" dirty="0"/>
-          </a:p>
-        </p:txBody>
-      </p:sp>
-      <p:sp>
-        <p:nvSpPr>
-          <p:cNvPr id="8" name="Text 5"/>
-          <p:cNvSpPr txBox="1"/>
-          <p:nvPr/>
-        </p:nvSpPr>
-        <p:spPr>
-          <a:xfrm>
-            <a:off x="1737360" y="1737360"/>
-            <a:ext cx="2621128" cy="548640"/>
-          </a:xfrm>
-          <a:prstGeom prst="rect">
-            <a:avLst/>
-          </a:prstGeom>
-          <a:noFill/>
-          <a:ln/>
-        </p:spPr>
-        <p:txBody>
-          <a:bodyPr wrap="square" lIns="0" tIns="0" rIns="0" bIns="0" rtlCol="0" anchor="ctr"/>
-          <a:lstStyle/>
-          <a:p>
-            <a:pPr indent="0" marL="0">
-              <a:buNone/>
-            </a:pPr>
-            <a:r>
-              <a:rPr lang="en-US" sz="2100" b="1" dirty="0">
-                <a:solidFill>
-                  <a:srgbClr val="003C6C"/>
-                </a:solidFill>
-                <a:latin typeface="Calibri" pitchFamily="34" charset="0"/>
-                <a:ea typeface="Calibri" pitchFamily="34" charset="-122"/>
-                <a:cs typeface="Calibri" pitchFamily="34" charset="-120"/>
-              </a:rPr>
-              <a:t>Public release</a:t>
-            </a:r>
-            <a:endParaRPr lang="en-US" sz="2100" dirty="0"/>
-          </a:p>
-        </p:txBody>
-      </p:sp>
-      <p:sp>
-        <p:nvSpPr>
-          <p:cNvPr id="9" name="Text 6"/>
-          <p:cNvSpPr txBox="1"/>
-          <p:nvPr/>
-        </p:nvSpPr>
-        <p:spPr>
-          <a:xfrm>
-            <a:off x="868680" y="2514600"/>
-            <a:ext cx="4724248" cy="960120"/>
-          </a:xfrm>
-          <a:prstGeom prst="rect">
-            <a:avLst/>
-          </a:prstGeom>
-          <a:noFill/>
-          <a:ln/>
-        </p:spPr>
-        <p:txBody>
-          <a:bodyPr wrap="square" lIns="0" tIns="0" rIns="0" bIns="0" rtlCol="0" anchor="t"/>
-          <a:lstStyle/>
-          <a:p>
-            <a:pPr indent="0" marL="0">
-              <a:buNone/>
-            </a:pPr>
-            <a:r>
-              <a:rPr lang="en-US" sz="1600" dirty="0">
+            <a:pPr marL="203200" indent="-203200">
+              <a:spcAft>
+                <a:spcPts val="2200"/>
+              </a:spcAft>
+              <a:buSzPct val="100000"/>
+              <a:buChar char="•"/>
+            </a:pPr>
+            <a:r>
+              <a:rPr lang="en-US" sz="2400" dirty="0">
                 <a:solidFill>
                   <a:srgbClr val="18293B"/>
                 </a:solidFill>
@@ -5411,192 +5260,20 @@
                 <a:ea typeface="Calibri" pitchFamily="34" charset="-122"/>
                 <a:cs typeface="Calibri" pitchFamily="34" charset="-120"/>
               </a:rPr>
-              <a:t>Both tools in the UCSC Genome Browser. On the development browser now.</a:t>
-            </a:r>
-            <a:endParaRPr lang="en-US" sz="1600" dirty="0"/>
-          </a:p>
-        </p:txBody>
-      </p:sp>
-      <p:sp>
-        <p:nvSpPr>
-          <p:cNvPr id="10" name="Shape 7"/>
-          <p:cNvSpPr/>
-          <p:nvPr/>
-        </p:nvSpPr>
-        <p:spPr>
-          <a:xfrm>
-            <a:off x="6278728" y="1325880"/>
-            <a:ext cx="5364328" cy="2240280"/>
-          </a:xfrm>
-          <a:prstGeom prst="roundRect">
-            <a:avLst>
-              <a:gd name="adj" fmla="val 4898"/>
-            </a:avLst>
-          </a:prstGeom>
-          <a:solidFill>
-            <a:srgbClr val="EDF1F6"/>
-          </a:solidFill>
-          <a:ln w="12700">
-            <a:solidFill>
-              <a:srgbClr val="DCE3EB"/>
-            </a:solidFill>
-            <a:prstDash val="solid"/>
-          </a:ln>
-        </p:spPr>
-      </p:sp>
-      <p:sp>
-        <p:nvSpPr>
-          <p:cNvPr id="11" name="Shape 8"/>
-          <p:cNvSpPr/>
-          <p:nvPr/>
-        </p:nvSpPr>
-        <p:spPr>
-          <a:xfrm>
-            <a:off x="6598768" y="1645920"/>
-            <a:ext cx="685800" cy="685800"/>
-          </a:xfrm>
-          <a:prstGeom prst="ellipse">
-            <a:avLst/>
-          </a:prstGeom>
-          <a:solidFill>
-            <a:srgbClr val="003C6C"/>
-          </a:solidFill>
-          <a:ln w="12700">
-            <a:solidFill>
-              <a:srgbClr val="003C6C"/>
-            </a:solidFill>
-            <a:prstDash val="solid"/>
-          </a:ln>
-        </p:spPr>
-      </p:sp>
-      <p:pic>
-        <p:nvPicPr>
-          <p:cNvPr id="12" name="Image 1" descr="preencoded.png">    </p:cNvPr>
-          <p:cNvPicPr>
-            <a:picLocks noChangeAspect="1"/>
-          </p:cNvPicPr>
-          <p:nvPr/>
-        </p:nvPicPr>
-        <p:blipFill>
-          <a:blip r:embed="rId2"/>
-          <a:stretch>
-            <a:fillRect/>
-          </a:stretch>
-        </p:blipFill>
-        <p:spPr>
-          <a:xfrm>
-            <a:off x="6777076" y="1824228"/>
-            <a:ext cx="329184" cy="329184"/>
-          </a:xfrm>
-          <a:prstGeom prst="rect">
-            <a:avLst/>
-          </a:prstGeom>
-        </p:spPr>
-      </p:pic>
-      <p:sp>
-        <p:nvSpPr>
-          <p:cNvPr id="13" name="Text 9"/>
-          <p:cNvSpPr txBox="1"/>
-          <p:nvPr/>
-        </p:nvSpPr>
-        <p:spPr>
-          <a:xfrm>
-            <a:off x="10180015" y="1691640"/>
-            <a:ext cx="1143000" cy="274320"/>
-          </a:xfrm>
-          <a:prstGeom prst="rect">
-            <a:avLst/>
-          </a:prstGeom>
-          <a:noFill/>
-          <a:ln/>
-        </p:spPr>
-        <p:txBody>
-          <a:bodyPr wrap="square" lIns="0" tIns="0" rIns="0" bIns="0" rtlCol="0" anchor="t"/>
-          <a:lstStyle/>
-          <a:p>
-            <a:pPr algn="r" indent="0" marL="0">
-              <a:buNone/>
-            </a:pPr>
-            <a:r>
-              <a:rPr lang="en-US" sz="1200" b="1" spc="200" kern="0" dirty="0">
-                <a:solidFill>
-                  <a:srgbClr val="003C6C"/>
-                </a:solidFill>
-                <a:latin typeface="Calibri" pitchFamily="34" charset="0"/>
-                <a:ea typeface="Calibri" pitchFamily="34" charset="-122"/>
-                <a:cs typeface="Calibri" pitchFamily="34" charset="-120"/>
-              </a:rPr>
-              <a:t>next</a:t>
-            </a:r>
-            <a:endParaRPr lang="en-US" sz="1200" dirty="0"/>
-          </a:p>
-        </p:txBody>
-      </p:sp>
-      <p:sp>
-        <p:nvSpPr>
-          <p:cNvPr id="14" name="Text 10"/>
-          <p:cNvSpPr txBox="1"/>
-          <p:nvPr/>
-        </p:nvSpPr>
-        <p:spPr>
-          <a:xfrm>
-            <a:off x="7467448" y="1737360"/>
-            <a:ext cx="2621128" cy="548640"/>
-          </a:xfrm>
-          <a:prstGeom prst="rect">
-            <a:avLst/>
-          </a:prstGeom>
-          <a:noFill/>
-          <a:ln/>
-        </p:spPr>
-        <p:txBody>
-          <a:bodyPr wrap="square" lIns="0" tIns="0" rIns="0" bIns="0" rtlCol="0" anchor="ctr"/>
-          <a:lstStyle/>
-          <a:p>
-            <a:pPr indent="0" marL="0">
-              <a:buNone/>
-            </a:pPr>
-            <a:r>
-              <a:rPr lang="en-US" sz="2100" b="1" dirty="0">
-                <a:solidFill>
-                  <a:srgbClr val="003C6C"/>
-                </a:solidFill>
-                <a:latin typeface="Calibri" pitchFamily="34" charset="0"/>
-                <a:ea typeface="Calibri" pitchFamily="34" charset="-122"/>
-                <a:cs typeface="Calibri" pitchFamily="34" charset="-120"/>
-              </a:rPr>
-              <a:t>Translation that just works</a:t>
-            </a:r>
-            <a:endParaRPr lang="en-US" sz="2100" dirty="0"/>
-          </a:p>
-        </p:txBody>
-      </p:sp>
-      <p:sp>
-        <p:nvSpPr>
-          <p:cNvPr id="15" name="Text 11"/>
-          <p:cNvSpPr txBox="1"/>
-          <p:nvPr/>
-        </p:nvSpPr>
-        <p:spPr>
-          <a:xfrm>
-            <a:off x="6598768" y="2514600"/>
-            <a:ext cx="4724248" cy="960120"/>
-          </a:xfrm>
-          <a:prstGeom prst="rect">
-            <a:avLst/>
-          </a:prstGeom>
-          <a:noFill/>
-          <a:ln/>
-        </p:spPr>
-        <p:txBody>
-          <a:bodyPr wrap="square" lIns="0" tIns="0" rIns="0" bIns="0" rtlCol="0" anchor="t"/>
-          <a:lstStyle/>
-          <a:p>
-            <a:pPr indent="0" marL="0">
-              <a:buNone/>
-            </a:pPr>
-            <a:r>
-              <a:rPr lang="en-US" sz="1600" dirty="0">
+              <a:t>Public release in the UCSC Genome Browser</a:t>
+            </a:r>
+            <a:endParaRPr lang="en-US" sz="2400" dirty="0"/>
+          </a:p>
+          <a:p>
+            <a:pPr marL="203200" indent="-203200">
+              <a:spcAft>
+                <a:spcPts val="2200"/>
+              </a:spcAft>
+              <a:buSzPct val="100000"/>
+              <a:buChar char="•"/>
+            </a:pPr>
+            <a:r>
+              <a:rPr lang="en-US" sz="2400" dirty="0">
                 <a:solidFill>
                   <a:srgbClr val="18293B"/>
                 </a:solidFill>
@@ -5604,192 +5281,20 @@
                 <a:ea typeface="Calibri" pitchFamily="34" charset="-122"/>
                 <a:cs typeface="Calibri" pitchFamily="34" charset="-120"/>
               </a:rPr>
-              <a:t>Coordinates and tracks follow you from haplotype to haplotype. No conversion step to think about.</a:t>
-            </a:r>
-            <a:endParaRPr lang="en-US" sz="1600" dirty="0"/>
-          </a:p>
-        </p:txBody>
-      </p:sp>
-      <p:sp>
-        <p:nvSpPr>
-          <p:cNvPr id="16" name="Shape 12"/>
-          <p:cNvSpPr/>
-          <p:nvPr/>
-        </p:nvSpPr>
-        <p:spPr>
-          <a:xfrm>
-            <a:off x="548640" y="3840480"/>
-            <a:ext cx="5364328" cy="2240280"/>
-          </a:xfrm>
-          <a:prstGeom prst="roundRect">
-            <a:avLst>
-              <a:gd name="adj" fmla="val 4898"/>
-            </a:avLst>
-          </a:prstGeom>
-          <a:solidFill>
-            <a:srgbClr val="EDF1F6"/>
-          </a:solidFill>
-          <a:ln w="12700">
-            <a:solidFill>
-              <a:srgbClr val="DCE3EB"/>
-            </a:solidFill>
-            <a:prstDash val="solid"/>
-          </a:ln>
-        </p:spPr>
-      </p:sp>
-      <p:sp>
-        <p:nvSpPr>
-          <p:cNvPr id="17" name="Shape 13"/>
-          <p:cNvSpPr/>
-          <p:nvPr/>
-        </p:nvSpPr>
-        <p:spPr>
-          <a:xfrm>
-            <a:off x="868680" y="4160520"/>
-            <a:ext cx="685800" cy="685800"/>
-          </a:xfrm>
-          <a:prstGeom prst="ellipse">
-            <a:avLst/>
-          </a:prstGeom>
-          <a:solidFill>
-            <a:srgbClr val="0E7C9C"/>
-          </a:solidFill>
-          <a:ln w="12700">
-            <a:solidFill>
-              <a:srgbClr val="0E7C9C"/>
-            </a:solidFill>
-            <a:prstDash val="solid"/>
-          </a:ln>
-        </p:spPr>
-      </p:sp>
-      <p:pic>
-        <p:nvPicPr>
-          <p:cNvPr id="18" name="Image 2" descr="preencoded.png">    </p:cNvPr>
-          <p:cNvPicPr>
-            <a:picLocks noChangeAspect="1"/>
-          </p:cNvPicPr>
-          <p:nvPr/>
-        </p:nvPicPr>
-        <p:blipFill>
-          <a:blip r:embed="rId3"/>
-          <a:stretch>
-            <a:fillRect/>
-          </a:stretch>
-        </p:blipFill>
-        <p:spPr>
-          <a:xfrm>
-            <a:off x="1046988" y="4338828"/>
-            <a:ext cx="329184" cy="329184"/>
-          </a:xfrm>
-          <a:prstGeom prst="rect">
-            <a:avLst/>
-          </a:prstGeom>
-        </p:spPr>
-      </p:pic>
-      <p:sp>
-        <p:nvSpPr>
-          <p:cNvPr id="19" name="Text 14"/>
-          <p:cNvSpPr txBox="1"/>
-          <p:nvPr/>
-        </p:nvSpPr>
-        <p:spPr>
-          <a:xfrm>
-            <a:off x="4449928" y="4206240"/>
-            <a:ext cx="1143000" cy="274320"/>
-          </a:xfrm>
-          <a:prstGeom prst="rect">
-            <a:avLst/>
-          </a:prstGeom>
-          <a:noFill/>
-          <a:ln/>
-        </p:spPr>
-        <p:txBody>
-          <a:bodyPr wrap="square" lIns="0" tIns="0" rIns="0" bIns="0" rtlCol="0" anchor="t"/>
-          <a:lstStyle/>
-          <a:p>
-            <a:pPr algn="r" indent="0" marL="0">
-              <a:buNone/>
-            </a:pPr>
-            <a:r>
-              <a:rPr lang="en-US" sz="1200" b="1" spc="200" kern="0" dirty="0">
-                <a:solidFill>
-                  <a:srgbClr val="0E7C9C"/>
-                </a:solidFill>
-                <a:latin typeface="Calibri" pitchFamily="34" charset="0"/>
-                <a:ea typeface="Calibri" pitchFamily="34" charset="-122"/>
-                <a:cs typeface="Calibri" pitchFamily="34" charset="-120"/>
-              </a:rPr>
-              <a:t>planned</a:t>
-            </a:r>
-            <a:endParaRPr lang="en-US" sz="1200" dirty="0"/>
-          </a:p>
-        </p:txBody>
-      </p:sp>
-      <p:sp>
-        <p:nvSpPr>
-          <p:cNvPr id="20" name="Text 15"/>
-          <p:cNvSpPr txBox="1"/>
-          <p:nvPr/>
-        </p:nvSpPr>
-        <p:spPr>
-          <a:xfrm>
-            <a:off x="1737360" y="4251960"/>
-            <a:ext cx="2621128" cy="548640"/>
-          </a:xfrm>
-          <a:prstGeom prst="rect">
-            <a:avLst/>
-          </a:prstGeom>
-          <a:noFill/>
-          <a:ln/>
-        </p:spPr>
-        <p:txBody>
-          <a:bodyPr wrap="square" lIns="0" tIns="0" rIns="0" bIns="0" rtlCol="0" anchor="ctr"/>
-          <a:lstStyle/>
-          <a:p>
-            <a:pPr indent="0" marL="0">
-              <a:buNone/>
-            </a:pPr>
-            <a:r>
-              <a:rPr lang="en-US" sz="2100" b="1" dirty="0">
-                <a:solidFill>
-                  <a:srgbClr val="003C6C"/>
-                </a:solidFill>
-                <a:latin typeface="Calibri" pitchFamily="34" charset="0"/>
-                <a:ea typeface="Calibri" pitchFamily="34" charset="-122"/>
-                <a:cs typeface="Calibri" pitchFamily="34" charset="-120"/>
-              </a:rPr>
-              <a:t>From a variant to its haplotypes</a:t>
-            </a:r>
-            <a:endParaRPr lang="en-US" sz="2100" dirty="0"/>
-          </a:p>
-        </p:txBody>
-      </p:sp>
-      <p:sp>
-        <p:nvSpPr>
-          <p:cNvPr id="21" name="Text 16"/>
-          <p:cNvSpPr txBox="1"/>
-          <p:nvPr/>
-        </p:nvSpPr>
-        <p:spPr>
-          <a:xfrm>
-            <a:off x="868680" y="5029200"/>
-            <a:ext cx="4724248" cy="960120"/>
-          </a:xfrm>
-          <a:prstGeom prst="rect">
-            <a:avLst/>
-          </a:prstGeom>
-          <a:noFill/>
-          <a:ln/>
-        </p:spPr>
-        <p:txBody>
-          <a:bodyPr wrap="square" lIns="0" tIns="0" rIns="0" bIns="0" rtlCol="0" anchor="t"/>
-          <a:lstStyle/>
-          <a:p>
-            <a:pPr indent="0" marL="0">
-              <a:buNone/>
-            </a:pPr>
-            <a:r>
-              <a:rPr lang="en-US" sz="1600" dirty="0">
+              <a:t>Translation that just works: tracks follow you across haplotypes, no conversion step</a:t>
+            </a:r>
+            <a:endParaRPr lang="en-US" sz="2400" dirty="0"/>
+          </a:p>
+          <a:p>
+            <a:pPr marL="203200" indent="-203200">
+              <a:spcAft>
+                <a:spcPts val="2200"/>
+              </a:spcAft>
+              <a:buSzPct val="100000"/>
+              <a:buChar char="•"/>
+            </a:pPr>
+            <a:r>
+              <a:rPr lang="en-US" sz="2400" dirty="0">
                 <a:solidFill>
                   <a:srgbClr val="18293B"/>
                 </a:solidFill>
@@ -5797,192 +5302,20 @@
                 <a:ea typeface="Calibri" pitchFamily="34" charset="-122"/>
                 <a:cs typeface="Calibri" pitchFamily="34" charset="-120"/>
               </a:rPr>
-              <a:t>Click an HPRC variant on GRCh38, see which release 2 haplotypes carry it, and jump to the sequence there.</a:t>
-            </a:r>
-            <a:endParaRPr lang="en-US" sz="1600" dirty="0"/>
-          </a:p>
-        </p:txBody>
-      </p:sp>
-      <p:sp>
-        <p:nvSpPr>
-          <p:cNvPr id="22" name="Shape 17"/>
-          <p:cNvSpPr/>
-          <p:nvPr/>
-        </p:nvSpPr>
-        <p:spPr>
-          <a:xfrm>
-            <a:off x="6278728" y="3840480"/>
-            <a:ext cx="5364328" cy="2240280"/>
-          </a:xfrm>
-          <a:prstGeom prst="roundRect">
-            <a:avLst>
-              <a:gd name="adj" fmla="val 4898"/>
-            </a:avLst>
-          </a:prstGeom>
-          <a:solidFill>
-            <a:srgbClr val="EDF1F6"/>
-          </a:solidFill>
-          <a:ln w="12700">
-            <a:solidFill>
-              <a:srgbClr val="DCE3EB"/>
-            </a:solidFill>
-            <a:prstDash val="solid"/>
-          </a:ln>
-        </p:spPr>
-      </p:sp>
-      <p:sp>
-        <p:nvSpPr>
-          <p:cNvPr id="23" name="Shape 18"/>
-          <p:cNvSpPr/>
-          <p:nvPr/>
-        </p:nvSpPr>
-        <p:spPr>
-          <a:xfrm>
-            <a:off x="6598768" y="4160520"/>
-            <a:ext cx="685800" cy="685800"/>
-          </a:xfrm>
-          <a:prstGeom prst="ellipse">
-            <a:avLst/>
-          </a:prstGeom>
-          <a:solidFill>
-            <a:srgbClr val="0E7C9C"/>
-          </a:solidFill>
-          <a:ln w="12700">
-            <a:solidFill>
-              <a:srgbClr val="0E7C9C"/>
-            </a:solidFill>
-            <a:prstDash val="solid"/>
-          </a:ln>
-        </p:spPr>
-      </p:sp>
-      <p:pic>
-        <p:nvPicPr>
-          <p:cNvPr id="24" name="Image 3" descr="preencoded.png">    </p:cNvPr>
-          <p:cNvPicPr>
-            <a:picLocks noChangeAspect="1"/>
-          </p:cNvPicPr>
-          <p:nvPr/>
-        </p:nvPicPr>
-        <p:blipFill>
-          <a:blip r:embed="rId4"/>
-          <a:stretch>
-            <a:fillRect/>
-          </a:stretch>
-        </p:blipFill>
-        <p:spPr>
-          <a:xfrm>
-            <a:off x="6777076" y="4338828"/>
-            <a:ext cx="329184" cy="329184"/>
-          </a:xfrm>
-          <a:prstGeom prst="rect">
-            <a:avLst/>
-          </a:prstGeom>
-        </p:spPr>
-      </p:pic>
-      <p:sp>
-        <p:nvSpPr>
-          <p:cNvPr id="25" name="Text 19"/>
-          <p:cNvSpPr txBox="1"/>
-          <p:nvPr/>
-        </p:nvSpPr>
-        <p:spPr>
-          <a:xfrm>
-            <a:off x="10180015" y="4206240"/>
-            <a:ext cx="1143000" cy="274320"/>
-          </a:xfrm>
-          <a:prstGeom prst="rect">
-            <a:avLst/>
-          </a:prstGeom>
-          <a:noFill/>
-          <a:ln/>
-        </p:spPr>
-        <p:txBody>
-          <a:bodyPr wrap="square" lIns="0" tIns="0" rIns="0" bIns="0" rtlCol="0" anchor="t"/>
-          <a:lstStyle/>
-          <a:p>
-            <a:pPr algn="r" indent="0" marL="0">
-              <a:buNone/>
-            </a:pPr>
-            <a:r>
-              <a:rPr lang="en-US" sz="1200" b="1" spc="200" kern="0" dirty="0">
-                <a:solidFill>
-                  <a:srgbClr val="0E7C9C"/>
-                </a:solidFill>
-                <a:latin typeface="Calibri" pitchFamily="34" charset="0"/>
-                <a:ea typeface="Calibri" pitchFamily="34" charset="-122"/>
-                <a:cs typeface="Calibri" pitchFamily="34" charset="-120"/>
-              </a:rPr>
-              <a:t>planned</a:t>
-            </a:r>
-            <a:endParaRPr lang="en-US" sz="1200" dirty="0"/>
-          </a:p>
-        </p:txBody>
-      </p:sp>
-      <p:sp>
-        <p:nvSpPr>
-          <p:cNvPr id="26" name="Text 20"/>
-          <p:cNvSpPr txBox="1"/>
-          <p:nvPr/>
-        </p:nvSpPr>
-        <p:spPr>
-          <a:xfrm>
-            <a:off x="7467448" y="4251960"/>
-            <a:ext cx="2621128" cy="548640"/>
-          </a:xfrm>
-          <a:prstGeom prst="rect">
-            <a:avLst/>
-          </a:prstGeom>
-          <a:noFill/>
-          <a:ln/>
-        </p:spPr>
-        <p:txBody>
-          <a:bodyPr wrap="square" lIns="0" tIns="0" rIns="0" bIns="0" rtlCol="0" anchor="ctr"/>
-          <a:lstStyle/>
-          <a:p>
-            <a:pPr indent="0" marL="0">
-              <a:buNone/>
-            </a:pPr>
-            <a:r>
-              <a:rPr lang="en-US" sz="2100" b="1" dirty="0">
-                <a:solidFill>
-                  <a:srgbClr val="003C6C"/>
-                </a:solidFill>
-                <a:latin typeface="Calibri" pitchFamily="34" charset="0"/>
-                <a:ea typeface="Calibri" pitchFamily="34" charset="-122"/>
-                <a:cs typeface="Calibri" pitchFamily="34" charset="-120"/>
-              </a:rPr>
-              <a:t>Ancestry in the results</a:t>
-            </a:r>
-            <a:endParaRPr lang="en-US" sz="2100" dirty="0"/>
-          </a:p>
-        </p:txBody>
-      </p:sp>
-      <p:sp>
-        <p:nvSpPr>
-          <p:cNvPr id="27" name="Text 21"/>
-          <p:cNvSpPr txBox="1"/>
-          <p:nvPr/>
-        </p:nvSpPr>
-        <p:spPr>
-          <a:xfrm>
-            <a:off x="6598768" y="5029200"/>
-            <a:ext cx="4724248" cy="960120"/>
-          </a:xfrm>
-          <a:prstGeom prst="rect">
-            <a:avLst/>
-          </a:prstGeom>
-          <a:noFill/>
-          <a:ln/>
-        </p:spPr>
-        <p:txBody>
-          <a:bodyPr wrap="square" lIns="0" tIns="0" rIns="0" bIns="0" rtlCol="0" anchor="t"/>
-          <a:lstStyle/>
-          <a:p>
-            <a:pPr indent="0" marL="0">
-              <a:buNone/>
-            </a:pPr>
-            <a:r>
-              <a:rPr lang="en-US" sz="1600" dirty="0">
+              <a:t>Click an HPRC variant on GRCh38, see which release 2 haplotypes carry it, go there</a:t>
+            </a:r>
+            <a:endParaRPr lang="en-US" sz="2400" dirty="0"/>
+          </a:p>
+          <a:p>
+            <a:pPr marL="203200" indent="-203200">
+              <a:spcAft>
+                <a:spcPts val="2200"/>
+              </a:spcAft>
+              <a:buSzPct val="100000"/>
+              <a:buChar char="•"/>
+            </a:pPr>
+            <a:r>
+              <a:rPr lang="en-US" sz="2400" dirty="0">
                 <a:solidFill>
                   <a:srgbClr val="18293B"/>
                 </a:solidFill>
@@ -5990,48 +5323,9 @@
                 <a:ea typeface="Calibri" pitchFamily="34" charset="-122"/>
                 <a:cs typeface="Calibri" pitchFamily="34" charset="-120"/>
               </a:rPr>
-              <a:t>Mapping results colored by local ancestry (pclai): where the carriers sit in ancestry space, and which haplotypes to examine.</a:t>
-            </a:r>
-            <a:endParaRPr lang="en-US" sz="1600" dirty="0"/>
-          </a:p>
-        </p:txBody>
-      </p:sp>
-      <p:sp>
-        <p:nvSpPr>
-          <p:cNvPr id="28" name="Text 22"/>
-          <p:cNvSpPr txBox="1"/>
-          <p:nvPr/>
-        </p:nvSpPr>
-        <p:spPr>
-          <a:xfrm>
-            <a:off x="548640" y="6172200"/>
-            <a:ext cx="11094415" cy="548640"/>
-          </a:xfrm>
-          <a:prstGeom prst="rect">
-            <a:avLst/>
-          </a:prstGeom>
-          <a:noFill/>
-          <a:ln/>
-        </p:spPr>
-        <p:txBody>
-          <a:bodyPr wrap="square" lIns="0" tIns="0" rIns="0" bIns="0" rtlCol="0" anchor="ctr"/>
-          <a:lstStyle/>
-          <a:p>
-            <a:pPr algn="ctr" indent="0" marL="0">
-              <a:buNone/>
-            </a:pPr>
-            <a:r>
-              <a:rPr lang="en-US" sz="2000" i="1" dirty="0">
-                <a:solidFill>
-                  <a:srgbClr val="003C6C"/>
-                </a:solidFill>
-                <a:latin typeface="Calibri" pitchFamily="34" charset="0"/>
-                <a:ea typeface="Calibri" pitchFamily="34" charset="-122"/>
-                <a:cs typeface="Calibri" pitchFamily="34" charset="-120"/>
-              </a:rPr>
-              <a:t>The pangenome becomes something a browser user works with, not something they know about.</a:t>
-            </a:r>
-            <a:endParaRPr lang="en-US" sz="2000" dirty="0"/>
+              <a:t>Mapping results colored by local ancestry (pclai)</a:t>
+            </a:r>
+            <a:endParaRPr lang="en-US" sz="2400" dirty="0"/>
           </a:p>
         </p:txBody>
       </p:sp>

</xml_diff>